<commit_message>
fix: satisfy Phase 2 review blockers
</commit_message>
<xml_diff>
--- a/thesis-deck-system/artifacts/phase2/acceptance-deck-render-compat.pptx
+++ b/thesis-deck-system/artifacts/phase2/acceptance-deck-render-compat.pptx
@@ -536,7 +536,7 @@
           </a:p>
           <a:p>
             <a:r>
-              <a:t>Synthetic Phase 2 fixture; source refs are ledger-derived.</a:t>
+              <a:t>Compiled from persisted ledger materialization.</a:t>
             </a:r>
           </a:p>
         </p:txBody>
@@ -611,6 +611,11 @@
           </a:p>
           <a:p>
             <a:r>
+              <a:t>E002</a:t>
+            </a:r>
+          </a:p>
+          <a:p>
+            <a:r>
               <a:t>E101</a:t>
             </a:r>
           </a:p>
@@ -621,12 +626,17 @@
           </a:p>
           <a:p>
             <a:r>
+              <a:t>E103</a:t>
+            </a:r>
+          </a:p>
+          <a:p>
+            <a:r>
               <a:t>[/Sources]</a:t>
             </a:r>
           </a:p>
           <a:p>
             <a:r>
-              <a:t>Synthetic Phase 2 fixture; source refs are ledger-derived.</a:t>
+              <a:t>Compiled from persisted ledger materialization.</a:t>
             </a:r>
           </a:p>
         </p:txBody>
@@ -701,6 +711,11 @@
           </a:p>
           <a:p>
             <a:r>
+              <a:t>E002</a:t>
+            </a:r>
+          </a:p>
+          <a:p>
+            <a:r>
               <a:t>E101</a:t>
             </a:r>
           </a:p>
@@ -711,12 +726,17 @@
           </a:p>
           <a:p>
             <a:r>
+              <a:t>E103</a:t>
+            </a:r>
+          </a:p>
+          <a:p>
+            <a:r>
               <a:t>[/Sources]</a:t>
             </a:r>
           </a:p>
           <a:p>
             <a:r>
-              <a:t>Synthetic Phase 2 fixture; source refs are ledger-derived.</a:t>
+              <a:t>Compiled from persisted ledger materialization.</a:t>
             </a:r>
           </a:p>
         </p:txBody>
@@ -791,6 +811,11 @@
           </a:p>
           <a:p>
             <a:r>
+              <a:t>E002</a:t>
+            </a:r>
+          </a:p>
+          <a:p>
+            <a:r>
               <a:t>E101</a:t>
             </a:r>
           </a:p>
@@ -801,12 +826,17 @@
           </a:p>
           <a:p>
             <a:r>
+              <a:t>E103</a:t>
+            </a:r>
+          </a:p>
+          <a:p>
+            <a:r>
               <a:t>[/Sources]</a:t>
             </a:r>
           </a:p>
           <a:p>
             <a:r>
-              <a:t>Synthetic Phase 2 fixture; source refs are ledger-derived.</a:t>
+              <a:t>Compiled from persisted ledger materialization.</a:t>
             </a:r>
           </a:p>
         </p:txBody>
@@ -891,7 +921,7 @@
           </a:p>
           <a:p>
             <a:r>
-              <a:t>Synthetic Phase 2 fixture; source refs are ledger-derived.</a:t>
+              <a:t>Compiled from persisted ledger materialization.</a:t>
             </a:r>
           </a:p>
         </p:txBody>
@@ -976,7 +1006,7 @@
           </a:p>
           <a:p>
             <a:r>
-              <a:t>Synthetic Phase 2 fixture; source refs are ledger-derived.</a:t>
+              <a:t>Compiled from persisted ledger materialization.</a:t>
             </a:r>
           </a:p>
         </p:txBody>
@@ -1061,7 +1091,7 @@
           </a:p>
           <a:p>
             <a:r>
-              <a:t>Synthetic Phase 2 fixture; source refs are ledger-derived.</a:t>
+              <a:t>Compiled from persisted ledger materialization.</a:t>
             </a:r>
           </a:p>
         </p:txBody>
@@ -1146,7 +1176,7 @@
           </a:p>
           <a:p>
             <a:r>
-              <a:t>Synthetic Phase 2 fixture; source refs are ledger-derived.</a:t>
+              <a:t>Compiled from persisted ledger materialization.</a:t>
             </a:r>
           </a:p>
         </p:txBody>
@@ -1231,7 +1261,7 @@
           </a:p>
           <a:p>
             <a:r>
-              <a:t>Synthetic Phase 2 fixture; source refs are ledger-derived.</a:t>
+              <a:t>Compiled from persisted ledger materialization.</a:t>
             </a:r>
           </a:p>
         </p:txBody>
@@ -1316,7 +1346,7 @@
           </a:p>
           <a:p>
             <a:r>
-              <a:t>Synthetic Phase 2 fixture; source refs are ledger-derived.</a:t>
+              <a:t>Compiled from persisted ledger materialization.</a:t>
             </a:r>
           </a:p>
         </p:txBody>
@@ -1391,6 +1421,11 @@
           </a:p>
           <a:p>
             <a:r>
+              <a:t>E002</a:t>
+            </a:r>
+          </a:p>
+          <a:p>
+            <a:r>
               <a:t>E101</a:t>
             </a:r>
           </a:p>
@@ -1401,12 +1436,17 @@
           </a:p>
           <a:p>
             <a:r>
+              <a:t>E103</a:t>
+            </a:r>
+          </a:p>
+          <a:p>
+            <a:r>
               <a:t>[/Sources]</a:t>
             </a:r>
           </a:p>
           <a:p>
             <a:r>
-              <a:t>Synthetic Phase 2 fixture; source refs are ledger-derived.</a:t>
+              <a:t>Compiled from persisted ledger materialization.</a:t>
             </a:r>
           </a:p>
         </p:txBody>
@@ -1481,6 +1521,11 @@
           </a:p>
           <a:p>
             <a:r>
+              <a:t>E002</a:t>
+            </a:r>
+          </a:p>
+          <a:p>
+            <a:r>
               <a:t>E101</a:t>
             </a:r>
           </a:p>
@@ -1491,12 +1536,17 @@
           </a:p>
           <a:p>
             <a:r>
+              <a:t>E103</a:t>
+            </a:r>
+          </a:p>
+          <a:p>
+            <a:r>
               <a:t>[/Sources]</a:t>
             </a:r>
           </a:p>
           <a:p>
             <a:r>
-              <a:t>Synthetic Phase 2 fixture; source refs are ledger-derived.</a:t>
+              <a:t>Compiled from persisted ledger materialization.</a:t>
             </a:r>
           </a:p>
         </p:txBody>
@@ -1571,6 +1621,11 @@
           </a:p>
           <a:p>
             <a:r>
+              <a:t>E002</a:t>
+            </a:r>
+          </a:p>
+          <a:p>
+            <a:r>
               <a:t>E101</a:t>
             </a:r>
           </a:p>
@@ -1581,12 +1636,17 @@
           </a:p>
           <a:p>
             <a:r>
+              <a:t>E103</a:t>
+            </a:r>
+          </a:p>
+          <a:p>
+            <a:r>
               <a:t>[/Sources]</a:t>
             </a:r>
           </a:p>
           <a:p>
             <a:r>
-              <a:t>Synthetic Phase 2 fixture; source refs are ledger-derived.</a:t>
+              <a:t>Compiled from persisted ledger materialization.</a:t>
             </a:r>
           </a:p>
         </p:txBody>
@@ -1661,6 +1721,11 @@
           </a:p>
           <a:p>
             <a:r>
+              <a:t>E002</a:t>
+            </a:r>
+          </a:p>
+          <a:p>
+            <a:r>
               <a:t>E101</a:t>
             </a:r>
           </a:p>
@@ -1671,12 +1736,17 @@
           </a:p>
           <a:p>
             <a:r>
+              <a:t>E103</a:t>
+            </a:r>
+          </a:p>
+          <a:p>
+            <a:r>
               <a:t>[/Sources]</a:t>
             </a:r>
           </a:p>
           <a:p>
             <a:r>
-              <a:t>Synthetic Phase 2 fixture; source refs are ledger-derived.</a:t>
+              <a:t>Compiled from persisted ledger materialization.</a:t>
             </a:r>
           </a:p>
         </p:txBody>
@@ -1751,6 +1821,11 @@
           </a:p>
           <a:p>
             <a:r>
+              <a:t>E002</a:t>
+            </a:r>
+          </a:p>
+          <a:p>
+            <a:r>
               <a:t>E101</a:t>
             </a:r>
           </a:p>
@@ -1761,12 +1836,17 @@
           </a:p>
           <a:p>
             <a:r>
+              <a:t>E103</a:t>
+            </a:r>
+          </a:p>
+          <a:p>
+            <a:r>
               <a:t>[/Sources]</a:t>
             </a:r>
           </a:p>
           <a:p>
             <a:r>
-              <a:t>Synthetic Phase 2 fixture; source refs are ledger-derived.</a:t>
+              <a:t>Compiled from persisted ledger materialization.</a:t>
             </a:r>
           </a:p>
         </p:txBody>
@@ -1841,6 +1921,11 @@
           </a:p>
           <a:p>
             <a:r>
+              <a:t>E002</a:t>
+            </a:r>
+          </a:p>
+          <a:p>
+            <a:r>
               <a:t>E101</a:t>
             </a:r>
           </a:p>
@@ -1851,12 +1936,17 @@
           </a:p>
           <a:p>
             <a:r>
+              <a:t>E103</a:t>
+            </a:r>
+          </a:p>
+          <a:p>
+            <a:r>
               <a:t>[/Sources]</a:t>
             </a:r>
           </a:p>
           <a:p>
             <a:r>
-              <a:t>Synthetic Phase 2 fixture; source refs are ledger-derived.</a:t>
+              <a:t>Compiled from persisted ledger materialization.</a:t>
             </a:r>
           </a:p>
         </p:txBody>
@@ -1931,6 +2021,11 @@
           </a:p>
           <a:p>
             <a:r>
+              <a:t>E002</a:t>
+            </a:r>
+          </a:p>
+          <a:p>
+            <a:r>
               <a:t>E101</a:t>
             </a:r>
           </a:p>
@@ -1941,12 +2036,17 @@
           </a:p>
           <a:p>
             <a:r>
+              <a:t>E103</a:t>
+            </a:r>
+          </a:p>
+          <a:p>
+            <a:r>
               <a:t>[/Sources]</a:t>
             </a:r>
           </a:p>
           <a:p>
             <a:r>
-              <a:t>Synthetic Phase 2 fixture; source refs are ledger-derived.</a:t>
+              <a:t>Compiled from persisted ledger materialization.</a:t>
             </a:r>
           </a:p>
         </p:txBody>
@@ -2021,6 +2121,11 @@
           </a:p>
           <a:p>
             <a:r>
+              <a:t>E002</a:t>
+            </a:r>
+          </a:p>
+          <a:p>
+            <a:r>
               <a:t>E101</a:t>
             </a:r>
           </a:p>
@@ -2031,12 +2136,17 @@
           </a:p>
           <a:p>
             <a:r>
+              <a:t>E103</a:t>
+            </a:r>
+          </a:p>
+          <a:p>
+            <a:r>
               <a:t>[/Sources]</a:t>
             </a:r>
           </a:p>
           <a:p>
             <a:r>
-              <a:t>Synthetic Phase 2 fixture; source refs are ledger-derived.</a:t>
+              <a:t>Compiled from persisted ledger materialization.</a:t>
             </a:r>
           </a:p>
         </p:txBody>
@@ -5148,8 +5258,8 @@
         </p:nvSpPr>
         <p:spPr>
           <a:xfrm>
-            <a:off x="640080" y="1417320"/>
-            <a:ext cx="4572000" cy="4480560"/>
+            <a:off x="731520" y="1325880"/>
+            <a:ext cx="5257800" cy="3840480"/>
           </a:xfrm>
           <a:prstGeom prst="rect">
             <a:avLst/>
@@ -5185,8 +5295,8 @@
         </p:blipFill>
         <p:spPr>
           <a:xfrm>
-            <a:off x="5212080" y="1417320"/>
-            <a:ext cx="6217920" cy="4114800"/>
+            <a:off x="6217920" y="1325880"/>
+            <a:ext cx="5257800" cy="3840480"/>
           </a:xfrm>
           <a:prstGeom prst="rect">
             <a:avLst/>
@@ -5257,8 +5367,8 @@
         </p:nvSpPr>
         <p:spPr>
           <a:xfrm>
-            <a:off x="640080" y="1417320"/>
-            <a:ext cx="4572000" cy="4480560"/>
+            <a:off x="731520" y="1325880"/>
+            <a:ext cx="5257800" cy="3840480"/>
           </a:xfrm>
           <a:prstGeom prst="rect">
             <a:avLst/>
@@ -5294,8 +5404,8 @@
         </p:blipFill>
         <p:spPr>
           <a:xfrm>
-            <a:off x="5212080" y="1417320"/>
-            <a:ext cx="6217920" cy="4114800"/>
+            <a:off x="6217920" y="1325880"/>
+            <a:ext cx="5257800" cy="3840480"/>
           </a:xfrm>
           <a:prstGeom prst="rect">
             <a:avLst/>
@@ -5366,8 +5476,8 @@
         </p:nvSpPr>
         <p:spPr>
           <a:xfrm>
-            <a:off x="640080" y="1417320"/>
-            <a:ext cx="4572000" cy="4480560"/>
+            <a:off x="731520" y="3566160"/>
+            <a:ext cx="10744200" cy="1554480"/>
           </a:xfrm>
           <a:prstGeom prst="rect">
             <a:avLst/>
@@ -5481,8 +5591,8 @@
         </p:nvSpPr>
         <p:spPr>
           <a:xfrm>
-            <a:off x="640080" y="1417320"/>
-            <a:ext cx="4572000" cy="4480560"/>
+            <a:off x="731520" y="1280160"/>
+            <a:ext cx="3383280" cy="2103120"/>
           </a:xfrm>
           <a:prstGeom prst="rect">
             <a:avLst/>
@@ -5503,19 +5613,13 @@
           <a:p>
             <a:r>
               <a:rPr sz="1800"/>
-              <a:t>Evidence｜E101, RES101, RES102</a:t>
-            </a:r>
-          </a:p>
-          <a:p>
-            <a:r>
-              <a:rPr sz="1800"/>
               <a:t>Hypothesis status｜partial_support</a:t>
             </a:r>
           </a:p>
           <a:p>
             <a:r>
               <a:rPr sz="1800"/>
-              <a:t>Decision｜D101</a:t>
+              <a:t>Decision｜Partial-Go: Bulk conductivity is contributory but insufficient.</a:t>
             </a:r>
           </a:p>
           <a:p>
@@ -5533,7 +5637,7 @@
           <a:p>
             <a:r>
               <a:rPr sz="1800"/>
-              <a:t>Next Step｜NS101｜Owner: Gary｜Timing committed</a:t>
+              <a:t>Next Step｜NS101</a:t>
             </a:r>
           </a:p>
         </p:txBody>
@@ -5602,8 +5706,8 @@
         </p:nvSpPr>
         <p:spPr>
           <a:xfrm>
-            <a:off x="640080" y="1417320"/>
-            <a:ext cx="4572000" cy="4480560"/>
+            <a:off x="731520" y="1417320"/>
+            <a:ext cx="10744200" cy="2468880"/>
           </a:xfrm>
           <a:prstGeom prst="rect">
             <a:avLst/>
@@ -5717,8 +5821,8 @@
         </p:nvSpPr>
         <p:spPr>
           <a:xfrm>
-            <a:off x="640080" y="1417320"/>
-            <a:ext cx="4572000" cy="4480560"/>
+            <a:off x="731520" y="1508760"/>
+            <a:ext cx="10698480" cy="2148840"/>
           </a:xfrm>
           <a:prstGeom prst="rect">
             <a:avLst/>
@@ -5733,13 +5837,19 @@
           <a:p>
             <a:r>
               <a:rPr sz="1800"/>
-              <a:t>目前相信｜低接觸壓力下，Contact resistance 主導訊號不穩定。</a:t>
-            </a:r>
-          </a:p>
-          <a:p>
-            <a:r>
-              <a:rPr sz="1800"/>
-              <a:t>Falsifier｜匹配導電度後，改變接觸壓力不影響 CV。</a:t>
+              <a:t>Hypothesis｜Contact resistance drives instability at low pressure.</a:t>
+            </a:r>
+          </a:p>
+          <a:p>
+            <a:r>
+              <a:rPr sz="1800"/>
+              <a:t>Falsifier｜Matched conditions do not change the predicted CV or resistance.</a:t>
+            </a:r>
+          </a:p>
+          <a:p>
+            <a:r>
+              <a:rPr sz="1800"/>
+              <a:t>Research question｜低接觸壓力下，contact resistance 是否主導訊號不穩定？</a:t>
             </a:r>
           </a:p>
         </p:txBody>
@@ -5808,8 +5918,8 @@
         </p:nvSpPr>
         <p:spPr>
           <a:xfrm>
-            <a:off x="640080" y="1417320"/>
-            <a:ext cx="4572000" cy="4480560"/>
+            <a:off x="8046720" y="1325880"/>
+            <a:ext cx="3383280" cy="1600200"/>
           </a:xfrm>
           <a:prstGeom prst="rect">
             <a:avLst/>
@@ -5824,7 +5934,7 @@
           <a:p>
             <a:r>
               <a:rPr sz="1800"/>
-              <a:t>Unresolved problem｜導電度改善後重複性仍未改善，剩餘變異與電極接觸位置相關。</a:t>
+              <a:t>Problem｜導電度改善後重複性仍未改善，剩餘變異與電極接觸位置相關。</a:t>
             </a:r>
           </a:p>
           <a:p>
@@ -5848,7 +5958,7 @@
           <a:p>
             <a:r>
               <a:rPr sz="1800"/>
-              <a:t>Remaining uncertainty｜匹配 bulk conductivity，改變 contact pressure 的對照實驗。</a:t>
+              <a:t>Scope｜匹配 bulk conductivity，改變 contact pressure 的對照實驗。</a:t>
             </a:r>
           </a:p>
         </p:txBody>
@@ -5917,8 +6027,8 @@
         </p:nvSpPr>
         <p:spPr>
           <a:xfrm>
-            <a:off x="640080" y="1417320"/>
-            <a:ext cx="4572000" cy="4480560"/>
+            <a:off x="731520" y="1508760"/>
+            <a:ext cx="2743200" cy="1280160"/>
           </a:xfrm>
           <a:prstGeom prst="rect">
             <a:avLst/>
@@ -5945,7 +6055,7 @@
           <a:p>
             <a:r>
               <a:rPr sz="1800"/>
-              <a:t>Old layer topology is immutable; current overview uses latest revision.</a:t>
+              <a:t>Immutable map; current branch highlighted.</a:t>
             </a:r>
           </a:p>
         </p:txBody>
@@ -5966,8 +6076,8 @@
         </p:blipFill>
         <p:spPr>
           <a:xfrm>
-            <a:off x="5212080" y="1417320"/>
-            <a:ext cx="6217920" cy="4114800"/>
+            <a:off x="3886200" y="1234440"/>
+            <a:ext cx="7635240" cy="4480560"/>
           </a:xfrm>
           <a:prstGeom prst="rect">
             <a:avLst/>
@@ -6038,8 +6148,8 @@
         </p:nvSpPr>
         <p:spPr>
           <a:xfrm>
-            <a:off x="640080" y="1417320"/>
-            <a:ext cx="4572000" cy="4480560"/>
+            <a:off x="731520" y="2331720"/>
+            <a:ext cx="5669280" cy="2423160"/>
           </a:xfrm>
           <a:prstGeom prst="rect">
             <a:avLst/>
@@ -6054,25 +6164,55 @@
           <a:p>
             <a:r>
               <a:rPr sz="1800"/>
-              <a:t>Observation｜H01 提升 conductivity，但 CV 未改善。</a:t>
-            </a:r>
-          </a:p>
-          <a:p>
-            <a:r>
-              <a:rPr sz="1800"/>
-              <a:t>Literature synthesis｜bulk transport 與 interface contact 可產生不同可辨識預測。</a:t>
-            </a:r>
-          </a:p>
-          <a:p>
-            <a:r>
-              <a:rPr sz="1800"/>
-              <a:t>Mechanism｜低壓造成 contact resistance 波動。</a:t>
-            </a:r>
-          </a:p>
-          <a:p>
-            <a:r>
-              <a:rPr sz="1800"/>
-              <a:t>Strategy｜匹配 bulk conductivity，僅改變 contact pressure。</a:t>
+              <a:t>Observation｜位置依賴缺陷與訊號變異已觀察到。</a:t>
+            </a:r>
+          </a:p>
+          <a:p>
+            <a:r>
+              <a:rPr sz="1800"/>
+              <a:t>Problem｜現有模型無法解釋此變異。</a:t>
+            </a:r>
+          </a:p>
+          <a:p>
+            <a:r>
+              <a:rPr sz="1800"/>
+              <a:t>Research question｜低接觸壓力下，contact resistance 是否主導訊號不穩定？</a:t>
+            </a:r>
+          </a:p>
+          <a:p>
+            <a:r>
+              <a:rPr sz="1800"/>
+              <a:t>Literature consensus｜transport gradient 可產生位置效應。</a:t>
+            </a:r>
+          </a:p>
+          <a:p>
+            <a:r>
+              <a:rPr sz="1800"/>
+              <a:t>Alternatives｜interface contact remains alternative</a:t>
+            </a:r>
+          </a:p>
+          <a:p>
+            <a:r>
+              <a:rPr sz="1800"/>
+              <a:t>Gap｜缺少控制比較隔離機制。</a:t>
+            </a:r>
+          </a:p>
+          <a:p>
+            <a:r>
+              <a:rPr sz="1800"/>
+              <a:t>Implication｜需匹配條件後比較。</a:t>
+            </a:r>
+          </a:p>
+          <a:p>
+            <a:r>
+              <a:rPr sz="1800"/>
+              <a:t>Mechanism｜contact resistance</a:t>
+            </a:r>
+          </a:p>
+          <a:p>
+            <a:r>
+              <a:rPr sz="1800"/>
+              <a:t>Strategy｜匹配導電度並改變接觸壓力</a:t>
             </a:r>
           </a:p>
         </p:txBody>
@@ -6141,8 +6281,8 @@
         </p:nvSpPr>
         <p:spPr>
           <a:xfrm>
-            <a:off x="640080" y="1417320"/>
-            <a:ext cx="4572000" cy="4480560"/>
+            <a:off x="731520" y="1325880"/>
+            <a:ext cx="5257800" cy="3840480"/>
           </a:xfrm>
           <a:prstGeom prst="rect">
             <a:avLst/>
@@ -6154,6 +6294,12 @@
             <a:spAutoFit/>
           </a:bodyPr>
           <a:lstStyle/>
+          <a:p>
+            <a:r>
+              <a:rPr sz="1800"/>
+              <a:t>EXP201｜</a:t>
+            </a:r>
+          </a:p>
           <a:p>
             <a:r>
               <a:rPr sz="1800"/>
@@ -6178,8 +6324,8 @@
         </p:blipFill>
         <p:spPr>
           <a:xfrm>
-            <a:off x="5212080" y="1417320"/>
-            <a:ext cx="6217920" cy="4114800"/>
+            <a:off x="6217920" y="1325880"/>
+            <a:ext cx="5257800" cy="3840480"/>
           </a:xfrm>
           <a:prstGeom prst="rect">
             <a:avLst/>
@@ -6310,8 +6456,8 @@
         </p:nvSpPr>
         <p:spPr>
           <a:xfrm>
-            <a:off x="640080" y="1417320"/>
-            <a:ext cx="4572000" cy="4480560"/>
+            <a:off x="731520" y="1280160"/>
+            <a:ext cx="3383280" cy="2103120"/>
           </a:xfrm>
           <a:prstGeom prst="rect">
             <a:avLst/>
@@ -6332,19 +6478,13 @@
           <a:p>
             <a:r>
               <a:rPr sz="1800"/>
-              <a:t>Evidence｜E201, RES201</a:t>
-            </a:r>
-          </a:p>
-          <a:p>
-            <a:r>
-              <a:rPr sz="1800"/>
               <a:t>Hypothesis status｜supported</a:t>
             </a:r>
           </a:p>
           <a:p>
             <a:r>
               <a:rPr sz="1800"/>
-              <a:t>Decision｜D201</a:t>
+              <a:t>Decision｜Go: Contact-pressure control discriminates the interface mechanism.</a:t>
             </a:r>
           </a:p>
           <a:p>
@@ -6362,7 +6502,7 @@
           <a:p>
             <a:r>
               <a:rPr sz="1800"/>
-              <a:t>Next Step｜NS201｜Owner: Gary｜Timing committed</a:t>
+              <a:t>Next Step｜NS201</a:t>
             </a:r>
           </a:p>
         </p:txBody>
@@ -6431,8 +6571,8 @@
         </p:nvSpPr>
         <p:spPr>
           <a:xfrm>
-            <a:off x="640080" y="1417320"/>
-            <a:ext cx="4572000" cy="4480560"/>
+            <a:off x="731520" y="1325880"/>
+            <a:ext cx="6400800" cy="3429000"/>
           </a:xfrm>
           <a:prstGeom prst="rect">
             <a:avLst/>
@@ -6447,25 +6587,31 @@
           <a:p>
             <a:r>
               <a:rPr sz="1800"/>
-              <a:t>Prior commitment｜NS101 matched-conductivity pressure test：done</a:t>
-            </a:r>
-          </a:p>
-          <a:p>
-            <a:r>
-              <a:rPr sz="1800"/>
-              <a:t>Current position｜H02 / FB-ELECTRODE-CONTACT</a:t>
-            </a:r>
-          </a:p>
-          <a:p>
-            <a:r>
-              <a:rPr sz="1800"/>
-              <a:t>Next｜NS201 high-pressure cycling；Owner: Gary；Due: 2026-09-24</a:t>
-            </a:r>
-          </a:p>
-          <a:p>
-            <a:r>
-              <a:rPr sz="1800"/>
-              <a:t>Parallel work｜cycling fixture + electrode geometry review</a:t>
+              <a:t>Current position｜H002</a:t>
+            </a:r>
+          </a:p>
+          <a:p>
+            <a:r>
+              <a:rPr sz="1800"/>
+              <a:t>Commitment｜NS101｜done｜Owner: Gary｜Due: 2026-09-10T09:00:00Z</a:t>
+            </a:r>
+          </a:p>
+          <a:p>
+            <a:r>
+              <a:rPr sz="1800"/>
+              <a:t>Dependencies｜pressure fixture｜Parallel: True</a:t>
+            </a:r>
+          </a:p>
+          <a:p>
+            <a:r>
+              <a:rPr sz="1800"/>
+              <a:t>Commitment｜NS201｜planned｜Owner: Gary｜Due: 2026-09-24T00:00:00Z</a:t>
+            </a:r>
+          </a:p>
+          <a:p>
+            <a:r>
+              <a:rPr sz="1800"/>
+              <a:t>Dependencies｜pressure fixture｜Parallel: True</a:t>
             </a:r>
           </a:p>
         </p:txBody>
@@ -6534,8 +6680,8 @@
         </p:nvSpPr>
         <p:spPr>
           <a:xfrm>
-            <a:off x="640080" y="1417320"/>
-            <a:ext cx="4572000" cy="4480560"/>
+            <a:off x="731520" y="1508760"/>
+            <a:ext cx="10698480" cy="2148840"/>
           </a:xfrm>
           <a:prstGeom prst="rect">
             <a:avLst/>
@@ -6550,13 +6696,19 @@
           <a:p>
             <a:r>
               <a:rPr sz="1800"/>
-              <a:t>目前相信｜Bulk conductivity 主導位置不穩定。</a:t>
-            </a:r>
-          </a:p>
-          <a:p>
-            <a:r>
-              <a:rPr sz="1800"/>
-              <a:t>Falsifier｜導電度提升後重複性仍不改善。</a:t>
+              <a:t>Hypothesis｜Bulk conductivity drives the positional signal gradient.</a:t>
+            </a:r>
+          </a:p>
+          <a:p>
+            <a:r>
+              <a:rPr sz="1800"/>
+              <a:t>Falsifier｜Matched conditions do not change the predicted CV or resistance.</a:t>
+            </a:r>
+          </a:p>
+          <a:p>
+            <a:r>
+              <a:rPr sz="1800"/>
+              <a:t>Research question｜提升 bulk conductivity 是否足以降低位置依賴的訊號變異？</a:t>
             </a:r>
           </a:p>
         </p:txBody>
@@ -6625,8 +6777,8 @@
         </p:nvSpPr>
         <p:spPr>
           <a:xfrm>
-            <a:off x="640080" y="1417320"/>
-            <a:ext cx="4572000" cy="4480560"/>
+            <a:off x="8046720" y="1325880"/>
+            <a:ext cx="3383280" cy="1600200"/>
           </a:xfrm>
           <a:prstGeom prst="rect">
             <a:avLst/>
@@ -6641,7 +6793,7 @@
           <a:p>
             <a:r>
               <a:rPr sz="1800"/>
-              <a:t>Unresolved problem｜合成薄膜的缺陷密度沿位置增加，且訊號重複性下降。</a:t>
+              <a:t>Problem｜合成薄膜的缺陷密度沿位置增加，且訊號重複性下降。</a:t>
             </a:r>
           </a:p>
           <a:p>
@@ -6665,7 +6817,7 @@
           <a:p>
             <a:r>
               <a:rPr sz="1800"/>
-              <a:t>Remaining uncertainty｜合成五個位置、每個位置三個 replicate 的機制辨識。</a:t>
+              <a:t>Scope｜合成五個位置、每個位置三個 replicate 的機制辨識。</a:t>
             </a:r>
           </a:p>
         </p:txBody>
@@ -6734,8 +6886,8 @@
         </p:nvSpPr>
         <p:spPr>
           <a:xfrm>
-            <a:off x="640080" y="1417320"/>
-            <a:ext cx="4572000" cy="4480560"/>
+            <a:off x="731520" y="1508760"/>
+            <a:ext cx="2743200" cy="1280160"/>
           </a:xfrm>
           <a:prstGeom prst="rect">
             <a:avLst/>
@@ -6762,7 +6914,7 @@
           <a:p>
             <a:r>
               <a:rPr sz="1800"/>
-              <a:t>Old layer topology is immutable; current overview uses latest revision.</a:t>
+              <a:t>Immutable map; current branch highlighted.</a:t>
             </a:r>
           </a:p>
         </p:txBody>
@@ -6783,8 +6935,8 @@
         </p:blipFill>
         <p:spPr>
           <a:xfrm>
-            <a:off x="5212080" y="1417320"/>
-            <a:ext cx="6217920" cy="4114800"/>
+            <a:off x="3886200" y="1234440"/>
+            <a:ext cx="7635240" cy="4480560"/>
           </a:xfrm>
           <a:prstGeom prst="rect">
             <a:avLst/>
@@ -6855,8 +7007,8 @@
         </p:nvSpPr>
         <p:spPr>
           <a:xfrm>
-            <a:off x="640080" y="1417320"/>
-            <a:ext cx="4572000" cy="4480560"/>
+            <a:off x="731520" y="2331720"/>
+            <a:ext cx="5669280" cy="2423160"/>
           </a:xfrm>
           <a:prstGeom prst="rect">
             <a:avLst/>
@@ -6871,29 +7023,83 @@
           <a:p>
             <a:r>
               <a:rPr sz="1800"/>
-              <a:t>Observation｜缺陷密度沿位置增加，訊號 CV 同步升高。</a:t>
-            </a:r>
-          </a:p>
-          <a:p>
-            <a:r>
-              <a:rPr sz="1800"/>
-              <a:t>Literature synthesis｜transport gradient 可改變 bulk conductivity；但 interface variability 仍是 alternative。</a:t>
-            </a:r>
-          </a:p>
-          <a:p>
-            <a:r>
-              <a:rPr sz="1800"/>
-              <a:t>Mechanism｜含水量梯度 → conductivity gradient。</a:t>
-            </a:r>
-          </a:p>
-          <a:p>
-            <a:r>
-              <a:rPr sz="1800"/>
-              <a:t>Strategy｜提升並均化含水量，再檢查 CV 是否同步下降。</a:t>
-            </a:r>
-          </a:p>
-        </p:txBody>
-      </p:sp>
+              <a:t>Observation｜位置依賴缺陷與訊號變異已觀察到。</a:t>
+            </a:r>
+          </a:p>
+          <a:p>
+            <a:r>
+              <a:rPr sz="1800"/>
+              <a:t>Problem｜現有模型無法解釋此變異。</a:t>
+            </a:r>
+          </a:p>
+          <a:p>
+            <a:r>
+              <a:rPr sz="1800"/>
+              <a:t>Research question｜提升 bulk conductivity 是否足以降低位置依賴的訊號變異？</a:t>
+            </a:r>
+          </a:p>
+          <a:p>
+            <a:r>
+              <a:rPr sz="1800"/>
+              <a:t>Literature consensus｜transport gradient 可產生位置效應。</a:t>
+            </a:r>
+          </a:p>
+          <a:p>
+            <a:r>
+              <a:rPr sz="1800"/>
+              <a:t>Alternatives｜interface contact remains alternative</a:t>
+            </a:r>
+          </a:p>
+          <a:p>
+            <a:r>
+              <a:rPr sz="1800"/>
+              <a:t>Gap｜缺少控制比較隔離機制。</a:t>
+            </a:r>
+          </a:p>
+          <a:p>
+            <a:r>
+              <a:rPr sz="1800"/>
+              <a:t>Implication｜需匹配條件後比較。</a:t>
+            </a:r>
+          </a:p>
+          <a:p>
+            <a:r>
+              <a:rPr sz="1800"/>
+              <a:t>Mechanism｜bulk transport</a:t>
+            </a:r>
+          </a:p>
+          <a:p>
+            <a:r>
+              <a:rPr sz="1800"/>
+              <a:t>Strategy｜均化導電度</a:t>
+            </a:r>
+          </a:p>
+        </p:txBody>
+      </p:sp>
+      <p:pic>
+        <p:nvPicPr>
+          <p:cNvPr id="5" name="Picture 4" descr="observation_visual.png"/>
+          <p:cNvPicPr>
+            <a:picLocks noChangeAspect="1"/>
+          </p:cNvPicPr>
+          <p:nvPr/>
+        </p:nvPicPr>
+        <p:blipFill>
+          <a:blip r:embed="rId2"/>
+          <a:stretch>
+            <a:fillRect/>
+          </a:stretch>
+        </p:blipFill>
+        <p:spPr>
+          <a:xfrm>
+            <a:off x="6903720" y="1280160"/>
+            <a:ext cx="4572000" cy="3474720"/>
+          </a:xfrm>
+          <a:prstGeom prst="rect">
+            <a:avLst/>
+          </a:prstGeom>
+        </p:spPr>
+      </p:pic>
     </p:spTree>
   </p:cSld>
   <p:clrMapOvr>
@@ -6958,8 +7164,8 @@
         </p:nvSpPr>
         <p:spPr>
           <a:xfrm>
-            <a:off x="640080" y="1417320"/>
-            <a:ext cx="4572000" cy="4480560"/>
+            <a:off x="731520" y="1325880"/>
+            <a:ext cx="5303520" cy="3566160"/>
           </a:xfrm>
           <a:prstGeom prst="rect">
             <a:avLst/>
@@ -6974,25 +7180,55 @@
           <a:p>
             <a:r>
               <a:rPr sz="1800"/>
-              <a:t>Observation｜缺陷密度沿位置增加，訊號 CV 同步升高。</a:t>
-            </a:r>
-          </a:p>
-          <a:p>
-            <a:r>
-              <a:rPr sz="1800"/>
-              <a:t>Literature synthesis｜transport gradient 可改變 bulk conductivity；但 interface variability 仍是 alternative。</a:t>
-            </a:r>
-          </a:p>
-          <a:p>
-            <a:r>
-              <a:rPr sz="1800"/>
-              <a:t>Mechanism｜含水量梯度 → conductivity gradient。</a:t>
-            </a:r>
-          </a:p>
-          <a:p>
-            <a:r>
-              <a:rPr sz="1800"/>
-              <a:t>Strategy｜提升並均化含水量，再檢查 CV 是否同步下降。</a:t>
+              <a:t>Observation｜位置依賴缺陷與訊號變異已觀察到。</a:t>
+            </a:r>
+          </a:p>
+          <a:p>
+            <a:r>
+              <a:rPr sz="1800"/>
+              <a:t>Problem｜現有模型無法解釋此變異。</a:t>
+            </a:r>
+          </a:p>
+          <a:p>
+            <a:r>
+              <a:rPr sz="1800"/>
+              <a:t>Research question｜提升 bulk conductivity 是否足以降低位置依賴的訊號變異？</a:t>
+            </a:r>
+          </a:p>
+          <a:p>
+            <a:r>
+              <a:rPr sz="1800"/>
+              <a:t>Literature consensus｜transport gradient 可產生位置效應。</a:t>
+            </a:r>
+          </a:p>
+          <a:p>
+            <a:r>
+              <a:rPr sz="1800"/>
+              <a:t>Alternatives｜interface contact remains alternative</a:t>
+            </a:r>
+          </a:p>
+          <a:p>
+            <a:r>
+              <a:rPr sz="1800"/>
+              <a:t>Gap｜缺少控制比較隔離機制。</a:t>
+            </a:r>
+          </a:p>
+          <a:p>
+            <a:r>
+              <a:rPr sz="1800"/>
+              <a:t>Implication｜需匹配條件後比較。</a:t>
+            </a:r>
+          </a:p>
+          <a:p>
+            <a:r>
+              <a:rPr sz="1800"/>
+              <a:t>Mechanism｜bulk transport</a:t>
+            </a:r>
+          </a:p>
+          <a:p>
+            <a:r>
+              <a:rPr sz="1800"/>
+              <a:t>Strategy｜均化導電度</a:t>
             </a:r>
           </a:p>
         </p:txBody>
@@ -7061,8 +7297,8 @@
         </p:nvSpPr>
         <p:spPr>
           <a:xfrm>
-            <a:off x="640080" y="1417320"/>
-            <a:ext cx="4572000" cy="4480560"/>
+            <a:off x="731520" y="1280160"/>
+            <a:ext cx="6766560" cy="3931920"/>
           </a:xfrm>
           <a:prstGeom prst="rect">
             <a:avLst/>
@@ -7077,50 +7313,86 @@
           <a:p>
             <a:r>
               <a:rPr sz="1800"/>
-              <a:t>EXP101｜提升含水量以提高 bulk conductivity</a:t>
-            </a:r>
-          </a:p>
-          <a:p>
-            <a:r>
-              <a:rPr sz="1800"/>
-              <a:t>IV: 含水量｜Control: 原始配方</a:t>
-            </a:r>
-          </a:p>
-          <a:p>
-            <a:r>
-              <a:rPr sz="1800"/>
-              <a:t>N: n=3 per position｜Metric/units: 導電度 / mS/cm</a:t>
-            </a:r>
-          </a:p>
-          <a:p>
-            <a:r>
-              <a:rPr sz="1800"/>
-              <a:t>Decision rule: Go if mean conductivity increases ≥20%</a:t>
+              <a:t>EXP101｜IV: ['含水量']</a:t>
+            </a:r>
+          </a:p>
+          <a:p>
+            <a:r>
+              <a:rPr sz="1800"/>
+              <a:t>Controls: ['原始配方']</a:t>
+            </a:r>
+          </a:p>
+          <a:p>
+            <a:r>
+              <a:rPr sz="1800"/>
+              <a:t>N/replicates: {'replicates': 3, 'samples': 15}</a:t>
+            </a:r>
+          </a:p>
+          <a:p>
+            <a:r>
+              <a:rPr sz="1800"/>
+              <a:t>Metrics/units: ['導電度 (mS/cm)']</a:t>
+            </a:r>
+          </a:p>
+          <a:p>
+            <a:r>
+              <a:rPr sz="1800"/>
+              <a:t>Method: ['synthetic-four-probe']</a:t>
+            </a:r>
+          </a:p>
+          <a:p>
+            <a:r>
+              <a:rPr sz="1800"/>
+              <a:t>Prediction: ['導電度提升']</a:t>
+            </a:r>
+          </a:p>
+          <a:p>
+            <a:r>
+              <a:rPr sz="1800"/>
+              <a:t>Decision rule: {'go': 'mean conductivity increases &gt;=20%', 'partial_go': '10-20%', 'no_go': '&lt;10%'}</a:t>
             </a:r>
           </a:p>
           <a:p/>
           <a:p>
             <a:r>
               <a:rPr sz="1800"/>
-              <a:t>EXP102｜檢查導電度改善是否同步改善重複性</a:t>
-            </a:r>
-          </a:p>
-          <a:p>
-            <a:r>
-              <a:rPr sz="1800"/>
-              <a:t>IV: 位置｜Control: 原始位置分布</a:t>
-            </a:r>
-          </a:p>
-          <a:p>
-            <a:r>
-              <a:rPr sz="1800"/>
-              <a:t>N: n=3 per position｜Metric/units: 訊號 CV / percent</a:t>
-            </a:r>
-          </a:p>
-          <a:p>
-            <a:r>
-              <a:rPr sz="1800"/>
-              <a:t>Decision rule: Go if CV decreases ≥30%; Partial-Go if 10–30%; No-Go otherwise</a:t>
+              <a:t>EXP102｜IV: ['位置']</a:t>
+            </a:r>
+          </a:p>
+          <a:p>
+            <a:r>
+              <a:rPr sz="1800"/>
+              <a:t>Controls: ['原始位置分布']</a:t>
+            </a:r>
+          </a:p>
+          <a:p>
+            <a:r>
+              <a:rPr sz="1800"/>
+              <a:t>N/replicates: {'replicates': 3, 'samples': 15}</a:t>
+            </a:r>
+          </a:p>
+          <a:p>
+            <a:r>
+              <a:rPr sz="1800"/>
+              <a:t>Metrics/units: ['訊號 CV (%)']</a:t>
+            </a:r>
+          </a:p>
+          <a:p>
+            <a:r>
+              <a:rPr sz="1800"/>
+              <a:t>Method: ['synthetic-signal-test']</a:t>
+            </a:r>
+          </a:p>
+          <a:p>
+            <a:r>
+              <a:rPr sz="1800"/>
+              <a:t>Prediction: ['CV 下降']</a:t>
+            </a:r>
+          </a:p>
+          <a:p>
+            <a:r>
+              <a:rPr sz="1800"/>
+              <a:t>Decision rule: {'go': 'CV decreases &gt;=30%', 'partial_go': '10-30%', 'no_go': '&lt;10%'}</a:t>
             </a:r>
           </a:p>
         </p:txBody>

</xml_diff>

<commit_message>
fix: complete Phase 2 revision 2 contracts
</commit_message>
<xml_diff>
--- a/thesis-deck-system/artifacts/phase2/acceptance-deck-render-compat.pptx
+++ b/thesis-deck-system/artifacts/phase2/acceptance-deck-render-compat.pptx
@@ -25,6 +25,7 @@
     <p:sldId id="273" r:id="rId25"/>
     <p:sldId id="274" r:id="rId26"/>
     <p:sldId id="275" r:id="rId27"/>
+    <p:sldId id="276" r:id="rId28"/>
   </p:sldIdLst>
   <p:sldSz cx="12191999" cy="6858000" type="screen4x3"/>
   <p:notesSz cx="6858000" cy="9144000"/>
@@ -526,6 +527,16 @@
           </a:p>
           <a:p>
             <a:r>
+              <a:t>E202</a:t>
+            </a:r>
+          </a:p>
+          <a:p>
+            <a:r>
+              <a:t>E204</a:t>
+            </a:r>
+          </a:p>
+          <a:p>
+            <a:r>
               <a:t>E201</a:t>
             </a:r>
           </a:p>
@@ -911,7 +922,12 @@
           </a:p>
           <a:p>
             <a:r>
-              <a:t>E201</a:t>
+              <a:t>E104</a:t>
+            </a:r>
+          </a:p>
+          <a:p>
+            <a:r>
+              <a:t>E101</a:t>
             </a:r>
           </a:p>
           <a:p>
@@ -996,6 +1012,16 @@
           </a:p>
           <a:p>
             <a:r>
+              <a:t>E202</a:t>
+            </a:r>
+          </a:p>
+          <a:p>
+            <a:r>
+              <a:t>E204</a:t>
+            </a:r>
+          </a:p>
+          <a:p>
+            <a:r>
               <a:t>E201</a:t>
             </a:r>
           </a:p>
@@ -1081,6 +1107,16 @@
           </a:p>
           <a:p>
             <a:r>
+              <a:t>E202</a:t>
+            </a:r>
+          </a:p>
+          <a:p>
+            <a:r>
+              <a:t>E204</a:t>
+            </a:r>
+          </a:p>
+          <a:p>
+            <a:r>
               <a:t>E201</a:t>
             </a:r>
           </a:p>
@@ -1166,6 +1202,16 @@
           </a:p>
           <a:p>
             <a:r>
+              <a:t>E202</a:t>
+            </a:r>
+          </a:p>
+          <a:p>
+            <a:r>
+              <a:t>E204</a:t>
+            </a:r>
+          </a:p>
+          <a:p>
+            <a:r>
               <a:t>E201</a:t>
             </a:r>
           </a:p>
@@ -1251,6 +1297,16 @@
           </a:p>
           <a:p>
             <a:r>
+              <a:t>E202</a:t>
+            </a:r>
+          </a:p>
+          <a:p>
+            <a:r>
+              <a:t>E204</a:t>
+            </a:r>
+          </a:p>
+          <a:p>
+            <a:r>
               <a:t>E201</a:t>
             </a:r>
           </a:p>
@@ -1332,6 +1388,111 @@
           <a:p>
             <a:r>
               <a:t>[Sources]</a:t>
+            </a:r>
+          </a:p>
+          <a:p>
+            <a:r>
+              <a:t>E202</a:t>
+            </a:r>
+          </a:p>
+          <a:p>
+            <a:r>
+              <a:t>E204</a:t>
+            </a:r>
+          </a:p>
+          <a:p>
+            <a:r>
+              <a:t>E201</a:t>
+            </a:r>
+          </a:p>
+          <a:p>
+            <a:r>
+              <a:t>[/Sources]</a:t>
+            </a:r>
+          </a:p>
+          <a:p>
+            <a:r>
+              <a:t>Compiled from persisted ledger materialization.</a:t>
+            </a:r>
+          </a:p>
+        </p:txBody>
+      </p:sp>
+      <p:sp>
+        <p:nvSpPr>
+          <p:cNvPr id="4" name="Slide Number Placeholder 3"/>
+          <p:cNvSpPr>
+            <a:spLocks noGrp="1"/>
+          </p:cNvSpPr>
+          <p:nvPr>
+            <p:ph type="sldNum" idx="5" sz="quarter"/>
+          </p:nvPr>
+        </p:nvSpPr>
+        <p:spPr/>
+      </p:sp>
+    </p:spTree>
+  </p:cSld>
+  <p:clrMapOvr>
+    <a:masterClrMapping/>
+  </p:clrMapOvr>
+</p:notes>
+</file>
+
+<file path=ppt/notesSlides/notesSlide19.xml><?xml version="1.0" encoding="utf-8"?>
+<p:notes xmlns:a="http://schemas.openxmlformats.org/drawingml/2006/main" xmlns:p="http://schemas.openxmlformats.org/presentationml/2006/main" xmlns:r="http://schemas.openxmlformats.org/officeDocument/2006/relationships">
+  <p:cSld>
+    <p:spTree>
+      <p:nvGrpSpPr>
+        <p:cNvPr id="1" name=""/>
+        <p:cNvGrpSpPr/>
+        <p:nvPr/>
+      </p:nvGrpSpPr>
+      <p:grpSpPr>
+        <a:xfrm>
+          <a:off x="0" y="0"/>
+          <a:ext cx="0" cy="0"/>
+          <a:chOff x="0" y="0"/>
+          <a:chExt cx="0" cy="0"/>
+        </a:xfrm>
+      </p:grpSpPr>
+      <p:sp>
+        <p:nvSpPr>
+          <p:cNvPr id="2" name="Slide Image Placeholder 1"/>
+          <p:cNvSpPr>
+            <a:spLocks noGrp="1"/>
+          </p:cNvSpPr>
+          <p:nvPr>
+            <p:ph type="sldImg" idx="2"/>
+          </p:nvPr>
+        </p:nvSpPr>
+        <p:spPr/>
+      </p:sp>
+      <p:sp>
+        <p:nvSpPr>
+          <p:cNvPr id="3" name="Notes Placeholder 2"/>
+          <p:cNvSpPr>
+            <a:spLocks noGrp="1"/>
+          </p:cNvSpPr>
+          <p:nvPr>
+            <p:ph type="body" idx="3" sz="quarter"/>
+          </p:nvPr>
+        </p:nvSpPr>
+        <p:spPr/>
+        <p:txBody>
+          <a:bodyPr/>
+          <a:lstStyle/>
+          <a:p>
+            <a:r>
+              <a:t>[Sources]</a:t>
+            </a:r>
+          </a:p>
+          <a:p>
+            <a:r>
+              <a:t>E202</a:t>
+            </a:r>
+          </a:p>
+          <a:p>
+            <a:r>
+              <a:t>E204</a:t>
             </a:r>
           </a:p>
           <a:p>
@@ -5222,13 +5383,19 @@
             <p:ph type="title"/>
           </p:nvPr>
         </p:nvSpPr>
-        <p:spPr/>
-        <p:txBody>
-          <a:bodyPr/>
-          <a:lstStyle/>
-          <a:p>
-            <a:r>
-              <a:t>H001｜Results</a:t>
+        <p:spPr>
+          <a:xfrm>
+            <a:off x="502920" y="201168"/>
+            <a:ext cx="11109960" cy="960120"/>
+          </a:xfrm>
+        </p:spPr>
+        <p:txBody>
+          <a:bodyPr lIns="0" rIns="0" tIns="0" bIns="0" wrap="square"/>
+          <a:lstStyle/>
+          <a:p>
+            <a:r>
+              <a:rPr sz="3000"/>
+              <a:t>H001｜Experiment Design</a:t>
             </a:r>
           </a:p>
         </p:txBody>
@@ -5252,14 +5419,14 @@
       </p:sp>
       <p:sp>
         <p:nvSpPr>
-          <p:cNvPr id="4" name="TextBox 3"/>
+          <p:cNvPr id="4" name="tds-slot:experiment_matrix"/>
           <p:cNvSpPr txBox="1"/>
           <p:nvPr/>
         </p:nvSpPr>
         <p:spPr>
           <a:xfrm>
-            <a:off x="731520" y="1325880"/>
-            <a:ext cx="5257800" cy="3840480"/>
+            <a:off x="731520" y="1280160"/>
+            <a:ext cx="6766560" cy="3931920"/>
           </a:xfrm>
           <a:prstGeom prst="rect">
             <a:avLst/>
@@ -5273,36 +5440,71 @@
           <a:lstStyle/>
           <a:p>
             <a:r>
-              <a:rPr sz="1800"/>
-              <a:t>RES101｜平均導電度增加 24% ± 5% SD</a:t>
-            </a:r>
-          </a:p>
-        </p:txBody>
-      </p:sp>
-      <p:pic>
-        <p:nvPicPr>
-          <p:cNvPr id="5" name="Picture 4" descr="B001_defect_density.png"/>
-          <p:cNvPicPr>
-            <a:picLocks noChangeAspect="1"/>
-          </p:cNvPicPr>
+              <a:rPr sz="1600"/>
+              <a:t>EXP102｜IV: ['位置']</a:t>
+            </a:r>
+          </a:p>
+          <a:p>
+            <a:r>
+              <a:rPr sz="1600"/>
+              <a:t>Controls: ['原始位置分布']</a:t>
+            </a:r>
+          </a:p>
+          <a:p>
+            <a:r>
+              <a:rPr sz="1600"/>
+              <a:t>N/replicates: {'replicates': 3, 'samples': 15}</a:t>
+            </a:r>
+          </a:p>
+          <a:p>
+            <a:r>
+              <a:rPr sz="1600"/>
+              <a:t>Metrics/units: ['訊號 CV (%)']</a:t>
+            </a:r>
+          </a:p>
+          <a:p>
+            <a:r>
+              <a:rPr sz="1600"/>
+              <a:t>Method: ['synthetic-signal-test']</a:t>
+            </a:r>
+          </a:p>
+        </p:txBody>
+      </p:sp>
+      <p:sp>
+        <p:nvSpPr>
+          <p:cNvPr id="5" name="tds-slot:decision_rule"/>
+          <p:cNvSpPr txBox="1"/>
           <p:nvPr/>
-        </p:nvPicPr>
-        <p:blipFill>
-          <a:blip r:embed="rId2"/>
-          <a:stretch>
-            <a:fillRect/>
-          </a:stretch>
-        </p:blipFill>
-        <p:spPr>
-          <a:xfrm>
-            <a:off x="6217920" y="1325880"/>
-            <a:ext cx="5257800" cy="3840480"/>
+        </p:nvSpPr>
+        <p:spPr>
+          <a:xfrm>
+            <a:off x="7818120" y="1280160"/>
+            <a:ext cx="3657600" cy="1828800"/>
           </a:xfrm>
           <a:prstGeom prst="rect">
             <a:avLst/>
           </a:prstGeom>
-        </p:spPr>
-      </p:pic>
+          <a:noFill/>
+        </p:spPr>
+        <p:txBody>
+          <a:bodyPr wrap="none">
+            <a:spAutoFit/>
+          </a:bodyPr>
+          <a:lstStyle/>
+          <a:p>
+            <a:r>
+              <a:rPr sz="1600"/>
+              <a:t>Prediction: ['CV 下降']</a:t>
+            </a:r>
+          </a:p>
+          <a:p>
+            <a:r>
+              <a:rPr sz="1600"/>
+              <a:t>Decision rule: {'go': 'CV decreases &gt;=30%', 'partial_go': '10-30%', 'no_go': '&lt;10%'}</a:t>
+            </a:r>
+          </a:p>
+        </p:txBody>
+      </p:sp>
     </p:spTree>
   </p:cSld>
   <p:clrMapOvr>
@@ -5331,12 +5533,18 @@
             <p:ph type="title"/>
           </p:nvPr>
         </p:nvSpPr>
-        <p:spPr/>
-        <p:txBody>
-          <a:bodyPr/>
-          <a:lstStyle/>
-          <a:p>
-            <a:r>
+        <p:spPr>
+          <a:xfrm>
+            <a:off x="502920" y="201168"/>
+            <a:ext cx="11109960" cy="960120"/>
+          </a:xfrm>
+        </p:spPr>
+        <p:txBody>
+          <a:bodyPr lIns="0" rIns="0" tIns="0" bIns="0" wrap="square"/>
+          <a:lstStyle/>
+          <a:p>
+            <a:r>
+              <a:rPr sz="3000"/>
               <a:t>H001｜Results</a:t>
             </a:r>
           </a:p>
@@ -5361,7 +5569,7 @@
       </p:sp>
       <p:sp>
         <p:nvSpPr>
-          <p:cNvPr id="4" name="TextBox 3"/>
+          <p:cNvPr id="4" name="tds-slot:control_panel"/>
           <p:cNvSpPr txBox="1"/>
           <p:nvPr/>
         </p:nvSpPr>
@@ -5382,15 +5590,15 @@
           <a:lstStyle/>
           <a:p>
             <a:r>
-              <a:rPr sz="1800"/>
-              <a:t>RES102｜訊號 CV 僅下降 4% ± 6% SD，屬 No-Go</a:t>
+              <a:rPr sz="1600"/>
+              <a:t>Control｜</a:t>
             </a:r>
           </a:p>
         </p:txBody>
       </p:sp>
       <p:pic>
         <p:nvPicPr>
-          <p:cNvPr id="5" name="Picture 4" descr="B001_defect_density.png"/>
+          <p:cNvPr id="5" name="tds-slot:proposed_panel" descr="B001_defect_density.png"/>
           <p:cNvPicPr>
             <a:picLocks noChangeAspect="1"/>
           </p:cNvPicPr>
@@ -5440,13 +5648,19 @@
             <p:ph type="title"/>
           </p:nvPr>
         </p:nvSpPr>
-        <p:spPr/>
-        <p:txBody>
-          <a:bodyPr/>
-          <a:lstStyle/>
-          <a:p>
-            <a:r>
-              <a:t>H001｜Integrated Discussion</a:t>
+        <p:spPr>
+          <a:xfrm>
+            <a:off x="502920" y="201168"/>
+            <a:ext cx="11109960" cy="960120"/>
+          </a:xfrm>
+        </p:spPr>
+        <p:txBody>
+          <a:bodyPr lIns="0" rIns="0" tIns="0" bIns="0" wrap="square"/>
+          <a:lstStyle/>
+          <a:p>
+            <a:r>
+              <a:rPr sz="3000"/>
+              <a:t>H001｜Results</a:t>
             </a:r>
           </a:p>
         </p:txBody>
@@ -5470,14 +5684,14 @@
       </p:sp>
       <p:sp>
         <p:nvSpPr>
-          <p:cNvPr id="4" name="TextBox 3"/>
+          <p:cNvPr id="4" name="tds-slot:control_panel"/>
           <p:cNvSpPr txBox="1"/>
           <p:nvPr/>
         </p:nvSpPr>
         <p:spPr>
           <a:xfrm>
-            <a:off x="731520" y="3566160"/>
-            <a:ext cx="10744200" cy="1554480"/>
+            <a:off x="731520" y="1325880"/>
+            <a:ext cx="5257800" cy="3840480"/>
           </a:xfrm>
           <a:prstGeom prst="rect">
             <a:avLst/>
@@ -5491,42 +5705,36 @@
           <a:lstStyle/>
           <a:p>
             <a:r>
-              <a:rPr sz="1800"/>
-              <a:t>Supporting｜RES101</a:t>
-            </a:r>
-          </a:p>
-          <a:p>
-            <a:r>
-              <a:rPr sz="1800"/>
-              <a:t>Contradicting｜RES102</a:t>
-            </a:r>
-          </a:p>
-          <a:p>
-            <a:r>
-              <a:rPr sz="1800"/>
-              <a:t>Cross-experiment pattern｜導電度提升成立，但重複性沒有同步改善。</a:t>
-            </a:r>
-          </a:p>
-          <a:p>
-            <a:r>
-              <a:rPr sz="1800"/>
-              <a:t>Mechanism assessment｜bulk conductivity 是部分機制，不足以解釋 interface-sensitive variation。</a:t>
-            </a:r>
-          </a:p>
-          <a:p>
-            <a:r>
-              <a:rPr sz="1800"/>
-              <a:t>Alternatives｜接觸電阻; 局部壓力差; 電極幾何</a:t>
-            </a:r>
-          </a:p>
-          <a:p>
-            <a:r>
-              <a:rPr sz="1800"/>
-              <a:t>Remaining uncertainty｜contact interface 是否為主導因素仍需匹配導電度後檢驗。</a:t>
-            </a:r>
-          </a:p>
-        </p:txBody>
-      </p:sp>
+              <a:rPr sz="1600"/>
+              <a:t>Control｜</a:t>
+            </a:r>
+          </a:p>
+        </p:txBody>
+      </p:sp>
+      <p:pic>
+        <p:nvPicPr>
+          <p:cNvPr id="5" name="tds-slot:proposed_panel" descr="B001_defect_density.png"/>
+          <p:cNvPicPr>
+            <a:picLocks noChangeAspect="1"/>
+          </p:cNvPicPr>
+          <p:nvPr/>
+        </p:nvPicPr>
+        <p:blipFill>
+          <a:blip r:embed="rId2"/>
+          <a:stretch>
+            <a:fillRect/>
+          </a:stretch>
+        </p:blipFill>
+        <p:spPr>
+          <a:xfrm>
+            <a:off x="6217920" y="1325880"/>
+            <a:ext cx="5257800" cy="3840480"/>
+          </a:xfrm>
+          <a:prstGeom prst="rect">
+            <a:avLst/>
+          </a:prstGeom>
+        </p:spPr>
+      </p:pic>
     </p:spTree>
   </p:cSld>
   <p:clrMapOvr>
@@ -5555,13 +5763,19 @@
             <p:ph type="title"/>
           </p:nvPr>
         </p:nvSpPr>
-        <p:spPr/>
-        <p:txBody>
-          <a:bodyPr/>
-          <a:lstStyle/>
-          <a:p>
-            <a:r>
-              <a:t>H001｜Layer Summary / Decision</a:t>
+        <p:spPr>
+          <a:xfrm>
+            <a:off x="502920" y="201168"/>
+            <a:ext cx="11109960" cy="960120"/>
+          </a:xfrm>
+        </p:spPr>
+        <p:txBody>
+          <a:bodyPr lIns="0" rIns="0" tIns="0" bIns="0" wrap="square"/>
+          <a:lstStyle/>
+          <a:p>
+            <a:r>
+              <a:rPr sz="3000"/>
+              <a:t>H001｜Integrated Discussion</a:t>
             </a:r>
           </a:p>
         </p:txBody>
@@ -5585,14 +5799,14 @@
       </p:sp>
       <p:sp>
         <p:nvSpPr>
-          <p:cNvPr id="4" name="TextBox 3"/>
+          <p:cNvPr id="4" name="tds-slot:supporting_results"/>
           <p:cNvSpPr txBox="1"/>
           <p:nvPr/>
         </p:nvSpPr>
         <p:spPr>
           <a:xfrm>
             <a:off x="731520" y="1280160"/>
-            <a:ext cx="3383280" cy="2103120"/>
+            <a:ext cx="5166360" cy="2011680"/>
           </a:xfrm>
           <a:prstGeom prst="rect">
             <a:avLst/>
@@ -5606,38 +5820,78 @@
           <a:lstStyle/>
           <a:p>
             <a:r>
-              <a:rPr sz="1800"/>
-              <a:t>Answered｜bulk conductivity 影響缺陷梯度，但不足以單獨解釋重複性。</a:t>
-            </a:r>
-          </a:p>
-          <a:p>
-            <a:r>
-              <a:rPr sz="1800"/>
-              <a:t>Hypothesis status｜partial_support</a:t>
-            </a:r>
-          </a:p>
-          <a:p>
-            <a:r>
-              <a:rPr sz="1800"/>
-              <a:t>Decision｜Partial-Go: Bulk conductivity is contributory but insufficient.</a:t>
-            </a:r>
-          </a:p>
-          <a:p>
-            <a:r>
-              <a:rPr sz="1800"/>
-              <a:t>Unresolved｜interface contact 的貢獻尚未量化。</a:t>
-            </a:r>
-          </a:p>
-          <a:p>
-            <a:r>
-              <a:rPr sz="1800"/>
-              <a:t>Next question｜匹配 bulk conductivity 後，contact resistance 是否主導變異？</a:t>
-            </a:r>
-          </a:p>
-          <a:p>
-            <a:r>
-              <a:rPr sz="1800"/>
-              <a:t>Next Step｜NS101</a:t>
+              <a:rPr sz="1600"/>
+              <a:t>RES101</a:t>
+            </a:r>
+          </a:p>
+        </p:txBody>
+      </p:sp>
+      <p:sp>
+        <p:nvSpPr>
+          <p:cNvPr id="5" name="tds-slot:contradicting_results"/>
+          <p:cNvSpPr txBox="1"/>
+          <p:nvPr/>
+        </p:nvSpPr>
+        <p:spPr>
+          <a:xfrm>
+            <a:off x="6217920" y="1280160"/>
+            <a:ext cx="5257800" cy="2011680"/>
+          </a:xfrm>
+          <a:prstGeom prst="rect">
+            <a:avLst/>
+          </a:prstGeom>
+          <a:noFill/>
+        </p:spPr>
+        <p:txBody>
+          <a:bodyPr wrap="none">
+            <a:spAutoFit/>
+          </a:bodyPr>
+          <a:lstStyle/>
+          <a:p>
+            <a:r>
+              <a:rPr sz="1600"/>
+              <a:t>RES102</a:t>
+            </a:r>
+          </a:p>
+        </p:txBody>
+      </p:sp>
+      <p:sp>
+        <p:nvSpPr>
+          <p:cNvPr id="6" name="tds-slot:uncertainty"/>
+          <p:cNvSpPr txBox="1"/>
+          <p:nvPr/>
+        </p:nvSpPr>
+        <p:spPr>
+          <a:xfrm>
+            <a:off x="731520" y="3566160"/>
+            <a:ext cx="10744200" cy="1554480"/>
+          </a:xfrm>
+          <a:prstGeom prst="rect">
+            <a:avLst/>
+          </a:prstGeom>
+          <a:noFill/>
+        </p:spPr>
+        <p:txBody>
+          <a:bodyPr wrap="none">
+            <a:spAutoFit/>
+          </a:bodyPr>
+          <a:lstStyle/>
+          <a:p>
+            <a:r>
+              <a:rPr sz="1600"/>
+              <a:t>Mechanism assessment｜bulk conductivity 是部分機制，不足以解釋 interface-sensitive variation。</a:t>
+            </a:r>
+          </a:p>
+          <a:p>
+            <a:r>
+              <a:rPr sz="1600"/>
+              <a:t>Alternatives｜接觸電阻; 局部壓力差; 電極幾何</a:t>
+            </a:r>
+          </a:p>
+          <a:p>
+            <a:r>
+              <a:rPr sz="1600"/>
+              <a:t>Remaining uncertainty｜contact interface 是否為主導因素仍需匹配導電度後檢驗。</a:t>
             </a:r>
           </a:p>
         </p:txBody>
@@ -5670,13 +5924,19 @@
             <p:ph type="title"/>
           </p:nvPr>
         </p:nvSpPr>
-        <p:spPr/>
-        <p:txBody>
-          <a:bodyPr/>
-          <a:lstStyle/>
-          <a:p>
-            <a:r>
-              <a:t>H01 → H02｜Hypothesis Transition</a:t>
+        <p:spPr>
+          <a:xfrm>
+            <a:off x="502920" y="201168"/>
+            <a:ext cx="11109960" cy="960120"/>
+          </a:xfrm>
+        </p:spPr>
+        <p:txBody>
+          <a:bodyPr lIns="0" rIns="0" tIns="0" bIns="0" wrap="square"/>
+          <a:lstStyle/>
+          <a:p>
+            <a:r>
+              <a:rPr sz="3000"/>
+              <a:t>H001｜Layer Summary / Decision</a:t>
             </a:r>
           </a:p>
         </p:txBody>
@@ -5700,14 +5960,14 @@
       </p:sp>
       <p:sp>
         <p:nvSpPr>
-          <p:cNvPr id="4" name="TextBox 3"/>
+          <p:cNvPr id="4" name="tds-slot:decision_status"/>
           <p:cNvSpPr txBox="1"/>
           <p:nvPr/>
         </p:nvSpPr>
         <p:spPr>
           <a:xfrm>
-            <a:off x="731520" y="1417320"/>
-            <a:ext cx="10744200" cy="2468880"/>
+            <a:off x="731520" y="1280160"/>
+            <a:ext cx="3383280" cy="2103120"/>
           </a:xfrm>
           <a:prstGeom prst="rect">
             <a:avLst/>
@@ -5722,37 +5982,83 @@
           <a:p>
             <a:r>
               <a:rPr sz="1800"/>
-              <a:t>Previous hypothesis｜C101</a:t>
+              <a:t>Answered｜bulk conductivity 影響缺陷梯度，但不足以單獨解釋重複性。</a:t>
             </a:r>
           </a:p>
           <a:p>
             <a:r>
               <a:rPr sz="1800"/>
-              <a:t>Key results｜RES101, RES102</a:t>
+              <a:t>Hypothesis status｜partial_support</a:t>
             </a:r>
           </a:p>
           <a:p>
             <a:r>
               <a:rPr sz="1800"/>
-              <a:t>Not explained｜導電度增加後訊號重複性沒有改善。</a:t>
-            </a:r>
-          </a:p>
-          <a:p>
-            <a:r>
-              <a:rPr sz="1800"/>
-              <a:t>New observation｜E201</a:t>
-            </a:r>
-          </a:p>
-          <a:p>
-            <a:r>
-              <a:rPr sz="1800"/>
-              <a:t>Therefore｜剩餘變異隨電極接觸位置改變，因此核心解釋由 bulk transport 轉向 interface contact。</a:t>
-            </a:r>
-          </a:p>
-          <a:p>
-            <a:r>
-              <a:rPr sz="1800"/>
-              <a:t>New hypothesis｜C201</a:t>
+              <a:t>Decision｜Partial-Go: Bulk conductivity is contributory but insufficient.</a:t>
+            </a:r>
+          </a:p>
+        </p:txBody>
+      </p:sp>
+      <p:sp>
+        <p:nvSpPr>
+          <p:cNvPr id="5" name="tds-slot:uncertainty"/>
+          <p:cNvSpPr txBox="1"/>
+          <p:nvPr/>
+        </p:nvSpPr>
+        <p:spPr>
+          <a:xfrm>
+            <a:off x="4389120" y="1280160"/>
+            <a:ext cx="3383280" cy="2103120"/>
+          </a:xfrm>
+          <a:prstGeom prst="rect">
+            <a:avLst/>
+          </a:prstGeom>
+          <a:noFill/>
+        </p:spPr>
+        <p:txBody>
+          <a:bodyPr wrap="none">
+            <a:spAutoFit/>
+          </a:bodyPr>
+          <a:lstStyle/>
+          <a:p>
+            <a:r>
+              <a:rPr sz="1600"/>
+              <a:t>interface contact 的貢獻尚未量化。</a:t>
+            </a:r>
+          </a:p>
+        </p:txBody>
+      </p:sp>
+      <p:sp>
+        <p:nvSpPr>
+          <p:cNvPr id="6" name="tds-slot:next_step"/>
+          <p:cNvSpPr txBox="1"/>
+          <p:nvPr/>
+        </p:nvSpPr>
+        <p:spPr>
+          <a:xfrm>
+            <a:off x="8046720" y="1280160"/>
+            <a:ext cx="3383280" cy="2103120"/>
+          </a:xfrm>
+          <a:prstGeom prst="rect">
+            <a:avLst/>
+          </a:prstGeom>
+          <a:noFill/>
+        </p:spPr>
+        <p:txBody>
+          <a:bodyPr wrap="none">
+            <a:spAutoFit/>
+          </a:bodyPr>
+          <a:lstStyle/>
+          <a:p>
+            <a:r>
+              <a:rPr sz="1600"/>
+              <a:t>Next question｜匹配 bulk conductivity 後，contact resistance 是否主導變異？</a:t>
+            </a:r>
+          </a:p>
+          <a:p>
+            <a:r>
+              <a:rPr sz="1600"/>
+              <a:t>Next Step｜NS101</a:t>
             </a:r>
           </a:p>
         </p:txBody>
@@ -5785,13 +6091,19 @@
             <p:ph type="title"/>
           </p:nvPr>
         </p:nvSpPr>
-        <p:spPr/>
-        <p:txBody>
-          <a:bodyPr/>
-          <a:lstStyle/>
-          <a:p>
-            <a:r>
-              <a:t>H002｜Hypothesis</a:t>
+        <p:spPr>
+          <a:xfrm>
+            <a:off x="502920" y="201168"/>
+            <a:ext cx="11109960" cy="960120"/>
+          </a:xfrm>
+        </p:spPr>
+        <p:txBody>
+          <a:bodyPr lIns="0" rIns="0" tIns="0" bIns="0" wrap="square"/>
+          <a:lstStyle/>
+          <a:p>
+            <a:r>
+              <a:rPr sz="3000"/>
+              <a:t>H001｜Hypothesis Transition</a:t>
             </a:r>
           </a:p>
         </p:txBody>
@@ -5815,14 +6127,14 @@
       </p:sp>
       <p:sp>
         <p:nvSpPr>
-          <p:cNvPr id="4" name="TextBox 3"/>
+          <p:cNvPr id="4" name="tds-slot:transition_nodes"/>
           <p:cNvSpPr txBox="1"/>
           <p:nvPr/>
         </p:nvSpPr>
         <p:spPr>
           <a:xfrm>
-            <a:off x="731520" y="1508760"/>
-            <a:ext cx="10698480" cy="2148840"/>
+            <a:off x="731520" y="1417320"/>
+            <a:ext cx="10744200" cy="2468880"/>
           </a:xfrm>
           <a:prstGeom prst="rect">
             <a:avLst/>
@@ -5837,19 +6149,60 @@
           <a:p>
             <a:r>
               <a:rPr sz="1800"/>
-              <a:t>Hypothesis｜Contact resistance drives instability at low pressure.</a:t>
+              <a:t>Previous hypothesis｜C101</a:t>
             </a:r>
           </a:p>
           <a:p>
             <a:r>
               <a:rPr sz="1800"/>
-              <a:t>Falsifier｜Matched conditions do not change the predicted CV or resistance.</a:t>
+              <a:t>Key results｜RES101, RES102</a:t>
             </a:r>
           </a:p>
           <a:p>
             <a:r>
               <a:rPr sz="1800"/>
-              <a:t>Research question｜低接觸壓力下，contact resistance 是否主導訊號不穩定？</a:t>
+              <a:t>New observation｜E104</a:t>
+            </a:r>
+          </a:p>
+          <a:p>
+            <a:r>
+              <a:rPr sz="1800"/>
+              <a:t>New hypothesis｜C201</a:t>
+            </a:r>
+          </a:p>
+        </p:txBody>
+      </p:sp>
+      <p:sp>
+        <p:nvSpPr>
+          <p:cNvPr id="5" name="tds-slot:derivation_strip"/>
+          <p:cNvSpPr txBox="1"/>
+          <p:nvPr/>
+        </p:nvSpPr>
+        <p:spPr>
+          <a:xfrm>
+            <a:off x="731520" y="4160520"/>
+            <a:ext cx="10744200" cy="731520"/>
+          </a:xfrm>
+          <a:prstGeom prst="rect">
+            <a:avLst/>
+          </a:prstGeom>
+          <a:noFill/>
+        </p:spPr>
+        <p:txBody>
+          <a:bodyPr wrap="none">
+            <a:spAutoFit/>
+          </a:bodyPr>
+          <a:lstStyle/>
+          <a:p>
+            <a:r>
+              <a:rPr sz="1600"/>
+              <a:t>Not explained｜導電度增加後訊號重複性沒有改善。</a:t>
+            </a:r>
+          </a:p>
+          <a:p>
+            <a:r>
+              <a:rPr sz="1600"/>
+              <a:t>Therefore｜剩餘變異隨電極接觸位置改變，因此核心解釋由 bulk transport 轉向 interface contact。</a:t>
             </a:r>
           </a:p>
         </p:txBody>
@@ -5882,13 +6235,19 @@
             <p:ph type="title"/>
           </p:nvPr>
         </p:nvSpPr>
-        <p:spPr/>
-        <p:txBody>
-          <a:bodyPr/>
-          <a:lstStyle/>
-          <a:p>
-            <a:r>
-              <a:t>H002｜Problem</a:t>
+        <p:spPr>
+          <a:xfrm>
+            <a:off x="502920" y="201168"/>
+            <a:ext cx="11109960" cy="960120"/>
+          </a:xfrm>
+        </p:spPr>
+        <p:txBody>
+          <a:bodyPr lIns="0" rIns="0" tIns="0" bIns="0" wrap="square"/>
+          <a:lstStyle/>
+          <a:p>
+            <a:r>
+              <a:rPr sz="3000"/>
+              <a:t>H002｜Hypothesis</a:t>
             </a:r>
           </a:p>
         </p:txBody>
@@ -5912,14 +6271,14 @@
       </p:sp>
       <p:sp>
         <p:nvSpPr>
-          <p:cNvPr id="4" name="TextBox 3"/>
+          <p:cNvPr id="4" name="tds-slot:hypothesis_statement"/>
           <p:cNvSpPr txBox="1"/>
           <p:nvPr/>
         </p:nvSpPr>
         <p:spPr>
           <a:xfrm>
-            <a:off x="8046720" y="1325880"/>
-            <a:ext cx="3383280" cy="1600200"/>
+            <a:off x="731520" y="1508760"/>
+            <a:ext cx="10698480" cy="2148840"/>
           </a:xfrm>
           <a:prstGeom prst="rect">
             <a:avLst/>
@@ -5933,32 +6292,20 @@
           <a:lstStyle/>
           <a:p>
             <a:r>
-              <a:rPr sz="1800"/>
-              <a:t>Problem｜導電度改善後重複性仍未改善，剩餘變異與電極接觸位置相關。</a:t>
-            </a:r>
-          </a:p>
-          <a:p>
-            <a:r>
-              <a:rPr sz="1800"/>
-              <a:t>Previous finding｜H01 支持導電度梯度存在; H01 未支持導電度單獨主導重複性</a:t>
-            </a:r>
-          </a:p>
-          <a:p>
-            <a:r>
-              <a:rPr sz="1800"/>
-              <a:t>Conflict｜bulk transport 與 interface contact 的相對貢獻尚未區分。</a:t>
-            </a:r>
-          </a:p>
-          <a:p>
-            <a:r>
-              <a:rPr sz="1800"/>
+              <a:rPr sz="2800"/>
+              <a:t>Hypothesis｜Contact resistance drives instability at low pressure.</a:t>
+            </a:r>
+          </a:p>
+          <a:p>
+            <a:r>
+              <a:rPr sz="2800"/>
+              <a:t>Falsifier｜Matched conditions do not change the predicted CV or resistance.</a:t>
+            </a:r>
+          </a:p>
+          <a:p>
+            <a:r>
+              <a:rPr sz="2800"/>
               <a:t>Research question｜低接觸壓力下，contact resistance 是否主導訊號不穩定？</a:t>
-            </a:r>
-          </a:p>
-          <a:p>
-            <a:r>
-              <a:rPr sz="1800"/>
-              <a:t>Scope｜匹配 bulk conductivity，改變 contact pressure 的對照實驗。</a:t>
             </a:r>
           </a:p>
         </p:txBody>
@@ -5991,13 +6338,19 @@
             <p:ph type="title"/>
           </p:nvPr>
         </p:nvSpPr>
-        <p:spPr/>
-        <p:txBody>
-          <a:bodyPr/>
-          <a:lstStyle/>
-          <a:p>
-            <a:r>
-              <a:t>H002｜Total Fishbone / Research Map</a:t>
+        <p:spPr>
+          <a:xfrm>
+            <a:off x="502920" y="201168"/>
+            <a:ext cx="11109960" cy="960120"/>
+          </a:xfrm>
+        </p:spPr>
+        <p:txBody>
+          <a:bodyPr lIns="0" rIns="0" tIns="0" bIns="0" wrap="square"/>
+          <a:lstStyle/>
+          <a:p>
+            <a:r>
+              <a:rPr sz="3000"/>
+              <a:t>H002｜Problem</a:t>
             </a:r>
           </a:p>
         </p:txBody>
@@ -6021,14 +6374,14 @@
       </p:sp>
       <p:sp>
         <p:nvSpPr>
-          <p:cNvPr id="4" name="TextBox 3"/>
+          <p:cNvPr id="4" name="tds-slot:previous_finding"/>
           <p:cNvSpPr txBox="1"/>
           <p:nvPr/>
         </p:nvSpPr>
         <p:spPr>
           <a:xfrm>
-            <a:off x="731520" y="1508760"/>
-            <a:ext cx="2743200" cy="1280160"/>
+            <a:off x="731520" y="1325880"/>
+            <a:ext cx="3383280" cy="1600200"/>
           </a:xfrm>
           <a:prstGeom prst="rect">
             <a:avLst/>
@@ -6043,47 +6396,69 @@
           <a:p>
             <a:r>
               <a:rPr sz="1800"/>
-              <a:t>Historical snapshot｜FB001 rev2</a:t>
-            </a:r>
-          </a:p>
-          <a:p>
-            <a:r>
-              <a:rPr sz="1800"/>
-              <a:t>Focus branch｜FB-ELECTRODE-CONTACT</a:t>
-            </a:r>
-          </a:p>
-          <a:p>
-            <a:r>
-              <a:rPr sz="1800"/>
-              <a:t>Immutable map; current branch highlighted.</a:t>
-            </a:r>
-          </a:p>
-        </p:txBody>
-      </p:sp>
-      <p:pic>
-        <p:nvPicPr>
-          <p:cNvPr id="5" name="Picture 4" descr="FB001-rev2.png"/>
-          <p:cNvPicPr>
-            <a:picLocks noChangeAspect="1"/>
-          </p:cNvPicPr>
+              <a:t>H01 支持導電度梯度存在; H01 未支持導電度單獨主導重複性</a:t>
+            </a:r>
+          </a:p>
+        </p:txBody>
+      </p:sp>
+      <p:sp>
+        <p:nvSpPr>
+          <p:cNvPr id="5" name="tds-slot:unresolved_conflict"/>
+          <p:cNvSpPr txBox="1"/>
           <p:nvPr/>
-        </p:nvPicPr>
-        <p:blipFill>
-          <a:blip r:embed="rId2"/>
-          <a:stretch>
-            <a:fillRect/>
-          </a:stretch>
-        </p:blipFill>
-        <p:spPr>
-          <a:xfrm>
-            <a:off x="3886200" y="1234440"/>
-            <a:ext cx="7635240" cy="4480560"/>
+        </p:nvSpPr>
+        <p:spPr>
+          <a:xfrm>
+            <a:off x="4389120" y="1325880"/>
+            <a:ext cx="3383280" cy="1600200"/>
           </a:xfrm>
           <a:prstGeom prst="rect">
             <a:avLst/>
           </a:prstGeom>
-        </p:spPr>
-      </p:pic>
+          <a:noFill/>
+        </p:spPr>
+        <p:txBody>
+          <a:bodyPr wrap="none">
+            <a:spAutoFit/>
+          </a:bodyPr>
+          <a:lstStyle/>
+          <a:p>
+            <a:r>
+              <a:rPr sz="1800"/>
+              <a:t>bulk transport 與 interface contact 的相對貢獻尚未區分。</a:t>
+            </a:r>
+          </a:p>
+        </p:txBody>
+      </p:sp>
+      <p:sp>
+        <p:nvSpPr>
+          <p:cNvPr id="6" name="tds-slot:research_question"/>
+          <p:cNvSpPr txBox="1"/>
+          <p:nvPr/>
+        </p:nvSpPr>
+        <p:spPr>
+          <a:xfrm>
+            <a:off x="8046720" y="1325880"/>
+            <a:ext cx="3383280" cy="1600200"/>
+          </a:xfrm>
+          <a:prstGeom prst="rect">
+            <a:avLst/>
+          </a:prstGeom>
+          <a:noFill/>
+        </p:spPr>
+        <p:txBody>
+          <a:bodyPr wrap="none">
+            <a:spAutoFit/>
+          </a:bodyPr>
+          <a:lstStyle/>
+          <a:p>
+            <a:r>
+              <a:rPr sz="2000"/>
+              <a:t>低接觸壓力下，contact resistance 是否主導訊號不穩定？</a:t>
+            </a:r>
+          </a:p>
+        </p:txBody>
+      </p:sp>
     </p:spTree>
   </p:cSld>
   <p:clrMapOvr>
@@ -6112,13 +6487,19 @@
             <p:ph type="title"/>
           </p:nvPr>
         </p:nvSpPr>
-        <p:spPr/>
-        <p:txBody>
-          <a:bodyPr/>
-          <a:lstStyle/>
-          <a:p>
-            <a:r>
-              <a:t>H002｜Observation → Literature → Mechanism</a:t>
+        <p:spPr>
+          <a:xfrm>
+            <a:off x="502920" y="201168"/>
+            <a:ext cx="11109960" cy="960120"/>
+          </a:xfrm>
+        </p:spPr>
+        <p:txBody>
+          <a:bodyPr lIns="0" rIns="0" tIns="0" bIns="0" wrap="square"/>
+          <a:lstStyle/>
+          <a:p>
+            <a:r>
+              <a:rPr sz="2400"/>
+              <a:t>H002｜Total Fishbone / Research Map</a:t>
             </a:r>
           </a:p>
         </p:txBody>
@@ -6140,16 +6521,40 @@
           <a:p/>
         </p:txBody>
       </p:sp>
-      <p:sp>
-        <p:nvSpPr>
-          <p:cNvPr id="4" name="TextBox 3"/>
+      <p:pic>
+        <p:nvPicPr>
+          <p:cNvPr id="4" name="tds-slot:primary_figure" descr="FB001-rev2.png"/>
+          <p:cNvPicPr>
+            <a:picLocks noChangeAspect="1"/>
+          </p:cNvPicPr>
+          <p:nvPr/>
+        </p:nvPicPr>
+        <p:blipFill>
+          <a:blip r:embed="rId2"/>
+          <a:stretch>
+            <a:fillRect/>
+          </a:stretch>
+        </p:blipFill>
+        <p:spPr>
+          <a:xfrm>
+            <a:off x="3886200" y="1234440"/>
+            <a:ext cx="7635240" cy="4480560"/>
+          </a:xfrm>
+          <a:prstGeom prst="rect">
+            <a:avLst/>
+          </a:prstGeom>
+        </p:spPr>
+      </p:pic>
+      <p:sp>
+        <p:nvSpPr>
+          <p:cNvPr id="5" name="tds-slot:fishbone_focus"/>
           <p:cNvSpPr txBox="1"/>
           <p:nvPr/>
         </p:nvSpPr>
         <p:spPr>
           <a:xfrm>
-            <a:off x="731520" y="2331720"/>
-            <a:ext cx="5669280" cy="2423160"/>
+            <a:off x="731520" y="1508760"/>
+            <a:ext cx="2743200" cy="1280160"/>
           </a:xfrm>
           <a:prstGeom prst="rect">
             <a:avLst/>
@@ -6163,56 +6568,8 @@
           <a:lstStyle/>
           <a:p>
             <a:r>
-              <a:rPr sz="1800"/>
-              <a:t>Observation｜位置依賴缺陷與訊號變異已觀察到。</a:t>
-            </a:r>
-          </a:p>
-          <a:p>
-            <a:r>
-              <a:rPr sz="1800"/>
-              <a:t>Problem｜現有模型無法解釋此變異。</a:t>
-            </a:r>
-          </a:p>
-          <a:p>
-            <a:r>
-              <a:rPr sz="1800"/>
-              <a:t>Research question｜低接觸壓力下，contact resistance 是否主導訊號不穩定？</a:t>
-            </a:r>
-          </a:p>
-          <a:p>
-            <a:r>
-              <a:rPr sz="1800"/>
-              <a:t>Literature consensus｜transport gradient 可產生位置效應。</a:t>
-            </a:r>
-          </a:p>
-          <a:p>
-            <a:r>
-              <a:rPr sz="1800"/>
-              <a:t>Alternatives｜interface contact remains alternative</a:t>
-            </a:r>
-          </a:p>
-          <a:p>
-            <a:r>
-              <a:rPr sz="1800"/>
-              <a:t>Gap｜缺少控制比較隔離機制。</a:t>
-            </a:r>
-          </a:p>
-          <a:p>
-            <a:r>
-              <a:rPr sz="1800"/>
-              <a:t>Implication｜需匹配條件後比較。</a:t>
-            </a:r>
-          </a:p>
-          <a:p>
-            <a:r>
-              <a:rPr sz="1800"/>
-              <a:t>Mechanism｜contact resistance</a:t>
-            </a:r>
-          </a:p>
-          <a:p>
-            <a:r>
-              <a:rPr sz="1800"/>
-              <a:t>Strategy｜匹配導電度並改變接觸壓力</a:t>
+              <a:rPr sz="1600"/>
+              <a:t>FB-ELECTRODE-CONTACT</a:t>
             </a:r>
           </a:p>
         </p:txBody>
@@ -6245,13 +6602,19 @@
             <p:ph type="title"/>
           </p:nvPr>
         </p:nvSpPr>
-        <p:spPr/>
-        <p:txBody>
-          <a:bodyPr/>
-          <a:lstStyle/>
-          <a:p>
-            <a:r>
-              <a:t>H002｜Results</a:t>
+        <p:spPr>
+          <a:xfrm>
+            <a:off x="502920" y="201168"/>
+            <a:ext cx="11109960" cy="960120"/>
+          </a:xfrm>
+        </p:spPr>
+        <p:txBody>
+          <a:bodyPr lIns="0" rIns="0" tIns="0" bIns="0" wrap="square"/>
+          <a:lstStyle/>
+          <a:p>
+            <a:r>
+              <a:rPr sz="2400"/>
+              <a:t>H002｜Observation → Literature → Mechanism</a:t>
             </a:r>
           </a:p>
         </p:txBody>
@@ -6275,14 +6638,14 @@
       </p:sp>
       <p:sp>
         <p:nvSpPr>
-          <p:cNvPr id="4" name="TextBox 3"/>
+          <p:cNvPr id="4" name="tds-slot:primary_figure"/>
           <p:cNvSpPr txBox="1"/>
           <p:nvPr/>
         </p:nvSpPr>
         <p:spPr>
           <a:xfrm>
-            <a:off x="731520" y="1325880"/>
-            <a:ext cx="5257800" cy="3840480"/>
+            <a:off x="6903720" y="1280160"/>
+            <a:ext cx="4572000" cy="3474720"/>
           </a:xfrm>
           <a:prstGeom prst="rect">
             <a:avLst/>
@@ -6296,42 +6659,76 @@
           <a:lstStyle/>
           <a:p>
             <a:r>
-              <a:rPr sz="1800"/>
-              <a:t>EXP201｜</a:t>
-            </a:r>
-          </a:p>
-          <a:p>
-            <a:r>
-              <a:rPr sz="1800"/>
-              <a:t>RES201｜高壓條件 CV 下降 38% ± 7% SD，contact resistance 同步下降</a:t>
-            </a:r>
-          </a:p>
-        </p:txBody>
-      </p:sp>
-      <p:pic>
-        <p:nvPicPr>
-          <p:cNvPr id="5" name="Picture 4" descr="H02_contact_pressure.png"/>
-          <p:cNvPicPr>
-            <a:picLocks noChangeAspect="1"/>
-          </p:cNvPicPr>
+              <a:rPr sz="1600"/>
+              <a:t>Registered observation visual.</a:t>
+            </a:r>
+          </a:p>
+        </p:txBody>
+      </p:sp>
+      <p:sp>
+        <p:nvSpPr>
+          <p:cNvPr id="5" name="tds-slot:research_question"/>
+          <p:cNvSpPr txBox="1"/>
           <p:nvPr/>
-        </p:nvPicPr>
-        <p:blipFill>
-          <a:blip r:embed="rId2"/>
-          <a:stretch>
-            <a:fillRect/>
-          </a:stretch>
-        </p:blipFill>
-        <p:spPr>
-          <a:xfrm>
-            <a:off x="6217920" y="1325880"/>
-            <a:ext cx="5257800" cy="3840480"/>
+        </p:nvSpPr>
+        <p:spPr>
+          <a:xfrm>
+            <a:off x="731520" y="1325880"/>
+            <a:ext cx="5669280" cy="822960"/>
           </a:xfrm>
           <a:prstGeom prst="rect">
             <a:avLst/>
           </a:prstGeom>
-        </p:spPr>
-      </p:pic>
+          <a:noFill/>
+        </p:spPr>
+        <p:txBody>
+          <a:bodyPr wrap="none">
+            <a:spAutoFit/>
+          </a:bodyPr>
+          <a:lstStyle/>
+          <a:p>
+            <a:r>
+              <a:rPr sz="2000"/>
+              <a:t>低接觸壓力下，contact resistance 是否主導訊號不穩定？</a:t>
+            </a:r>
+          </a:p>
+        </p:txBody>
+      </p:sp>
+      <p:sp>
+        <p:nvSpPr>
+          <p:cNvPr id="6" name="tds-slot:observation_text"/>
+          <p:cNvSpPr txBox="1"/>
+          <p:nvPr/>
+        </p:nvSpPr>
+        <p:spPr>
+          <a:xfrm>
+            <a:off x="731520" y="2331720"/>
+            <a:ext cx="5669280" cy="2423160"/>
+          </a:xfrm>
+          <a:prstGeom prst="rect">
+            <a:avLst/>
+          </a:prstGeom>
+          <a:noFill/>
+        </p:spPr>
+        <p:txBody>
+          <a:bodyPr wrap="none">
+            <a:spAutoFit/>
+          </a:bodyPr>
+          <a:lstStyle/>
+          <a:p>
+            <a:r>
+              <a:rPr sz="1600"/>
+              <a:t>Observation｜位置依賴缺陷與訊號變異已觀察到。</a:t>
+            </a:r>
+          </a:p>
+          <a:p>
+            <a:r>
+              <a:rPr sz="1600"/>
+              <a:t>Problem｜現有模型無法解釋此變異。</a:t>
+            </a:r>
+          </a:p>
+        </p:txBody>
+      </p:sp>
     </p:spTree>
   </p:cSld>
   <p:clrMapOvr>
@@ -6420,13 +6817,19 @@
             <p:ph type="title"/>
           </p:nvPr>
         </p:nvSpPr>
-        <p:spPr/>
-        <p:txBody>
-          <a:bodyPr/>
-          <a:lstStyle/>
-          <a:p>
-            <a:r>
-              <a:t>H002｜Layer Summary / Decision</a:t>
+        <p:spPr>
+          <a:xfrm>
+            <a:off x="502920" y="201168"/>
+            <a:ext cx="11109960" cy="960120"/>
+          </a:xfrm>
+        </p:spPr>
+        <p:txBody>
+          <a:bodyPr lIns="0" rIns="0" tIns="0" bIns="0" wrap="square"/>
+          <a:lstStyle/>
+          <a:p>
+            <a:r>
+              <a:rPr sz="3000"/>
+              <a:t>H002｜Results</a:t>
             </a:r>
           </a:p>
         </p:txBody>
@@ -6450,14 +6853,14 @@
       </p:sp>
       <p:sp>
         <p:nvSpPr>
-          <p:cNvPr id="4" name="TextBox 3"/>
+          <p:cNvPr id="4" name="tds-slot:control_panel"/>
           <p:cNvSpPr txBox="1"/>
           <p:nvPr/>
         </p:nvSpPr>
         <p:spPr>
           <a:xfrm>
-            <a:off x="731520" y="1280160"/>
-            <a:ext cx="3383280" cy="2103120"/>
+            <a:off x="731520" y="1325880"/>
+            <a:ext cx="5257800" cy="3840480"/>
           </a:xfrm>
           <a:prstGeom prst="rect">
             <a:avLst/>
@@ -6471,6 +6874,121 @@
           <a:lstStyle/>
           <a:p>
             <a:r>
+              <a:rPr sz="1600"/>
+              <a:t>Control｜low-pressure control</a:t>
+            </a:r>
+          </a:p>
+        </p:txBody>
+      </p:sp>
+      <p:pic>
+        <p:nvPicPr>
+          <p:cNvPr id="5" name="tds-slot:proposed_panel" descr="H02_contact_pressure.png"/>
+          <p:cNvPicPr>
+            <a:picLocks noChangeAspect="1"/>
+          </p:cNvPicPr>
+          <p:nvPr/>
+        </p:nvPicPr>
+        <p:blipFill>
+          <a:blip r:embed="rId2"/>
+          <a:stretch>
+            <a:fillRect/>
+          </a:stretch>
+        </p:blipFill>
+        <p:spPr>
+          <a:xfrm>
+            <a:off x="6217920" y="1325880"/>
+            <a:ext cx="5257800" cy="3840480"/>
+          </a:xfrm>
+          <a:prstGeom prst="rect">
+            <a:avLst/>
+          </a:prstGeom>
+        </p:spPr>
+      </p:pic>
+    </p:spTree>
+  </p:cSld>
+  <p:clrMapOvr>
+    <a:masterClrMapping/>
+  </p:clrMapOvr>
+</p:sld>
+</file>
+
+<file path=ppt/slides/slide21.xml><?xml version="1.0" encoding="utf-8"?>
+<p:sld xmlns:a="http://schemas.openxmlformats.org/drawingml/2006/main" xmlns:p="http://schemas.openxmlformats.org/presentationml/2006/main" xmlns:r="http://schemas.openxmlformats.org/officeDocument/2006/relationships">
+  <p:cSld>
+    <p:spTree>
+      <p:nvGrpSpPr>
+        <p:cNvPr id="1" name=""/>
+        <p:cNvGrpSpPr/>
+        <p:nvPr/>
+      </p:nvGrpSpPr>
+      <p:grpSpPr/>
+      <p:sp>
+        <p:nvSpPr>
+          <p:cNvPr id="2" name="Title 1"/>
+          <p:cNvSpPr>
+            <a:spLocks noGrp="1"/>
+          </p:cNvSpPr>
+          <p:nvPr>
+            <p:ph type="title"/>
+          </p:nvPr>
+        </p:nvSpPr>
+        <p:spPr>
+          <a:xfrm>
+            <a:off x="502920" y="201168"/>
+            <a:ext cx="11109960" cy="960120"/>
+          </a:xfrm>
+        </p:spPr>
+        <p:txBody>
+          <a:bodyPr lIns="0" rIns="0" tIns="0" bIns="0" wrap="square"/>
+          <a:lstStyle/>
+          <a:p>
+            <a:r>
+              <a:rPr sz="3000"/>
+              <a:t>H002｜Layer Summary / Decision</a:t>
+            </a:r>
+          </a:p>
+        </p:txBody>
+      </p:sp>
+      <p:sp>
+        <p:nvSpPr>
+          <p:cNvPr id="3" name="Content Placeholder 2"/>
+          <p:cNvSpPr>
+            <a:spLocks noGrp="1"/>
+          </p:cNvSpPr>
+          <p:nvPr>
+            <p:ph idx="1"/>
+          </p:nvPr>
+        </p:nvSpPr>
+        <p:spPr/>
+        <p:txBody>
+          <a:bodyPr/>
+          <a:lstStyle/>
+          <a:p/>
+        </p:txBody>
+      </p:sp>
+      <p:sp>
+        <p:nvSpPr>
+          <p:cNvPr id="4" name="tds-slot:decision_status"/>
+          <p:cNvSpPr txBox="1"/>
+          <p:nvPr/>
+        </p:nvSpPr>
+        <p:spPr>
+          <a:xfrm>
+            <a:off x="731520" y="1280160"/>
+            <a:ext cx="3383280" cy="2103120"/>
+          </a:xfrm>
+          <a:prstGeom prst="rect">
+            <a:avLst/>
+          </a:prstGeom>
+          <a:noFill/>
+        </p:spPr>
+        <p:txBody>
+          <a:bodyPr wrap="none">
+            <a:spAutoFit/>
+          </a:bodyPr>
+          <a:lstStyle/>
+          <a:p>
+            <a:r>
               <a:rPr sz="1800"/>
               <a:t>Answered｜低接觸壓力下 contact resistance 是主導不穩定來源。</a:t>
             </a:r>
@@ -6487,21 +7005,67 @@
               <a:t>Decision｜Go: Contact-pressure control discriminates the interface mechanism.</a:t>
             </a:r>
           </a:p>
-          <a:p>
-            <a:r>
-              <a:rPr sz="1800"/>
-              <a:t>Unresolved｜高壓循環的耐久性與 wear 尚未測試。</a:t>
-            </a:r>
-          </a:p>
-          <a:p>
-            <a:r>
-              <a:rPr sz="1800"/>
+        </p:txBody>
+      </p:sp>
+      <p:sp>
+        <p:nvSpPr>
+          <p:cNvPr id="5" name="tds-slot:uncertainty"/>
+          <p:cNvSpPr txBox="1"/>
+          <p:nvPr/>
+        </p:nvSpPr>
+        <p:spPr>
+          <a:xfrm>
+            <a:off x="4389120" y="1280160"/>
+            <a:ext cx="3383280" cy="2103120"/>
+          </a:xfrm>
+          <a:prstGeom prst="rect">
+            <a:avLst/>
+          </a:prstGeom>
+          <a:noFill/>
+        </p:spPr>
+        <p:txBody>
+          <a:bodyPr wrap="none">
+            <a:spAutoFit/>
+          </a:bodyPr>
+          <a:lstStyle/>
+          <a:p>
+            <a:r>
+              <a:rPr sz="1600"/>
+              <a:t>高壓循環的耐久性與 wear 尚未測試。</a:t>
+            </a:r>
+          </a:p>
+        </p:txBody>
+      </p:sp>
+      <p:sp>
+        <p:nvSpPr>
+          <p:cNvPr id="6" name="tds-slot:next_step"/>
+          <p:cNvSpPr txBox="1"/>
+          <p:nvPr/>
+        </p:nvSpPr>
+        <p:spPr>
+          <a:xfrm>
+            <a:off x="8046720" y="1280160"/>
+            <a:ext cx="3383280" cy="2103120"/>
+          </a:xfrm>
+          <a:prstGeom prst="rect">
+            <a:avLst/>
+          </a:prstGeom>
+          <a:noFill/>
+        </p:spPr>
+        <p:txBody>
+          <a:bodyPr wrap="none">
+            <a:spAutoFit/>
+          </a:bodyPr>
+          <a:lstStyle/>
+          <a:p>
+            <a:r>
+              <a:rPr sz="1600"/>
               <a:t>Next question｜接觸壓力改善能否在長期循環下維持？</a:t>
             </a:r>
           </a:p>
           <a:p>
             <a:r>
-              <a:rPr sz="1800"/>
+              <a:rPr sz="1600"/>
               <a:t>Next Step｜NS201</a:t>
             </a:r>
           </a:p>
@@ -6535,12 +7099,18 @@
             <p:ph type="title"/>
           </p:nvPr>
         </p:nvSpPr>
-        <p:spPr/>
-        <p:txBody>
-          <a:bodyPr/>
-          <a:lstStyle/>
-          <a:p>
-            <a:r>
+        <p:spPr>
+          <a:xfrm>
+            <a:off x="502920" y="201168"/>
+            <a:ext cx="11109960" cy="960120"/>
+          </a:xfrm>
+        </p:spPr>
+        <p:txBody>
+          <a:bodyPr lIns="0" rIns="0" tIns="0" bIns="0" wrap="square"/>
+          <a:lstStyle/>
+          <a:p>
+            <a:r>
+              <a:rPr sz="2400"/>
               <a:t>Progress / Previous Commitments</a:t>
             </a:r>
           </a:p>
@@ -6565,7 +7135,7 @@
       </p:sp>
       <p:sp>
         <p:nvSpPr>
-          <p:cNvPr id="4" name="TextBox 3"/>
+          <p:cNvPr id="4" name="tds-slot:commitment_table"/>
           <p:cNvSpPr txBox="1"/>
           <p:nvPr/>
         </p:nvSpPr>
@@ -6586,31 +7156,77 @@
           <a:lstStyle/>
           <a:p>
             <a:r>
-              <a:rPr sz="1800"/>
-              <a:t>Current position｜H002</a:t>
-            </a:r>
-          </a:p>
-          <a:p>
-            <a:r>
-              <a:rPr sz="1800"/>
+              <a:rPr sz="1600"/>
               <a:t>Commitment｜NS101｜done｜Owner: Gary｜Due: 2026-09-10T09:00:00Z</a:t>
             </a:r>
           </a:p>
           <a:p>
             <a:r>
-              <a:rPr sz="1800"/>
+              <a:rPr sz="1600"/>
+              <a:t>Commitment｜NS201｜planned｜Owner: Gary｜Due: 2026-09-24T00:00:00Z</a:t>
+            </a:r>
+          </a:p>
+        </p:txBody>
+      </p:sp>
+      <p:sp>
+        <p:nvSpPr>
+          <p:cNvPr id="5" name="tds-slot:current_position"/>
+          <p:cNvSpPr txBox="1"/>
+          <p:nvPr/>
+        </p:nvSpPr>
+        <p:spPr>
+          <a:xfrm>
+            <a:off x="7452360" y="1325880"/>
+            <a:ext cx="4023360" cy="1554480"/>
+          </a:xfrm>
+          <a:prstGeom prst="rect">
+            <a:avLst/>
+          </a:prstGeom>
+          <a:noFill/>
+        </p:spPr>
+        <p:txBody>
+          <a:bodyPr wrap="none">
+            <a:spAutoFit/>
+          </a:bodyPr>
+          <a:lstStyle/>
+          <a:p>
+            <a:r>
+              <a:rPr sz="1600"/>
+              <a:t>H002</a:t>
+            </a:r>
+          </a:p>
+        </p:txBody>
+      </p:sp>
+      <p:sp>
+        <p:nvSpPr>
+          <p:cNvPr id="6" name="tds-slot:parallel_work"/>
+          <p:cNvSpPr txBox="1"/>
+          <p:nvPr/>
+        </p:nvSpPr>
+        <p:spPr>
+          <a:xfrm>
+            <a:off x="7452360" y="3154680"/>
+            <a:ext cx="4023360" cy="1600200"/>
+          </a:xfrm>
+          <a:prstGeom prst="rect">
+            <a:avLst/>
+          </a:prstGeom>
+          <a:noFill/>
+        </p:spPr>
+        <p:txBody>
+          <a:bodyPr wrap="none">
+            <a:spAutoFit/>
+          </a:bodyPr>
+          <a:lstStyle/>
+          <a:p>
+            <a:r>
+              <a:rPr sz="1600"/>
               <a:t>Dependencies｜pressure fixture｜Parallel: True</a:t>
             </a:r>
           </a:p>
           <a:p>
             <a:r>
-              <a:rPr sz="1800"/>
-              <a:t>Commitment｜NS201｜planned｜Owner: Gary｜Due: 2026-09-24T00:00:00Z</a:t>
-            </a:r>
-          </a:p>
-          <a:p>
-            <a:r>
-              <a:rPr sz="1800"/>
+              <a:rPr sz="1600"/>
               <a:t>Dependencies｜pressure fixture｜Parallel: True</a:t>
             </a:r>
           </a:p>
@@ -6644,12 +7260,18 @@
             <p:ph type="title"/>
           </p:nvPr>
         </p:nvSpPr>
-        <p:spPr/>
-        <p:txBody>
-          <a:bodyPr/>
-          <a:lstStyle/>
-          <a:p>
-            <a:r>
+        <p:spPr>
+          <a:xfrm>
+            <a:off x="502920" y="201168"/>
+            <a:ext cx="11109960" cy="960120"/>
+          </a:xfrm>
+        </p:spPr>
+        <p:txBody>
+          <a:bodyPr lIns="0" rIns="0" tIns="0" bIns="0" wrap="square"/>
+          <a:lstStyle/>
+          <a:p>
+            <a:r>
+              <a:rPr sz="3000"/>
               <a:t>H001｜Hypothesis</a:t>
             </a:r>
           </a:p>
@@ -6674,7 +7296,7 @@
       </p:sp>
       <p:sp>
         <p:nvSpPr>
-          <p:cNvPr id="4" name="TextBox 3"/>
+          <p:cNvPr id="4" name="tds-slot:hypothesis_statement"/>
           <p:cNvSpPr txBox="1"/>
           <p:nvPr/>
         </p:nvSpPr>
@@ -6695,19 +7317,19 @@
           <a:lstStyle/>
           <a:p>
             <a:r>
-              <a:rPr sz="1800"/>
+              <a:rPr sz="2800"/>
               <a:t>Hypothesis｜Bulk conductivity drives the positional signal gradient.</a:t>
             </a:r>
           </a:p>
           <a:p>
             <a:r>
-              <a:rPr sz="1800"/>
+              <a:rPr sz="2800"/>
               <a:t>Falsifier｜Matched conditions do not change the predicted CV or resistance.</a:t>
             </a:r>
           </a:p>
           <a:p>
             <a:r>
-              <a:rPr sz="1800"/>
+              <a:rPr sz="2800"/>
               <a:t>Research question｜提升 bulk conductivity 是否足以降低位置依賴的訊號變異？</a:t>
             </a:r>
           </a:p>
@@ -6741,12 +7363,18 @@
             <p:ph type="title"/>
           </p:nvPr>
         </p:nvSpPr>
-        <p:spPr/>
-        <p:txBody>
-          <a:bodyPr/>
-          <a:lstStyle/>
-          <a:p>
-            <a:r>
+        <p:spPr>
+          <a:xfrm>
+            <a:off x="502920" y="201168"/>
+            <a:ext cx="11109960" cy="960120"/>
+          </a:xfrm>
+        </p:spPr>
+        <p:txBody>
+          <a:bodyPr lIns="0" rIns="0" tIns="0" bIns="0" wrap="square"/>
+          <a:lstStyle/>
+          <a:p>
+            <a:r>
+              <a:rPr sz="3000"/>
               <a:t>H001｜Problem</a:t>
             </a:r>
           </a:p>
@@ -6771,13 +7399,13 @@
       </p:sp>
       <p:sp>
         <p:nvSpPr>
-          <p:cNvPr id="4" name="TextBox 3"/>
+          <p:cNvPr id="4" name="tds-slot:previous_finding"/>
           <p:cNvSpPr txBox="1"/>
           <p:nvPr/>
         </p:nvSpPr>
         <p:spPr>
           <a:xfrm>
-            <a:off x="8046720" y="1325880"/>
+            <a:off x="731520" y="1325880"/>
             <a:ext cx="3383280" cy="1600200"/>
           </a:xfrm>
           <a:prstGeom prst="rect">
@@ -6793,31 +7421,65 @@
           <a:p>
             <a:r>
               <a:rPr sz="1800"/>
-              <a:t>Problem｜合成薄膜的缺陷密度沿位置增加，且訊號重複性下降。</a:t>
-            </a:r>
-          </a:p>
+              <a:t>含水量與導電度存在位置梯度</a:t>
+            </a:r>
+          </a:p>
+        </p:txBody>
+      </p:sp>
+      <p:sp>
+        <p:nvSpPr>
+          <p:cNvPr id="5" name="tds-slot:unresolved_conflict"/>
+          <p:cNvSpPr txBox="1"/>
+          <p:nvPr/>
+        </p:nvSpPr>
+        <p:spPr>
+          <a:xfrm>
+            <a:off x="4389120" y="1325880"/>
+            <a:ext cx="3383280" cy="1600200"/>
+          </a:xfrm>
+          <a:prstGeom prst="rect">
+            <a:avLst/>
+          </a:prstGeom>
+          <a:noFill/>
+        </p:spPr>
+        <p:txBody>
+          <a:bodyPr wrap="none">
+            <a:spAutoFit/>
+          </a:bodyPr>
+          <a:lstStyle/>
           <a:p>
             <a:r>
               <a:rPr sz="1800"/>
-              <a:t>Previous finding｜含水量與導電度存在位置梯度</a:t>
-            </a:r>
-          </a:p>
-          <a:p>
-            <a:r>
-              <a:rPr sz="1800"/>
-              <a:t>Conflict｜導電度提高是否足以修復重複性仍未知。</a:t>
-            </a:r>
-          </a:p>
-          <a:p>
-            <a:r>
-              <a:rPr sz="1800"/>
-              <a:t>Research question｜提升 bulk conductivity 是否足以降低位置依賴的訊號變異？</a:t>
-            </a:r>
-          </a:p>
-          <a:p>
-            <a:r>
-              <a:rPr sz="1800"/>
-              <a:t>Scope｜合成五個位置、每個位置三個 replicate 的機制辨識。</a:t>
+              <a:t>導電度提高是否足以修復重複性仍未知。</a:t>
+            </a:r>
+          </a:p>
+        </p:txBody>
+      </p:sp>
+      <p:sp>
+        <p:nvSpPr>
+          <p:cNvPr id="6" name="tds-slot:research_question"/>
+          <p:cNvSpPr txBox="1"/>
+          <p:nvPr/>
+        </p:nvSpPr>
+        <p:spPr>
+          <a:xfrm>
+            <a:off x="8046720" y="1325880"/>
+            <a:ext cx="3383280" cy="1600200"/>
+          </a:xfrm>
+          <a:prstGeom prst="rect">
+            <a:avLst/>
+          </a:prstGeom>
+          <a:noFill/>
+        </p:spPr>
+        <p:txBody>
+          <a:bodyPr wrap="none">
+            <a:spAutoFit/>
+          </a:bodyPr>
+          <a:lstStyle/>
+          <a:p>
+            <a:r>
+              <a:rPr sz="2000"/>
+              <a:t>提升 bulk conductivity 是否足以降低位置依賴的訊號變異？</a:t>
             </a:r>
           </a:p>
         </p:txBody>
@@ -6850,12 +7512,18 @@
             <p:ph type="title"/>
           </p:nvPr>
         </p:nvSpPr>
-        <p:spPr/>
-        <p:txBody>
-          <a:bodyPr/>
-          <a:lstStyle/>
-          <a:p>
-            <a:r>
+        <p:spPr>
+          <a:xfrm>
+            <a:off x="502920" y="201168"/>
+            <a:ext cx="11109960" cy="960120"/>
+          </a:xfrm>
+        </p:spPr>
+        <p:txBody>
+          <a:bodyPr lIns="0" rIns="0" tIns="0" bIns="0" wrap="square"/>
+          <a:lstStyle/>
+          <a:p>
+            <a:r>
+              <a:rPr sz="2400"/>
               <a:t>H001｜Total Fishbone / Research Map</a:t>
             </a:r>
           </a:p>
@@ -6876,52 +7544,11 @@
           <a:bodyPr/>
           <a:lstStyle/>
           <a:p/>
-        </p:txBody>
-      </p:sp>
-      <p:sp>
-        <p:nvSpPr>
-          <p:cNvPr id="4" name="TextBox 3"/>
-          <p:cNvSpPr txBox="1"/>
-          <p:nvPr/>
-        </p:nvSpPr>
-        <p:spPr>
-          <a:xfrm>
-            <a:off x="731520" y="1508760"/>
-            <a:ext cx="2743200" cy="1280160"/>
-          </a:xfrm>
-          <a:prstGeom prst="rect">
-            <a:avLst/>
-          </a:prstGeom>
-          <a:noFill/>
-        </p:spPr>
-        <p:txBody>
-          <a:bodyPr wrap="none">
-            <a:spAutoFit/>
-          </a:bodyPr>
-          <a:lstStyle/>
-          <a:p>
-            <a:r>
-              <a:rPr sz="1800"/>
-              <a:t>Historical snapshot｜FB001 rev1</a:t>
-            </a:r>
-          </a:p>
-          <a:p>
-            <a:r>
-              <a:rPr sz="1800"/>
-              <a:t>Focus branch｜FB-MATERIAL-HYDRATION</a:t>
-            </a:r>
-          </a:p>
-          <a:p>
-            <a:r>
-              <a:rPr sz="1800"/>
-              <a:t>Immutable map; current branch highlighted.</a:t>
-            </a:r>
-          </a:p>
         </p:txBody>
       </p:sp>
       <p:pic>
         <p:nvPicPr>
-          <p:cNvPr id="5" name="Picture 4" descr="FB001-rev1.png"/>
+          <p:cNvPr id="4" name="tds-slot:primary_figure" descr="FB001-rev1.png"/>
           <p:cNvPicPr>
             <a:picLocks noChangeAspect="1"/>
           </p:cNvPicPr>
@@ -6943,6 +7570,35 @@
           </a:prstGeom>
         </p:spPr>
       </p:pic>
+      <p:sp>
+        <p:nvSpPr>
+          <p:cNvPr id="5" name="tds-slot:fishbone_focus"/>
+          <p:cNvSpPr txBox="1"/>
+          <p:nvPr/>
+        </p:nvSpPr>
+        <p:spPr>
+          <a:xfrm>
+            <a:off x="731520" y="1508760"/>
+            <a:ext cx="2743200" cy="1280160"/>
+          </a:xfrm>
+          <a:prstGeom prst="rect">
+            <a:avLst/>
+          </a:prstGeom>
+          <a:noFill/>
+        </p:spPr>
+        <p:txBody>
+          <a:bodyPr wrap="none">
+            <a:spAutoFit/>
+          </a:bodyPr>
+          <a:lstStyle/>
+          <a:p>
+            <a:r>
+              <a:rPr sz="1600"/>
+              <a:t>FB-MATERIAL-HYDRATION</a:t>
+            </a:r>
+          </a:p>
+        </p:txBody>
+      </p:sp>
     </p:spTree>
   </p:cSld>
   <p:clrMapOvr>
@@ -6971,12 +7627,18 @@
             <p:ph type="title"/>
           </p:nvPr>
         </p:nvSpPr>
-        <p:spPr/>
-        <p:txBody>
-          <a:bodyPr/>
-          <a:lstStyle/>
-          <a:p>
-            <a:r>
+        <p:spPr>
+          <a:xfrm>
+            <a:off x="502920" y="201168"/>
+            <a:ext cx="11109960" cy="960120"/>
+          </a:xfrm>
+        </p:spPr>
+        <p:txBody>
+          <a:bodyPr lIns="0" rIns="0" tIns="0" bIns="0" wrap="square"/>
+          <a:lstStyle/>
+          <a:p>
+            <a:r>
+              <a:rPr sz="2400"/>
               <a:t>H001｜Observation → Literature → Mechanism</a:t>
             </a:r>
           </a:p>
@@ -6997,88 +7659,11 @@
           <a:bodyPr/>
           <a:lstStyle/>
           <a:p/>
-        </p:txBody>
-      </p:sp>
-      <p:sp>
-        <p:nvSpPr>
-          <p:cNvPr id="4" name="TextBox 3"/>
-          <p:cNvSpPr txBox="1"/>
-          <p:nvPr/>
-        </p:nvSpPr>
-        <p:spPr>
-          <a:xfrm>
-            <a:off x="731520" y="2331720"/>
-            <a:ext cx="5669280" cy="2423160"/>
-          </a:xfrm>
-          <a:prstGeom prst="rect">
-            <a:avLst/>
-          </a:prstGeom>
-          <a:noFill/>
-        </p:spPr>
-        <p:txBody>
-          <a:bodyPr wrap="none">
-            <a:spAutoFit/>
-          </a:bodyPr>
-          <a:lstStyle/>
-          <a:p>
-            <a:r>
-              <a:rPr sz="1800"/>
-              <a:t>Observation｜位置依賴缺陷與訊號變異已觀察到。</a:t>
-            </a:r>
-          </a:p>
-          <a:p>
-            <a:r>
-              <a:rPr sz="1800"/>
-              <a:t>Problem｜現有模型無法解釋此變異。</a:t>
-            </a:r>
-          </a:p>
-          <a:p>
-            <a:r>
-              <a:rPr sz="1800"/>
-              <a:t>Research question｜提升 bulk conductivity 是否足以降低位置依賴的訊號變異？</a:t>
-            </a:r>
-          </a:p>
-          <a:p>
-            <a:r>
-              <a:rPr sz="1800"/>
-              <a:t>Literature consensus｜transport gradient 可產生位置效應。</a:t>
-            </a:r>
-          </a:p>
-          <a:p>
-            <a:r>
-              <a:rPr sz="1800"/>
-              <a:t>Alternatives｜interface contact remains alternative</a:t>
-            </a:r>
-          </a:p>
-          <a:p>
-            <a:r>
-              <a:rPr sz="1800"/>
-              <a:t>Gap｜缺少控制比較隔離機制。</a:t>
-            </a:r>
-          </a:p>
-          <a:p>
-            <a:r>
-              <a:rPr sz="1800"/>
-              <a:t>Implication｜需匹配條件後比較。</a:t>
-            </a:r>
-          </a:p>
-          <a:p>
-            <a:r>
-              <a:rPr sz="1800"/>
-              <a:t>Mechanism｜bulk transport</a:t>
-            </a:r>
-          </a:p>
-          <a:p>
-            <a:r>
-              <a:rPr sz="1800"/>
-              <a:t>Strategy｜均化導電度</a:t>
-            </a:r>
-          </a:p>
         </p:txBody>
       </p:sp>
       <p:pic>
         <p:nvPicPr>
-          <p:cNvPr id="5" name="Picture 4" descr="observation_visual.png"/>
+          <p:cNvPr id="4" name="tds-slot:primary_figure" descr="observation_visual.png"/>
           <p:cNvPicPr>
             <a:picLocks noChangeAspect="1"/>
           </p:cNvPicPr>
@@ -7100,6 +7685,70 @@
           </a:prstGeom>
         </p:spPr>
       </p:pic>
+      <p:sp>
+        <p:nvSpPr>
+          <p:cNvPr id="5" name="tds-slot:research_question"/>
+          <p:cNvSpPr txBox="1"/>
+          <p:nvPr/>
+        </p:nvSpPr>
+        <p:spPr>
+          <a:xfrm>
+            <a:off x="731520" y="1325880"/>
+            <a:ext cx="5669280" cy="822960"/>
+          </a:xfrm>
+          <a:prstGeom prst="rect">
+            <a:avLst/>
+          </a:prstGeom>
+          <a:noFill/>
+        </p:spPr>
+        <p:txBody>
+          <a:bodyPr wrap="none">
+            <a:spAutoFit/>
+          </a:bodyPr>
+          <a:lstStyle/>
+          <a:p>
+            <a:r>
+              <a:rPr sz="2000"/>
+              <a:t>提升 bulk conductivity 是否足以降低位置依賴的訊號變異？</a:t>
+            </a:r>
+          </a:p>
+        </p:txBody>
+      </p:sp>
+      <p:sp>
+        <p:nvSpPr>
+          <p:cNvPr id="6" name="tds-slot:observation_text"/>
+          <p:cNvSpPr txBox="1"/>
+          <p:nvPr/>
+        </p:nvSpPr>
+        <p:spPr>
+          <a:xfrm>
+            <a:off x="731520" y="2331720"/>
+            <a:ext cx="5669280" cy="2423160"/>
+          </a:xfrm>
+          <a:prstGeom prst="rect">
+            <a:avLst/>
+          </a:prstGeom>
+          <a:noFill/>
+        </p:spPr>
+        <p:txBody>
+          <a:bodyPr wrap="none">
+            <a:spAutoFit/>
+          </a:bodyPr>
+          <a:lstStyle/>
+          <a:p>
+            <a:r>
+              <a:rPr sz="1600"/>
+              <a:t>Observation｜位置依賴缺陷與訊號變異已觀察到。</a:t>
+            </a:r>
+          </a:p>
+          <a:p>
+            <a:r>
+              <a:rPr sz="1600"/>
+              <a:t>Problem｜現有模型無法解釋此變異。</a:t>
+            </a:r>
+          </a:p>
+        </p:txBody>
+      </p:sp>
     </p:spTree>
   </p:cSld>
   <p:clrMapOvr>
@@ -7128,12 +7777,18 @@
             <p:ph type="title"/>
           </p:nvPr>
         </p:nvSpPr>
-        <p:spPr/>
-        <p:txBody>
-          <a:bodyPr/>
-          <a:lstStyle/>
-          <a:p>
-            <a:r>
+        <p:spPr>
+          <a:xfrm>
+            <a:off x="502920" y="201168"/>
+            <a:ext cx="11109960" cy="960120"/>
+          </a:xfrm>
+        </p:spPr>
+        <p:txBody>
+          <a:bodyPr lIns="0" rIns="0" tIns="0" bIns="0" wrap="square"/>
+          <a:lstStyle/>
+          <a:p>
+            <a:r>
+              <a:rPr sz="2400"/>
               <a:t>H001｜Literature → Mechanism → Strategy</a:t>
             </a:r>
           </a:p>
@@ -7158,7 +7813,7 @@
       </p:sp>
       <p:sp>
         <p:nvSpPr>
-          <p:cNvPr id="4" name="TextBox 3"/>
+          <p:cNvPr id="4" name="tds-slot:literature_evidence"/>
           <p:cNvSpPr txBox="1"/>
           <p:nvPr/>
         </p:nvSpPr>
@@ -7179,55 +7834,60 @@
           <a:lstStyle/>
           <a:p>
             <a:r>
-              <a:rPr sz="1800"/>
-              <a:t>Observation｜位置依賴缺陷與訊號變異已觀察到。</a:t>
-            </a:r>
-          </a:p>
-          <a:p>
-            <a:r>
-              <a:rPr sz="1800"/>
-              <a:t>Problem｜現有模型無法解釋此變異。</a:t>
-            </a:r>
-          </a:p>
-          <a:p>
-            <a:r>
-              <a:rPr sz="1800"/>
-              <a:t>Research question｜提升 bulk conductivity 是否足以降低位置依賴的訊號變異？</a:t>
-            </a:r>
-          </a:p>
-          <a:p>
-            <a:r>
-              <a:rPr sz="1800"/>
+              <a:rPr sz="1600"/>
               <a:t>Literature consensus｜transport gradient 可產生位置效應。</a:t>
             </a:r>
           </a:p>
           <a:p>
             <a:r>
-              <a:rPr sz="1800"/>
+              <a:rPr sz="1600"/>
               <a:t>Alternatives｜interface contact remains alternative</a:t>
             </a:r>
           </a:p>
           <a:p>
             <a:r>
-              <a:rPr sz="1800"/>
+              <a:rPr sz="1600"/>
               <a:t>Gap｜缺少控制比較隔離機制。</a:t>
             </a:r>
           </a:p>
           <a:p>
             <a:r>
-              <a:rPr sz="1800"/>
+              <a:rPr sz="1600"/>
               <a:t>Implication｜需匹配條件後比較。</a:t>
             </a:r>
           </a:p>
-          <a:p>
-            <a:r>
-              <a:rPr sz="1800"/>
+        </p:txBody>
+      </p:sp>
+      <p:sp>
+        <p:nvSpPr>
+          <p:cNvPr id="5" name="tds-slot:mechanism_diagram"/>
+          <p:cNvSpPr txBox="1"/>
+          <p:nvPr/>
+        </p:nvSpPr>
+        <p:spPr>
+          <a:xfrm>
+            <a:off x="6400800" y="1325880"/>
+            <a:ext cx="5074920" cy="3566160"/>
+          </a:xfrm>
+          <a:prstGeom prst="rect">
+            <a:avLst/>
+          </a:prstGeom>
+          <a:noFill/>
+        </p:spPr>
+        <p:txBody>
+          <a:bodyPr wrap="none">
+            <a:spAutoFit/>
+          </a:bodyPr>
+          <a:lstStyle/>
+          <a:p>
+            <a:r>
+              <a:rPr sz="1600"/>
               <a:t>Mechanism｜bulk transport</a:t>
             </a:r>
           </a:p>
           <a:p>
             <a:r>
-              <a:rPr sz="1800"/>
+              <a:rPr sz="1600"/>
               <a:t>Strategy｜均化導電度</a:t>
             </a:r>
           </a:p>
@@ -7261,12 +7921,18 @@
             <p:ph type="title"/>
           </p:nvPr>
         </p:nvSpPr>
-        <p:spPr/>
-        <p:txBody>
-          <a:bodyPr/>
-          <a:lstStyle/>
-          <a:p>
-            <a:r>
+        <p:spPr>
+          <a:xfrm>
+            <a:off x="502920" y="201168"/>
+            <a:ext cx="11109960" cy="960120"/>
+          </a:xfrm>
+        </p:spPr>
+        <p:txBody>
+          <a:bodyPr lIns="0" rIns="0" tIns="0" bIns="0" wrap="square"/>
+          <a:lstStyle/>
+          <a:p>
+            <a:r>
+              <a:rPr sz="3000"/>
               <a:t>H001｜Experiment Design</a:t>
             </a:r>
           </a:p>
@@ -7291,7 +7957,7 @@
       </p:sp>
       <p:sp>
         <p:nvSpPr>
-          <p:cNvPr id="4" name="TextBox 3"/>
+          <p:cNvPr id="4" name="tds-slot:experiment_matrix"/>
           <p:cNvSpPr txBox="1"/>
           <p:nvPr/>
         </p:nvSpPr>
@@ -7312,87 +7978,67 @@
           <a:lstStyle/>
           <a:p>
             <a:r>
-              <a:rPr sz="1800"/>
+              <a:rPr sz="1600"/>
               <a:t>EXP101｜IV: ['含水量']</a:t>
             </a:r>
           </a:p>
           <a:p>
             <a:r>
-              <a:rPr sz="1800"/>
+              <a:rPr sz="1600"/>
               <a:t>Controls: ['原始配方']</a:t>
             </a:r>
           </a:p>
           <a:p>
             <a:r>
-              <a:rPr sz="1800"/>
+              <a:rPr sz="1600"/>
               <a:t>N/replicates: {'replicates': 3, 'samples': 15}</a:t>
             </a:r>
           </a:p>
           <a:p>
             <a:r>
-              <a:rPr sz="1800"/>
+              <a:rPr sz="1600"/>
               <a:t>Metrics/units: ['導電度 (mS/cm)']</a:t>
             </a:r>
           </a:p>
           <a:p>
             <a:r>
-              <a:rPr sz="1800"/>
+              <a:rPr sz="1600"/>
               <a:t>Method: ['synthetic-four-probe']</a:t>
             </a:r>
           </a:p>
-          <a:p>
-            <a:r>
-              <a:rPr sz="1800"/>
+        </p:txBody>
+      </p:sp>
+      <p:sp>
+        <p:nvSpPr>
+          <p:cNvPr id="5" name="tds-slot:decision_rule"/>
+          <p:cNvSpPr txBox="1"/>
+          <p:nvPr/>
+        </p:nvSpPr>
+        <p:spPr>
+          <a:xfrm>
+            <a:off x="7818120" y="1280160"/>
+            <a:ext cx="3657600" cy="1828800"/>
+          </a:xfrm>
+          <a:prstGeom prst="rect">
+            <a:avLst/>
+          </a:prstGeom>
+          <a:noFill/>
+        </p:spPr>
+        <p:txBody>
+          <a:bodyPr wrap="none">
+            <a:spAutoFit/>
+          </a:bodyPr>
+          <a:lstStyle/>
+          <a:p>
+            <a:r>
+              <a:rPr sz="1600"/>
               <a:t>Prediction: ['導電度提升']</a:t>
             </a:r>
           </a:p>
           <a:p>
             <a:r>
-              <a:rPr sz="1800"/>
+              <a:rPr sz="1600"/>
               <a:t>Decision rule: {'go': 'mean conductivity increases &gt;=20%', 'partial_go': '10-20%', 'no_go': '&lt;10%'}</a:t>
-            </a:r>
-          </a:p>
-          <a:p/>
-          <a:p>
-            <a:r>
-              <a:rPr sz="1800"/>
-              <a:t>EXP102｜IV: ['位置']</a:t>
-            </a:r>
-          </a:p>
-          <a:p>
-            <a:r>
-              <a:rPr sz="1800"/>
-              <a:t>Controls: ['原始位置分布']</a:t>
-            </a:r>
-          </a:p>
-          <a:p>
-            <a:r>
-              <a:rPr sz="1800"/>
-              <a:t>N/replicates: {'replicates': 3, 'samples': 15}</a:t>
-            </a:r>
-          </a:p>
-          <a:p>
-            <a:r>
-              <a:rPr sz="1800"/>
-              <a:t>Metrics/units: ['訊號 CV (%)']</a:t>
-            </a:r>
-          </a:p>
-          <a:p>
-            <a:r>
-              <a:rPr sz="1800"/>
-              <a:t>Method: ['synthetic-signal-test']</a:t>
-            </a:r>
-          </a:p>
-          <a:p>
-            <a:r>
-              <a:rPr sz="1800"/>
-              <a:t>Prediction: ['CV 下降']</a:t>
-            </a:r>
-          </a:p>
-          <a:p>
-            <a:r>
-              <a:rPr sz="1800"/>
-              <a:t>Decision rule: {'go': 'CV decreases &gt;=30%', 'partial_go': '10-30%', 'no_go': '&lt;10%'}</a:t>
             </a:r>
           </a:p>
         </p:txBody>

</xml_diff>

<commit_message>
fix: phase2 presentation semantic fidelity revision
</commit_message>
<xml_diff>
--- a/thesis-deck-system/artifacts/phase2/acceptance-deck-render-compat.pptx
+++ b/thesis-deck-system/artifacts/phase2/acceptance-deck-render-compat.pptx
@@ -527,17 +527,7 @@
           </a:p>
           <a:p>
             <a:r>
-              <a:t>E202</a:t>
-            </a:r>
-          </a:p>
-          <a:p>
-            <a:r>
-              <a:t>E204</a:t>
-            </a:r>
-          </a:p>
-          <a:p>
-            <a:r>
-              <a:t>E201</a:t>
+              <a:t>E101</a:t>
             </a:r>
           </a:p>
           <a:p>
@@ -622,22 +612,7 @@
           </a:p>
           <a:p>
             <a:r>
-              <a:t>E002</a:t>
-            </a:r>
-          </a:p>
-          <a:p>
-            <a:r>
               <a:t>E101</a:t>
-            </a:r>
-          </a:p>
-          <a:p>
-            <a:r>
-              <a:t>E102</a:t>
-            </a:r>
-          </a:p>
-          <a:p>
-            <a:r>
-              <a:t>E103</a:t>
             </a:r>
           </a:p>
           <a:p>
@@ -722,11 +697,6 @@
           </a:p>
           <a:p>
             <a:r>
-              <a:t>E002</a:t>
-            </a:r>
-          </a:p>
-          <a:p>
-            <a:r>
               <a:t>E101</a:t>
             </a:r>
           </a:p>
@@ -822,22 +792,7 @@
           </a:p>
           <a:p>
             <a:r>
-              <a:t>E002</a:t>
-            </a:r>
-          </a:p>
-          <a:p>
-            <a:r>
               <a:t>E101</a:t>
-            </a:r>
-          </a:p>
-          <a:p>
-            <a:r>
-              <a:t>E102</a:t>
-            </a:r>
-          </a:p>
-          <a:p>
-            <a:r>
-              <a:t>E103</a:t>
             </a:r>
           </a:p>
           <a:p>
@@ -1012,17 +967,7 @@
           </a:p>
           <a:p>
             <a:r>
-              <a:t>E202</a:t>
-            </a:r>
-          </a:p>
-          <a:p>
-            <a:r>
               <a:t>E204</a:t>
-            </a:r>
-          </a:p>
-          <a:p>
-            <a:r>
-              <a:t>E201</a:t>
             </a:r>
           </a:p>
           <a:p>
@@ -1107,17 +1052,7 @@
           </a:p>
           <a:p>
             <a:r>
-              <a:t>E202</a:t>
-            </a:r>
-          </a:p>
-          <a:p>
-            <a:r>
               <a:t>E204</a:t>
-            </a:r>
-          </a:p>
-          <a:p>
-            <a:r>
-              <a:t>E201</a:t>
             </a:r>
           </a:p>
           <a:p>
@@ -1202,17 +1137,7 @@
           </a:p>
           <a:p>
             <a:r>
-              <a:t>E202</a:t>
-            </a:r>
-          </a:p>
-          <a:p>
-            <a:r>
               <a:t>E204</a:t>
-            </a:r>
-          </a:p>
-          <a:p>
-            <a:r>
-              <a:t>E201</a:t>
             </a:r>
           </a:p>
           <a:p>
@@ -1297,17 +1222,12 @@
           </a:p>
           <a:p>
             <a:r>
+              <a:t>E204</a:t>
+            </a:r>
+          </a:p>
+          <a:p>
+            <a:r>
               <a:t>E202</a:t>
-            </a:r>
-          </a:p>
-          <a:p>
-            <a:r>
-              <a:t>E204</a:t>
-            </a:r>
-          </a:p>
-          <a:p>
-            <a:r>
-              <a:t>E201</a:t>
             </a:r>
           </a:p>
           <a:p>
@@ -1392,11 +1312,6 @@
           </a:p>
           <a:p>
             <a:r>
-              <a:t>E202</a:t>
-            </a:r>
-          </a:p>
-          <a:p>
-            <a:r>
               <a:t>E204</a:t>
             </a:r>
           </a:p>
@@ -1487,16 +1402,6 @@
           </a:p>
           <a:p>
             <a:r>
-              <a:t>E202</a:t>
-            </a:r>
-          </a:p>
-          <a:p>
-            <a:r>
-              <a:t>E204</a:t>
-            </a:r>
-          </a:p>
-          <a:p>
-            <a:r>
               <a:t>E201</a:t>
             </a:r>
           </a:p>
@@ -1587,17 +1492,7 @@
           </a:p>
           <a:p>
             <a:r>
-              <a:t>E101</a:t>
-            </a:r>
-          </a:p>
-          <a:p>
-            <a:r>
               <a:t>E102</a:t>
-            </a:r>
-          </a:p>
-          <a:p>
-            <a:r>
-              <a:t>E103</a:t>
             </a:r>
           </a:p>
           <a:p>
@@ -1687,21 +1582,6 @@
           </a:p>
           <a:p>
             <a:r>
-              <a:t>E101</a:t>
-            </a:r>
-          </a:p>
-          <a:p>
-            <a:r>
-              <a:t>E102</a:t>
-            </a:r>
-          </a:p>
-          <a:p>
-            <a:r>
-              <a:t>E103</a:t>
-            </a:r>
-          </a:p>
-          <a:p>
-            <a:r>
               <a:t>[/Sources]</a:t>
             </a:r>
           </a:p>
@@ -1782,21 +1662,6 @@
           </a:p>
           <a:p>
             <a:r>
-              <a:t>E002</a:t>
-            </a:r>
-          </a:p>
-          <a:p>
-            <a:r>
-              <a:t>E101</a:t>
-            </a:r>
-          </a:p>
-          <a:p>
-            <a:r>
-              <a:t>E102</a:t>
-            </a:r>
-          </a:p>
-          <a:p>
-            <a:r>
               <a:t>E103</a:t>
             </a:r>
           </a:p>
@@ -1887,17 +1752,7 @@
           </a:p>
           <a:p>
             <a:r>
-              <a:t>E101</a:t>
-            </a:r>
-          </a:p>
-          <a:p>
-            <a:r>
               <a:t>E102</a:t>
-            </a:r>
-          </a:p>
-          <a:p>
-            <a:r>
-              <a:t>E103</a:t>
             </a:r>
           </a:p>
           <a:p>
@@ -1982,21 +1837,6 @@
           </a:p>
           <a:p>
             <a:r>
-              <a:t>E002</a:t>
-            </a:r>
-          </a:p>
-          <a:p>
-            <a:r>
-              <a:t>E101</a:t>
-            </a:r>
-          </a:p>
-          <a:p>
-            <a:r>
-              <a:t>E102</a:t>
-            </a:r>
-          </a:p>
-          <a:p>
-            <a:r>
               <a:t>E103</a:t>
             </a:r>
           </a:p>
@@ -2087,21 +1927,6 @@
           </a:p>
           <a:p>
             <a:r>
-              <a:t>E101</a:t>
-            </a:r>
-          </a:p>
-          <a:p>
-            <a:r>
-              <a:t>E102</a:t>
-            </a:r>
-          </a:p>
-          <a:p>
-            <a:r>
-              <a:t>E103</a:t>
-            </a:r>
-          </a:p>
-          <a:p>
-            <a:r>
               <a:t>[/Sources]</a:t>
             </a:r>
           </a:p>
@@ -2187,17 +2012,7 @@
           </a:p>
           <a:p>
             <a:r>
-              <a:t>E101</a:t>
-            </a:r>
-          </a:p>
-          <a:p>
-            <a:r>
               <a:t>E102</a:t>
-            </a:r>
-          </a:p>
-          <a:p>
-            <a:r>
-              <a:t>E103</a:t>
             </a:r>
           </a:p>
           <a:p>
@@ -2282,22 +2097,7 @@
           </a:p>
           <a:p>
             <a:r>
-              <a:t>E002</a:t>
-            </a:r>
-          </a:p>
-          <a:p>
-            <a:r>
               <a:t>E101</a:t>
-            </a:r>
-          </a:p>
-          <a:p>
-            <a:r>
-              <a:t>E102</a:t>
-            </a:r>
-          </a:p>
-          <a:p>
-            <a:r>
-              <a:t>E103</a:t>
             </a:r>
           </a:p>
           <a:p>
@@ -5545,7 +5345,7 @@
           <a:p>
             <a:r>
               <a:rPr sz="3000"/>
-              <a:t>H001｜Results</a:t>
+              <a:t>H001｜Result</a:t>
             </a:r>
           </a:p>
         </p:txBody>
@@ -5565,40 +5365,11 @@
           <a:bodyPr/>
           <a:lstStyle/>
           <a:p/>
-        </p:txBody>
-      </p:sp>
-      <p:sp>
-        <p:nvSpPr>
-          <p:cNvPr id="4" name="tds-slot:control_panel"/>
-          <p:cNvSpPr txBox="1"/>
-          <p:nvPr/>
-        </p:nvSpPr>
-        <p:spPr>
-          <a:xfrm>
-            <a:off x="731520" y="1325880"/>
-            <a:ext cx="5257800" cy="3840480"/>
-          </a:xfrm>
-          <a:prstGeom prst="rect">
-            <a:avLst/>
-          </a:prstGeom>
-          <a:noFill/>
-        </p:spPr>
-        <p:txBody>
-          <a:bodyPr wrap="none">
-            <a:spAutoFit/>
-          </a:bodyPr>
-          <a:lstStyle/>
-          <a:p>
-            <a:r>
-              <a:rPr sz="1600"/>
-              <a:t>Control｜</a:t>
-            </a:r>
-          </a:p>
         </p:txBody>
       </p:sp>
       <p:pic>
         <p:nvPicPr>
-          <p:cNvPr id="5" name="tds-slot:proposed_panel" descr="B001_defect_density.png"/>
+          <p:cNvPr id="4" name="tds-slot:result_plot/figure" descr="B001_defect_density.png"/>
           <p:cNvPicPr>
             <a:picLocks noChangeAspect="1"/>
           </p:cNvPicPr>
@@ -5612,14 +5383,72 @@
         </p:blipFill>
         <p:spPr>
           <a:xfrm>
-            <a:off x="6217920" y="1325880"/>
-            <a:ext cx="5257800" cy="3840480"/>
+            <a:off x="5486400" y="1234440"/>
+            <a:ext cx="5989320" cy="4069080"/>
           </a:xfrm>
           <a:prstGeom prst="rect">
             <a:avLst/>
           </a:prstGeom>
         </p:spPr>
       </p:pic>
+      <p:sp>
+        <p:nvSpPr>
+          <p:cNvPr id="5" name="tds-slot:result_plot/annotation"/>
+          <p:cNvSpPr txBox="1"/>
+          <p:nvPr/>
+        </p:nvSpPr>
+        <p:spPr>
+          <a:xfrm>
+            <a:off x="5486400" y="4001414"/>
+            <a:ext cx="5989320" cy="1302105"/>
+          </a:xfrm>
+          <a:prstGeom prst="rect">
+            <a:avLst/>
+          </a:prstGeom>
+          <a:noFill/>
+        </p:spPr>
+        <p:txBody>
+          <a:bodyPr wrap="none">
+            <a:spAutoFit/>
+          </a:bodyPr>
+          <a:lstStyle/>
+          <a:p>
+            <a:r>
+              <a:rPr sz="1500"/>
+              <a:t>RES101｜平均導電度增加 24% ± 5% SD</a:t>
+            </a:r>
+          </a:p>
+        </p:txBody>
+      </p:sp>
+      <p:sp>
+        <p:nvSpPr>
+          <p:cNvPr id="6" name="tds-slot:result_annotation"/>
+          <p:cNvSpPr txBox="1"/>
+          <p:nvPr/>
+        </p:nvSpPr>
+        <p:spPr>
+          <a:xfrm>
+            <a:off x="731520" y="1508760"/>
+            <a:ext cx="4389120" cy="2103120"/>
+          </a:xfrm>
+          <a:prstGeom prst="rect">
+            <a:avLst/>
+          </a:prstGeom>
+          <a:noFill/>
+        </p:spPr>
+        <p:txBody>
+          <a:bodyPr wrap="none">
+            <a:spAutoFit/>
+          </a:bodyPr>
+          <a:lstStyle/>
+          <a:p>
+            <a:r>
+              <a:rPr sz="1600"/>
+              <a:t>RES101｜平均導電度增加 24% ± 5% SD</a:t>
+            </a:r>
+          </a:p>
+        </p:txBody>
+      </p:sp>
     </p:spTree>
   </p:cSld>
   <p:clrMapOvr>
@@ -5660,7 +5489,7 @@
           <a:p>
             <a:r>
               <a:rPr sz="3000"/>
-              <a:t>H001｜Results</a:t>
+              <a:t>H001｜Result</a:t>
             </a:r>
           </a:p>
         </p:txBody>
@@ -5680,40 +5509,11 @@
           <a:bodyPr/>
           <a:lstStyle/>
           <a:p/>
-        </p:txBody>
-      </p:sp>
-      <p:sp>
-        <p:nvSpPr>
-          <p:cNvPr id="4" name="tds-slot:control_panel"/>
-          <p:cNvSpPr txBox="1"/>
-          <p:nvPr/>
-        </p:nvSpPr>
-        <p:spPr>
-          <a:xfrm>
-            <a:off x="731520" y="1325880"/>
-            <a:ext cx="5257800" cy="3840480"/>
-          </a:xfrm>
-          <a:prstGeom prst="rect">
-            <a:avLst/>
-          </a:prstGeom>
-          <a:noFill/>
-        </p:spPr>
-        <p:txBody>
-          <a:bodyPr wrap="none">
-            <a:spAutoFit/>
-          </a:bodyPr>
-          <a:lstStyle/>
-          <a:p>
-            <a:r>
-              <a:rPr sz="1600"/>
-              <a:t>Control｜</a:t>
-            </a:r>
-          </a:p>
         </p:txBody>
       </p:sp>
       <p:pic>
         <p:nvPicPr>
-          <p:cNvPr id="5" name="tds-slot:proposed_panel" descr="B001_defect_density.png"/>
+          <p:cNvPr id="4" name="tds-slot:result_plot/figure" descr="B001_defect_density.png"/>
           <p:cNvPicPr>
             <a:picLocks noChangeAspect="1"/>
           </p:cNvPicPr>
@@ -5727,14 +5527,72 @@
         </p:blipFill>
         <p:spPr>
           <a:xfrm>
-            <a:off x="6217920" y="1325880"/>
-            <a:ext cx="5257800" cy="3840480"/>
+            <a:off x="5486400" y="1234440"/>
+            <a:ext cx="5989320" cy="4069080"/>
           </a:xfrm>
           <a:prstGeom prst="rect">
             <a:avLst/>
           </a:prstGeom>
         </p:spPr>
       </p:pic>
+      <p:sp>
+        <p:nvSpPr>
+          <p:cNvPr id="5" name="tds-slot:result_plot/annotation"/>
+          <p:cNvSpPr txBox="1"/>
+          <p:nvPr/>
+        </p:nvSpPr>
+        <p:spPr>
+          <a:xfrm>
+            <a:off x="5486400" y="4001414"/>
+            <a:ext cx="5989320" cy="1302105"/>
+          </a:xfrm>
+          <a:prstGeom prst="rect">
+            <a:avLst/>
+          </a:prstGeom>
+          <a:noFill/>
+        </p:spPr>
+        <p:txBody>
+          <a:bodyPr wrap="none">
+            <a:spAutoFit/>
+          </a:bodyPr>
+          <a:lstStyle/>
+          <a:p>
+            <a:r>
+              <a:rPr sz="1500"/>
+              <a:t>RES102｜訊號 CV 僅下降 4% ± 6% SD，屬 No-Go</a:t>
+            </a:r>
+          </a:p>
+        </p:txBody>
+      </p:sp>
+      <p:sp>
+        <p:nvSpPr>
+          <p:cNvPr id="6" name="tds-slot:result_annotation"/>
+          <p:cNvSpPr txBox="1"/>
+          <p:nvPr/>
+        </p:nvSpPr>
+        <p:spPr>
+          <a:xfrm>
+            <a:off x="731520" y="1508760"/>
+            <a:ext cx="4389120" cy="2103120"/>
+          </a:xfrm>
+          <a:prstGeom prst="rect">
+            <a:avLst/>
+          </a:prstGeom>
+          <a:noFill/>
+        </p:spPr>
+        <p:txBody>
+          <a:bodyPr wrap="none">
+            <a:spAutoFit/>
+          </a:bodyPr>
+          <a:lstStyle/>
+          <a:p>
+            <a:r>
+              <a:rPr sz="1600"/>
+              <a:t>RES102｜訊號 CV 僅下降 4% ± 6% SD，屬 No-Go</a:t>
+            </a:r>
+          </a:p>
+        </p:txBody>
+      </p:sp>
     </p:spTree>
   </p:cSld>
   <p:clrMapOvr>
@@ -6638,14 +6496,14 @@
       </p:sp>
       <p:sp>
         <p:nvSpPr>
-          <p:cNvPr id="4" name="tds-slot:primary_figure"/>
+          <p:cNvPr id="4" name="tds-slot:observation_text"/>
           <p:cNvSpPr txBox="1"/>
           <p:nvPr/>
         </p:nvSpPr>
         <p:spPr>
           <a:xfrm>
-            <a:off x="6903720" y="1280160"/>
-            <a:ext cx="4572000" cy="3474720"/>
+            <a:off x="731520" y="1280160"/>
+            <a:ext cx="2743200" cy="1920240"/>
           </a:xfrm>
           <a:prstGeom prst="rect">
             <a:avLst/>
@@ -6660,7 +6518,13 @@
           <a:p>
             <a:r>
               <a:rPr sz="1600"/>
-              <a:t>Registered observation visual.</a:t>
+              <a:t>Observation｜位置依賴缺陷與訊號變異已觀察到。</a:t>
+            </a:r>
+          </a:p>
+          <a:p>
+            <a:r>
+              <a:rPr sz="1600"/>
+              <a:t>Problem｜現有模型無法解釋此變異。</a:t>
             </a:r>
           </a:p>
         </p:txBody>
@@ -6673,8 +6537,8 @@
         </p:nvSpPr>
         <p:spPr>
           <a:xfrm>
-            <a:off x="731520" y="1325880"/>
-            <a:ext cx="5669280" cy="822960"/>
+            <a:off x="731520" y="3429000"/>
+            <a:ext cx="2743200" cy="1417320"/>
           </a:xfrm>
           <a:prstGeom prst="rect">
             <a:avLst/>
@@ -6688,7 +6552,7 @@
           <a:lstStyle/>
           <a:p>
             <a:r>
-              <a:rPr sz="2000"/>
+              <a:rPr sz="1800"/>
               <a:t>低接觸壓力下，contact resistance 是否主導訊號不穩定？</a:t>
             </a:r>
           </a:p>
@@ -6696,14 +6560,14 @@
       </p:sp>
       <p:sp>
         <p:nvSpPr>
-          <p:cNvPr id="6" name="tds-slot:observation_text"/>
+          <p:cNvPr id="6" name="tds-slot:literature_evidence"/>
           <p:cNvSpPr txBox="1"/>
           <p:nvPr/>
         </p:nvSpPr>
         <p:spPr>
           <a:xfrm>
-            <a:off x="731520" y="2331720"/>
-            <a:ext cx="5669280" cy="2423160"/>
+            <a:off x="3749039" y="1280160"/>
+            <a:ext cx="3749039" cy="3566160"/>
           </a:xfrm>
           <a:prstGeom prst="rect">
             <a:avLst/>
@@ -6718,13 +6582,112 @@
           <a:p>
             <a:r>
               <a:rPr sz="1600"/>
-              <a:t>Observation｜位置依賴缺陷與訊號變異已觀察到。</a:t>
+              <a:t>Literature consensus｜transport gradient 可產生位置效應。</a:t>
             </a:r>
           </a:p>
           <a:p>
             <a:r>
               <a:rPr sz="1600"/>
-              <a:t>Problem｜現有模型無法解釋此變異。</a:t>
+              <a:t>Alternatives｜interface contact remains alternative</a:t>
+            </a:r>
+          </a:p>
+          <a:p>
+            <a:r>
+              <a:rPr sz="1600"/>
+              <a:t>Gap｜缺少控制比較隔離機制。</a:t>
+            </a:r>
+          </a:p>
+          <a:p>
+            <a:r>
+              <a:rPr sz="1600"/>
+              <a:t>Implication｜需匹配條件後比較。</a:t>
+            </a:r>
+          </a:p>
+        </p:txBody>
+      </p:sp>
+      <p:sp>
+        <p:nvSpPr>
+          <p:cNvPr id="7" name="tds-slot:mechanism_diagram"/>
+          <p:cNvSpPr txBox="1"/>
+          <p:nvPr/>
+        </p:nvSpPr>
+        <p:spPr>
+          <a:xfrm>
+            <a:off x="7772400" y="1280160"/>
+            <a:ext cx="1920240" cy="2103120"/>
+          </a:xfrm>
+          <a:prstGeom prst="rect">
+            <a:avLst/>
+          </a:prstGeom>
+          <a:noFill/>
+        </p:spPr>
+        <p:txBody>
+          <a:bodyPr wrap="none">
+            <a:spAutoFit/>
+          </a:bodyPr>
+          <a:lstStyle/>
+          <a:p>
+            <a:r>
+              <a:rPr sz="1600"/>
+              <a:t>Mechanism｜contact resistance</a:t>
+            </a:r>
+          </a:p>
+        </p:txBody>
+      </p:sp>
+      <p:sp>
+        <p:nvSpPr>
+          <p:cNvPr id="8" name="tds-slot:strategy"/>
+          <p:cNvSpPr txBox="1"/>
+          <p:nvPr/>
+        </p:nvSpPr>
+        <p:spPr>
+          <a:xfrm>
+            <a:off x="9875520" y="1280160"/>
+            <a:ext cx="1554480" cy="2103120"/>
+          </a:xfrm>
+          <a:prstGeom prst="rect">
+            <a:avLst/>
+          </a:prstGeom>
+          <a:noFill/>
+        </p:spPr>
+        <p:txBody>
+          <a:bodyPr wrap="none">
+            <a:spAutoFit/>
+          </a:bodyPr>
+          <a:lstStyle/>
+          <a:p>
+            <a:r>
+              <a:rPr sz="1600"/>
+              <a:t>匹配導電度並改變接觸壓力</a:t>
+            </a:r>
+          </a:p>
+        </p:txBody>
+      </p:sp>
+      <p:sp>
+        <p:nvSpPr>
+          <p:cNvPr id="9" name="tds-slot:primary_figure"/>
+          <p:cNvSpPr txBox="1"/>
+          <p:nvPr/>
+        </p:nvSpPr>
+        <p:spPr>
+          <a:xfrm>
+            <a:off x="7772400" y="3611880"/>
+            <a:ext cx="3657600" cy="1234440"/>
+          </a:xfrm>
+          <a:prstGeom prst="rect">
+            <a:avLst/>
+          </a:prstGeom>
+          <a:noFill/>
+        </p:spPr>
+        <p:txBody>
+          <a:bodyPr wrap="none">
+            <a:spAutoFit/>
+          </a:bodyPr>
+          <a:lstStyle/>
+          <a:p>
+            <a:r>
+              <a:rPr sz="1600"/>
+              <a:t>Registered observation visual.</a:t>
             </a:r>
           </a:p>
         </p:txBody>
@@ -6853,14 +6816,14 @@
       </p:sp>
       <p:sp>
         <p:nvSpPr>
-          <p:cNvPr id="4" name="tds-slot:control_panel"/>
+          <p:cNvPr id="4" name="tds-slot:experiment_matrix"/>
           <p:cNvSpPr txBox="1"/>
           <p:nvPr/>
         </p:nvSpPr>
         <p:spPr>
           <a:xfrm>
-            <a:off x="731520" y="1325880"/>
-            <a:ext cx="5257800" cy="3840480"/>
+            <a:off x="731520" y="1280160"/>
+            <a:ext cx="5303520" cy="3931920"/>
           </a:xfrm>
           <a:prstGeom prst="rect">
             <a:avLst/>
@@ -6875,14 +6838,79 @@
           <a:p>
             <a:r>
               <a:rPr sz="1600"/>
-              <a:t>Control｜low-pressure control</a:t>
+              <a:t>IV: contact pressure</a:t>
+            </a:r>
+          </a:p>
+          <a:p>
+            <a:r>
+              <a:rPr sz="1600"/>
+              <a:t>Controls: bulk conductivity; 電極幾何</a:t>
+            </a:r>
+          </a:p>
+          <a:p>
+            <a:r>
+              <a:rPr sz="1600"/>
+              <a:t>Baselines: low-pressure control</a:t>
+            </a:r>
+          </a:p>
+          <a:p>
+            <a:r>
+              <a:rPr sz="1600"/>
+              <a:t>N/replicates: replicates: 5; samples: 15</a:t>
+            </a:r>
+          </a:p>
+          <a:p>
+            <a:r>
+              <a:rPr sz="1600"/>
+              <a:t>Metrics/units: 訊號 CV (%); contact resistance (ohm)</a:t>
+            </a:r>
+          </a:p>
+          <a:p>
+            <a:r>
+              <a:rPr sz="1600"/>
+              <a:t>Method: synthetic-pressure-fixture</a:t>
+            </a:r>
+          </a:p>
+          <a:p>
+            <a:r>
+              <a:rPr sz="1600"/>
+              <a:t>Prediction: CV and resistance decrease</a:t>
+            </a:r>
+          </a:p>
+        </p:txBody>
+      </p:sp>
+      <p:sp>
+        <p:nvSpPr>
+          <p:cNvPr id="5" name="tds-slot:decision_rule"/>
+          <p:cNvSpPr txBox="1"/>
+          <p:nvPr/>
+        </p:nvSpPr>
+        <p:spPr>
+          <a:xfrm>
+            <a:off x="6217920" y="1280160"/>
+            <a:ext cx="1828800" cy="1828800"/>
+          </a:xfrm>
+          <a:prstGeom prst="rect">
+            <a:avLst/>
+          </a:prstGeom>
+          <a:noFill/>
+        </p:spPr>
+        <p:txBody>
+          <a:bodyPr wrap="none">
+            <a:spAutoFit/>
+          </a:bodyPr>
+          <a:lstStyle/>
+          <a:p>
+            <a:r>
+              <a:rPr sz="1600"/>
+              <a:t>go: both metrics improve; partial_go: one metric improves; no_go: neither improves</a:t>
             </a:r>
           </a:p>
         </p:txBody>
       </p:sp>
       <p:pic>
         <p:nvPicPr>
-          <p:cNvPr id="5" name="tds-slot:proposed_panel" descr="H02_contact_pressure.png"/>
+          <p:cNvPr id="6" name="tds-slot:result_plot/figure" descr="H02_contact_pressure.png"/>
           <p:cNvPicPr>
             <a:picLocks noChangeAspect="1"/>
           </p:cNvPicPr>
@@ -6896,14 +6924,72 @@
         </p:blipFill>
         <p:spPr>
           <a:xfrm>
-            <a:off x="6217920" y="1325880"/>
-            <a:ext cx="5257800" cy="3840480"/>
+            <a:off x="8275320" y="1280160"/>
+            <a:ext cx="3200400" cy="2194560"/>
           </a:xfrm>
           <a:prstGeom prst="rect">
             <a:avLst/>
           </a:prstGeom>
         </p:spPr>
       </p:pic>
+      <p:sp>
+        <p:nvSpPr>
+          <p:cNvPr id="7" name="tds-slot:result_plot/annotation"/>
+          <p:cNvSpPr txBox="1"/>
+          <p:nvPr/>
+        </p:nvSpPr>
+        <p:spPr>
+          <a:xfrm>
+            <a:off x="8275320" y="2772460"/>
+            <a:ext cx="3200400" cy="702259"/>
+          </a:xfrm>
+          <a:prstGeom prst="rect">
+            <a:avLst/>
+          </a:prstGeom>
+          <a:noFill/>
+        </p:spPr>
+        <p:txBody>
+          <a:bodyPr wrap="none">
+            <a:spAutoFit/>
+          </a:bodyPr>
+          <a:lstStyle/>
+          <a:p>
+            <a:r>
+              <a:rPr sz="1500"/>
+              <a:t>高壓條件 CV 下降 38% ± 7% SD，contact resistance 同步下降</a:t>
+            </a:r>
+          </a:p>
+        </p:txBody>
+      </p:sp>
+      <p:sp>
+        <p:nvSpPr>
+          <p:cNvPr id="8" name="tds-slot:result_annotation"/>
+          <p:cNvSpPr txBox="1"/>
+          <p:nvPr/>
+        </p:nvSpPr>
+        <p:spPr>
+          <a:xfrm>
+            <a:off x="6217920" y="3611880"/>
+            <a:ext cx="5257800" cy="1600200"/>
+          </a:xfrm>
+          <a:prstGeom prst="rect">
+            <a:avLst/>
+          </a:prstGeom>
+          <a:noFill/>
+        </p:spPr>
+        <p:txBody>
+          <a:bodyPr wrap="none">
+            <a:spAutoFit/>
+          </a:bodyPr>
+          <a:lstStyle/>
+          <a:p>
+            <a:r>
+              <a:rPr sz="1600"/>
+              <a:t>高壓條件 CV 下降 38% ± 7% SD，contact resistance 同步下降</a:t>
+            </a:r>
+          </a:p>
+        </p:txBody>
+      </p:sp>
     </p:spTree>
   </p:cSld>
   <p:clrMapOvr>
@@ -6968,14 +7054,14 @@
       </p:sp>
       <p:sp>
         <p:nvSpPr>
-          <p:cNvPr id="4" name="tds-slot:decision_status"/>
+          <p:cNvPr id="4" name="tds-slot:supporting_results"/>
           <p:cNvSpPr txBox="1"/>
           <p:nvPr/>
         </p:nvSpPr>
         <p:spPr>
           <a:xfrm>
             <a:off x="731520" y="1280160"/>
-            <a:ext cx="3383280" cy="2103120"/>
+            <a:ext cx="2743200" cy="1920240"/>
           </a:xfrm>
           <a:prstGeom prst="rect">
             <a:avLst/>
@@ -6989,34 +7075,22 @@
           <a:lstStyle/>
           <a:p>
             <a:r>
-              <a:rPr sz="1800"/>
-              <a:t>Answered｜低接觸壓力下 contact resistance 是主導不穩定來源。</a:t>
-            </a:r>
-          </a:p>
-          <a:p>
-            <a:r>
-              <a:rPr sz="1800"/>
-              <a:t>Hypothesis status｜supported</a:t>
-            </a:r>
-          </a:p>
-          <a:p>
-            <a:r>
-              <a:rPr sz="1800"/>
-              <a:t>Decision｜Go: Contact-pressure control discriminates the interface mechanism.</a:t>
-            </a:r>
-          </a:p>
-        </p:txBody>
-      </p:sp>
-      <p:sp>
-        <p:nvSpPr>
-          <p:cNvPr id="5" name="tds-slot:uncertainty"/>
+              <a:rPr sz="1600"/>
+              <a:t>RES201</a:t>
+            </a:r>
+          </a:p>
+        </p:txBody>
+      </p:sp>
+      <p:sp>
+        <p:nvSpPr>
+          <p:cNvPr id="5" name="tds-slot:contradicting_results"/>
           <p:cNvSpPr txBox="1"/>
           <p:nvPr/>
         </p:nvSpPr>
         <p:spPr>
           <a:xfrm>
-            <a:off x="4389120" y="1280160"/>
-            <a:ext cx="3383280" cy="2103120"/>
+            <a:off x="3703320" y="1280160"/>
+            <a:ext cx="2743200" cy="1920240"/>
           </a:xfrm>
           <a:prstGeom prst="rect">
             <a:avLst/>
@@ -7031,21 +7105,132 @@
           <a:p>
             <a:r>
               <a:rPr sz="1600"/>
-              <a:t>高壓循環的耐久性與 wear 尚未測試。</a:t>
-            </a:r>
-          </a:p>
-        </p:txBody>
-      </p:sp>
-      <p:sp>
-        <p:nvSpPr>
-          <p:cNvPr id="6" name="tds-slot:next_step"/>
+              <a:t>None identified</a:t>
+            </a:r>
+          </a:p>
+        </p:txBody>
+      </p:sp>
+      <p:sp>
+        <p:nvSpPr>
+          <p:cNvPr id="6" name="tds-slot:discussion_synthesis"/>
           <p:cNvSpPr txBox="1"/>
           <p:nvPr/>
         </p:nvSpPr>
         <p:spPr>
           <a:xfrm>
-            <a:off x="8046720" y="1280160"/>
-            <a:ext cx="3383280" cy="2103120"/>
+            <a:off x="6675120" y="1280160"/>
+            <a:ext cx="4800600" cy="1920240"/>
+          </a:xfrm>
+          <a:prstGeom prst="rect">
+            <a:avLst/>
+          </a:prstGeom>
+          <a:noFill/>
+        </p:spPr>
+        <p:txBody>
+          <a:bodyPr wrap="none">
+            <a:spAutoFit/>
+          </a:bodyPr>
+          <a:lstStyle/>
+          <a:p>
+            <a:r>
+              <a:rPr sz="1600"/>
+              <a:t>Cross-experiment pattern｜匹配導電度後，提高接觸壓力明顯降低變異。</a:t>
+            </a:r>
+          </a:p>
+          <a:p>
+            <a:r>
+              <a:rPr sz="1600"/>
+              <a:t>Mechanism assessment｜contact resistance 在低壓條件下主導不穩定。</a:t>
+            </a:r>
+          </a:p>
+          <a:p>
+            <a:r>
+              <a:rPr sz="1600"/>
+              <a:t>Alternatives｜電極幾何仍可能調節壓力分布</a:t>
+            </a:r>
+          </a:p>
+        </p:txBody>
+      </p:sp>
+      <p:sp>
+        <p:nvSpPr>
+          <p:cNvPr id="7" name="tds-slot:uncertainty"/>
+          <p:cNvSpPr txBox="1"/>
+          <p:nvPr/>
+        </p:nvSpPr>
+        <p:spPr>
+          <a:xfrm>
+            <a:off x="731520" y="3474720"/>
+            <a:ext cx="5257800" cy="1554480"/>
+          </a:xfrm>
+          <a:prstGeom prst="rect">
+            <a:avLst/>
+          </a:prstGeom>
+          <a:noFill/>
+        </p:spPr>
+        <p:txBody>
+          <a:bodyPr wrap="none">
+            <a:spAutoFit/>
+          </a:bodyPr>
+          <a:lstStyle/>
+          <a:p>
+            <a:r>
+              <a:rPr sz="1600"/>
+              <a:t>Discussion uncertainty｜高壓長期循環是否造成新的 wear mechanism 尚未知。</a:t>
+            </a:r>
+          </a:p>
+          <a:p>
+            <a:r>
+              <a:rPr sz="1600"/>
+              <a:t>Summary unresolved｜高壓循環的耐久性與 wear 尚未測試。</a:t>
+            </a:r>
+          </a:p>
+        </p:txBody>
+      </p:sp>
+      <p:sp>
+        <p:nvSpPr>
+          <p:cNvPr id="8" name="tds-slot:decision_status"/>
+          <p:cNvSpPr txBox="1"/>
+          <p:nvPr/>
+        </p:nvSpPr>
+        <p:spPr>
+          <a:xfrm>
+            <a:off x="6217920" y="3474720"/>
+            <a:ext cx="2514600" cy="1554480"/>
+          </a:xfrm>
+          <a:prstGeom prst="rect">
+            <a:avLst/>
+          </a:prstGeom>
+          <a:noFill/>
+        </p:spPr>
+        <p:txBody>
+          <a:bodyPr wrap="none">
+            <a:spAutoFit/>
+          </a:bodyPr>
+          <a:lstStyle/>
+          <a:p>
+            <a:r>
+              <a:rPr sz="1600"/>
+              <a:t>Hypothesis status｜supported</a:t>
+            </a:r>
+          </a:p>
+          <a:p>
+            <a:r>
+              <a:rPr sz="1600"/>
+              <a:t>Decision｜Go: Contact-pressure control discriminates the interface mechanism.</a:t>
+            </a:r>
+          </a:p>
+        </p:txBody>
+      </p:sp>
+      <p:sp>
+        <p:nvSpPr>
+          <p:cNvPr id="9" name="tds-slot:next_step"/>
+          <p:cNvSpPr txBox="1"/>
+          <p:nvPr/>
+        </p:nvSpPr>
+        <p:spPr>
+          <a:xfrm>
+            <a:off x="8961120" y="3474720"/>
+            <a:ext cx="2514600" cy="1554480"/>
           </a:xfrm>
           <a:prstGeom prst="rect">
             <a:avLst/>
@@ -7157,7 +7342,7 @@
           <a:p>
             <a:r>
               <a:rPr sz="1600"/>
-              <a:t>Commitment｜NS101｜done｜Owner: Gary｜Due: 2026-09-10T09:00:00Z</a:t>
+              <a:t>Commitment｜NS101｜planned｜Owner: Gary｜Due: 2026-09-10T09:00:00Z</a:t>
             </a:r>
           </a:p>
           <a:p>

</xml_diff>

<commit_message>
Complete Phase 2 revision 4 history fidelity
</commit_message>
<xml_diff>
--- a/thesis-deck-system/artifacts/phase2/acceptance-deck-render-compat.pptx
+++ b/thesis-deck-system/artifacts/phase2/acceptance-deck-render-compat.pptx
@@ -528,6 +528,11 @@
           <a:p>
             <a:r>
               <a:t>E101</a:t>
+            </a:r>
+          </a:p>
+          <a:p>
+            <a:r>
+              <a:t>E201</a:t>
             </a:r>
           </a:p>
           <a:p>
@@ -5241,31 +5246,49 @@
           <a:p>
             <a:r>
               <a:rPr sz="1600"/>
-              <a:t>EXP102｜IV: ['位置']</a:t>
+              <a:t>IV｜位置</a:t>
             </a:r>
           </a:p>
           <a:p>
             <a:r>
               <a:rPr sz="1600"/>
-              <a:t>Controls: ['原始位置分布']</a:t>
+              <a:t>Controls｜配方; 電極; 接觸壓力</a:t>
             </a:r>
           </a:p>
           <a:p>
             <a:r>
               <a:rPr sz="1600"/>
-              <a:t>N/replicates: {'replicates': 3, 'samples': 15}</a:t>
+              <a:t>Baseline｜原始位置分布</a:t>
             </a:r>
           </a:p>
           <a:p>
             <a:r>
               <a:rPr sz="1600"/>
-              <a:t>Metrics/units: ['訊號 CV (%)']</a:t>
+              <a:t>Sample｜replicates: 3; samples: 15</a:t>
             </a:r>
           </a:p>
           <a:p>
             <a:r>
               <a:rPr sz="1600"/>
-              <a:t>Method: ['synthetic-signal-test']</a:t>
+              <a:t>N｜3</a:t>
+            </a:r>
+          </a:p>
+          <a:p>
+            <a:r>
+              <a:rPr sz="1600"/>
+              <a:t>Outputs｜訊號 CV (%)</a:t>
+            </a:r>
+          </a:p>
+          <a:p>
+            <a:r>
+              <a:rPr sz="1600"/>
+              <a:t>Units｜訊號 CV (%)</a:t>
+            </a:r>
+          </a:p>
+          <a:p>
+            <a:r>
+              <a:rPr sz="1600"/>
+              <a:t>Method｜synthetic-signal-test</a:t>
             </a:r>
           </a:p>
         </p:txBody>
@@ -5294,13 +5317,13 @@
           <a:p>
             <a:r>
               <a:rPr sz="1600"/>
-              <a:t>Prediction: ['CV 下降']</a:t>
+              <a:t>Prediction｜CV 下降</a:t>
             </a:r>
           </a:p>
           <a:p>
             <a:r>
               <a:rPr sz="1600"/>
-              <a:t>Decision rule: {'go': 'CV decreases &gt;=30%', 'partial_go': '10-30%', 'no_go': '&lt;10%'}</a:t>
+              <a:t>Rule｜go: CV decreases &gt;=30%; partial_go: 10-30%; no_go: &lt;10%</a:t>
             </a:r>
           </a:p>
         </p:txBody>
@@ -5384,7 +5407,7 @@
         <p:spPr>
           <a:xfrm>
             <a:off x="5486400" y="1234440"/>
-            <a:ext cx="5989320" cy="4069080"/>
+            <a:ext cx="5989320" cy="3630168"/>
           </a:xfrm>
           <a:prstGeom prst="rect">
             <a:avLst/>
@@ -5399,8 +5422,39 @@
         </p:nvSpPr>
         <p:spPr>
           <a:xfrm>
-            <a:off x="5486400" y="4001414"/>
-            <a:ext cx="5989320" cy="1302105"/>
+            <a:off x="5486400" y="4864608"/>
+            <a:ext cx="5989320" cy="438912"/>
+          </a:xfrm>
+          <a:prstGeom prst="rect">
+            <a:avLst/>
+          </a:prstGeom>
+          <a:solidFill>
+            <a:srgbClr val="FFFFFF"/>
+          </a:solidFill>
+        </p:spPr>
+        <p:txBody>
+          <a:bodyPr wrap="none">
+            <a:spAutoFit/>
+          </a:bodyPr>
+          <a:lstStyle/>
+          <a:p>
+            <a:r>
+              <a:rPr sz="1200"/>
+              <a:t>Figure｜RES101｜平均導電度增加 24% ± 5% SD</a:t>
+            </a:r>
+          </a:p>
+        </p:txBody>
+      </p:sp>
+      <p:sp>
+        <p:nvSpPr>
+          <p:cNvPr id="6" name="tds-slot:result_annotation"/>
+          <p:cNvSpPr txBox="1"/>
+          <p:nvPr/>
+        </p:nvSpPr>
+        <p:spPr>
+          <a:xfrm>
+            <a:off x="731520" y="1508760"/>
+            <a:ext cx="4389120" cy="2103120"/>
           </a:xfrm>
           <a:prstGeom prst="rect">
             <a:avLst/>
@@ -5414,37 +5468,20 @@
           <a:lstStyle/>
           <a:p>
             <a:r>
-              <a:rPr sz="1500"/>
-              <a:t>RES101｜平均導電度增加 24% ± 5% SD</a:t>
-            </a:r>
-          </a:p>
-        </p:txBody>
-      </p:sp>
-      <p:sp>
-        <p:nvSpPr>
-          <p:cNvPr id="6" name="tds-slot:result_annotation"/>
-          <p:cNvSpPr txBox="1"/>
-          <p:nvPr/>
-        </p:nvSpPr>
-        <p:spPr>
-          <a:xfrm>
-            <a:off x="731520" y="1508760"/>
-            <a:ext cx="4389120" cy="2103120"/>
-          </a:xfrm>
-          <a:prstGeom prst="rect">
-            <a:avLst/>
-          </a:prstGeom>
-          <a:noFill/>
-        </p:spPr>
-        <p:txBody>
-          <a:bodyPr wrap="none">
-            <a:spAutoFit/>
-          </a:bodyPr>
-          <a:lstStyle/>
-          <a:p>
-            <a:r>
               <a:rPr sz="1600"/>
-              <a:t>RES101｜平均導電度增加 24% ± 5% SD</a:t>
+              <a:t>ID｜RES101</a:t>
+            </a:r>
+          </a:p>
+          <a:p>
+            <a:r>
+              <a:rPr sz="1600"/>
+              <a:t>Result｜平均導電度增加 24% ± 5% SD</a:t>
+            </a:r>
+          </a:p>
+          <a:p>
+            <a:r>
+              <a:rPr sz="1600"/>
+              <a:t>Metric｜{'name': 'CV', 'value': 24, 'uncertainty': 5, 'units': '%'}</a:t>
             </a:r>
           </a:p>
         </p:txBody>
@@ -5528,7 +5565,7 @@
         <p:spPr>
           <a:xfrm>
             <a:off x="5486400" y="1234440"/>
-            <a:ext cx="5989320" cy="4069080"/>
+            <a:ext cx="5989320" cy="3630168"/>
           </a:xfrm>
           <a:prstGeom prst="rect">
             <a:avLst/>
@@ -5543,8 +5580,39 @@
         </p:nvSpPr>
         <p:spPr>
           <a:xfrm>
-            <a:off x="5486400" y="4001414"/>
-            <a:ext cx="5989320" cy="1302105"/>
+            <a:off x="5486400" y="4864608"/>
+            <a:ext cx="5989320" cy="438912"/>
+          </a:xfrm>
+          <a:prstGeom prst="rect">
+            <a:avLst/>
+          </a:prstGeom>
+          <a:solidFill>
+            <a:srgbClr val="FFFFFF"/>
+          </a:solidFill>
+        </p:spPr>
+        <p:txBody>
+          <a:bodyPr wrap="none">
+            <a:spAutoFit/>
+          </a:bodyPr>
+          <a:lstStyle/>
+          <a:p>
+            <a:r>
+              <a:rPr sz="1200"/>
+              <a:t>Figure｜RES102｜訊號 CV 僅下降 4% ± 6% SD，屬 No-Go</a:t>
+            </a:r>
+          </a:p>
+        </p:txBody>
+      </p:sp>
+      <p:sp>
+        <p:nvSpPr>
+          <p:cNvPr id="6" name="tds-slot:result_annotation"/>
+          <p:cNvSpPr txBox="1"/>
+          <p:nvPr/>
+        </p:nvSpPr>
+        <p:spPr>
+          <a:xfrm>
+            <a:off x="731520" y="1508760"/>
+            <a:ext cx="4389120" cy="2103120"/>
           </a:xfrm>
           <a:prstGeom prst="rect">
             <a:avLst/>
@@ -5558,37 +5626,20 @@
           <a:lstStyle/>
           <a:p>
             <a:r>
-              <a:rPr sz="1500"/>
-              <a:t>RES102｜訊號 CV 僅下降 4% ± 6% SD，屬 No-Go</a:t>
-            </a:r>
-          </a:p>
-        </p:txBody>
-      </p:sp>
-      <p:sp>
-        <p:nvSpPr>
-          <p:cNvPr id="6" name="tds-slot:result_annotation"/>
-          <p:cNvSpPr txBox="1"/>
-          <p:nvPr/>
-        </p:nvSpPr>
-        <p:spPr>
-          <a:xfrm>
-            <a:off x="731520" y="1508760"/>
-            <a:ext cx="4389120" cy="2103120"/>
-          </a:xfrm>
-          <a:prstGeom prst="rect">
-            <a:avLst/>
-          </a:prstGeom>
-          <a:noFill/>
-        </p:spPr>
-        <p:txBody>
-          <a:bodyPr wrap="none">
-            <a:spAutoFit/>
-          </a:bodyPr>
-          <a:lstStyle/>
-          <a:p>
-            <a:r>
               <a:rPr sz="1600"/>
-              <a:t>RES102｜訊號 CV 僅下降 4% ± 6% SD，屬 No-Go</a:t>
+              <a:t>ID｜RES102</a:t>
+            </a:r>
+          </a:p>
+          <a:p>
+            <a:r>
+              <a:rPr sz="1600"/>
+              <a:t>Result｜訊號 CV 僅下降 4% ± 6% SD，屬 No-Go</a:t>
+            </a:r>
+          </a:p>
+          <a:p>
+            <a:r>
+              <a:rPr sz="1600"/>
+              <a:t>Metric｜{'name': 'CV', 'value': 4, 'uncertainty': 5, 'units': '%'}</a:t>
             </a:r>
           </a:p>
         </p:txBody>
@@ -5679,7 +5730,7 @@
           <a:p>
             <a:r>
               <a:rPr sz="1600"/>
-              <a:t>RES101</a:t>
+              <a:t>Support｜RES101</a:t>
             </a:r>
           </a:p>
         </p:txBody>
@@ -5708,7 +5759,13 @@
           <a:p>
             <a:r>
               <a:rPr sz="1600"/>
-              <a:t>RES102</a:t>
+              <a:t>Conflict｜RES102</a:t>
+            </a:r>
+          </a:p>
+          <a:p>
+            <a:r>
+              <a:rPr sz="1600"/>
+              <a:t>Non-disc.｜none</a:t>
             </a:r>
           </a:p>
         </p:txBody>
@@ -5737,7 +5794,13 @@
           <a:p>
             <a:r>
               <a:rPr sz="1600"/>
-              <a:t>Mechanism assessment｜bulk conductivity 是部分機制，不足以解釋 interface-sensitive variation。</a:t>
+              <a:t>Pattern｜導電度提升成立，但重複性沒有同步改善。</a:t>
+            </a:r>
+          </a:p>
+          <a:p>
+            <a:r>
+              <a:rPr sz="1600"/>
+              <a:t>Mechanism｜bulk conductivity 是部分機制，不足以解釋 interface-sensitive variation。</a:t>
             </a:r>
           </a:p>
           <a:p>
@@ -5749,7 +5812,7 @@
           <a:p>
             <a:r>
               <a:rPr sz="1600"/>
-              <a:t>Remaining uncertainty｜contact interface 是否為主導因素仍需匹配導電度後檢驗。</a:t>
+              <a:t>Uncertainty｜contact interface 是否為主導因素仍需匹配導電度後檢驗。</a:t>
             </a:r>
           </a:p>
         </p:txBody>
@@ -5840,19 +5903,19 @@
           <a:p>
             <a:r>
               <a:rPr sz="1800"/>
-              <a:t>Answered｜bulk conductivity 影響缺陷梯度，但不足以單獨解釋重複性。</a:t>
+              <a:t>Answer｜bulk conductivity 影響缺陷梯度，但不足以單獨解釋重複性。</a:t>
             </a:r>
           </a:p>
           <a:p>
             <a:r>
               <a:rPr sz="1800"/>
-              <a:t>Hypothesis status｜partial_support</a:t>
+              <a:t>Status｜partial_support</a:t>
             </a:r>
           </a:p>
           <a:p>
             <a:r>
               <a:rPr sz="1800"/>
-              <a:t>Decision｜Partial-Go: Bulk conductivity is contributory but insufficient.</a:t>
+              <a:t>Decision｜Partial-Go; Bulk conductivity is contributory but insufficient.</a:t>
             </a:r>
           </a:p>
         </p:txBody>
@@ -5881,7 +5944,7 @@
           <a:p>
             <a:r>
               <a:rPr sz="1600"/>
-              <a:t>interface contact 的貢獻尚未量化。</a:t>
+              <a:t>Unresolved｜interface contact 的貢獻尚未量化。</a:t>
             </a:r>
           </a:p>
         </p:txBody>
@@ -5916,7 +5979,7 @@
           <a:p>
             <a:r>
               <a:rPr sz="1600"/>
-              <a:t>Next Step｜NS101</a:t>
+              <a:t>Next step｜NS101</a:t>
             </a:r>
           </a:p>
         </p:txBody>
@@ -6007,25 +6070,25 @@
           <a:p>
             <a:r>
               <a:rPr sz="1800"/>
-              <a:t>Previous hypothesis｜C101</a:t>
+              <a:t>Prior H｜C101</a:t>
             </a:r>
           </a:p>
           <a:p>
             <a:r>
               <a:rPr sz="1800"/>
-              <a:t>Key results｜RES101, RES102</a:t>
+              <a:t>Key results｜RES101; RES102</a:t>
             </a:r>
           </a:p>
           <a:p>
             <a:r>
               <a:rPr sz="1800"/>
-              <a:t>New observation｜E104</a:t>
+              <a:t>Precursor｜E104</a:t>
             </a:r>
           </a:p>
           <a:p>
             <a:r>
               <a:rPr sz="1800"/>
-              <a:t>New hypothesis｜C201</a:t>
+              <a:t>New H｜C201</a:t>
             </a:r>
           </a:p>
         </p:txBody>
@@ -6054,13 +6117,13 @@
           <a:p>
             <a:r>
               <a:rPr sz="1600"/>
-              <a:t>Not explained｜導電度增加後訊號重複性沒有改善。</a:t>
+              <a:t>Unresolved｜導電度增加後訊號重複性沒有改善。</a:t>
             </a:r>
           </a:p>
           <a:p>
             <a:r>
               <a:rPr sz="1600"/>
-              <a:t>Therefore｜剩餘變異隨電極接觸位置改變，因此核心解釋由 bulk transport 轉向 interface contact。</a:t>
+              <a:t>Rationale｜剩餘變異隨電極接觸位置改變，因此核心解釋由 bulk transport 轉向 interface contact。</a:t>
             </a:r>
           </a:p>
         </p:txBody>
@@ -6163,7 +6226,7 @@
           <a:p>
             <a:r>
               <a:rPr sz="2800"/>
-              <a:t>Research question｜低接觸壓力下，contact resistance 是否主導訊號不穩定？</a:t>
+              <a:t>Question｜低接觸壓力下，contact resistance 是否主導訊號不穩定？</a:t>
             </a:r>
           </a:p>
         </p:txBody>
@@ -6254,7 +6317,7 @@
           <a:p>
             <a:r>
               <a:rPr sz="1800"/>
-              <a:t>H01 支持導電度梯度存在; H01 未支持導電度單獨主導重複性</a:t>
+              <a:t>Prior｜H01 支持導電度梯度存在; H01 未支持導電度單獨主導重複性</a:t>
             </a:r>
           </a:p>
         </p:txBody>
@@ -6283,7 +6346,7 @@
           <a:p>
             <a:r>
               <a:rPr sz="1800"/>
-              <a:t>bulk transport 與 interface contact 的相對貢獻尚未區分。</a:t>
+              <a:t>Conflict｜bulk transport 與 interface contact 的相對貢獻尚未區分。</a:t>
             </a:r>
           </a:p>
         </p:txBody>
@@ -6312,7 +6375,7 @@
           <a:p>
             <a:r>
               <a:rPr sz="2000"/>
-              <a:t>低接觸壓力下，contact resistance 是否主導訊號不穩定？</a:t>
+              <a:t>Question｜低接觸壓力下，contact resistance 是否主導訊號不穩定？</a:t>
             </a:r>
           </a:p>
         </p:txBody>
@@ -6427,7 +6490,13 @@
           <a:p>
             <a:r>
               <a:rPr sz="1600"/>
-              <a:t>FB-ELECTRODE-CONTACT</a:t>
+              <a:t>History｜FB001 rev2</a:t>
+            </a:r>
+          </a:p>
+          <a:p>
+            <a:r>
+              <a:rPr sz="1600"/>
+              <a:t>Focus｜FB-ELECTRODE-CONTACT</a:t>
             </a:r>
           </a:p>
         </p:txBody>
@@ -6521,12 +6590,6 @@
               <a:t>Observation｜位置依賴缺陷與訊號變異已觀察到。</a:t>
             </a:r>
           </a:p>
-          <a:p>
-            <a:r>
-              <a:rPr sz="1600"/>
-              <a:t>Problem｜現有模型無法解釋此變異。</a:t>
-            </a:r>
-          </a:p>
         </p:txBody>
       </p:sp>
       <p:sp>
@@ -6553,7 +6616,7 @@
           <a:p>
             <a:r>
               <a:rPr sz="1800"/>
-              <a:t>低接觸壓力下，contact resistance 是否主導訊號不穩定？</a:t>
+              <a:t>Question｜低接觸壓力下，contact resistance 是否主導訊號不穩定？</a:t>
             </a:r>
           </a:p>
         </p:txBody>
@@ -6582,7 +6645,7 @@
           <a:p>
             <a:r>
               <a:rPr sz="1600"/>
-              <a:t>Literature consensus｜transport gradient 可產生位置效應。</a:t>
+              <a:t>Consensus｜transport gradient 可產生位置效應。</a:t>
             </a:r>
           </a:p>
           <a:p>
@@ -6632,6 +6695,12 @@
               <a:t>Mechanism｜contact resistance</a:t>
             </a:r>
           </a:p>
+          <a:p>
+            <a:r>
+              <a:rPr sz="1600"/>
+              <a:t>Evidence｜C202; C203; E202</a:t>
+            </a:r>
+          </a:p>
         </p:txBody>
       </p:sp>
       <p:sp>
@@ -6658,7 +6727,13 @@
           <a:p>
             <a:r>
               <a:rPr sz="1600"/>
-              <a:t>匹配導電度並改變接觸壓力</a:t>
+              <a:t>Strategy｜匹配導電度並改變接觸壓力</a:t>
+            </a:r>
+          </a:p>
+          <a:p>
+            <a:r>
+              <a:rPr sz="1600"/>
+              <a:t>Criterion｜預測指標跨過 decision threshold</a:t>
             </a:r>
           </a:p>
         </p:txBody>
@@ -6838,43 +6913,49 @@
           <a:p>
             <a:r>
               <a:rPr sz="1600"/>
-              <a:t>IV: contact pressure</a:t>
+              <a:t>IV｜contact pressure</a:t>
             </a:r>
           </a:p>
           <a:p>
             <a:r>
               <a:rPr sz="1600"/>
-              <a:t>Controls: bulk conductivity; 電極幾何</a:t>
+              <a:t>Controls｜bulk conductivity; 電極幾何</a:t>
             </a:r>
           </a:p>
           <a:p>
             <a:r>
               <a:rPr sz="1600"/>
-              <a:t>Baselines: low-pressure control</a:t>
+              <a:t>Baseline｜low-pressure control</a:t>
             </a:r>
           </a:p>
           <a:p>
             <a:r>
               <a:rPr sz="1600"/>
-              <a:t>N/replicates: replicates: 5; samples: 15</a:t>
+              <a:t>Sample｜replicates: 5; samples: 15</a:t>
             </a:r>
           </a:p>
           <a:p>
             <a:r>
               <a:rPr sz="1600"/>
-              <a:t>Metrics/units: 訊號 CV (%); contact resistance (ohm)</a:t>
+              <a:t>N｜5</a:t>
             </a:r>
           </a:p>
           <a:p>
             <a:r>
               <a:rPr sz="1600"/>
-              <a:t>Method: synthetic-pressure-fixture</a:t>
+              <a:t>Outputs｜訊號 CV (%); contact resistance (ohm)</a:t>
             </a:r>
           </a:p>
           <a:p>
             <a:r>
               <a:rPr sz="1600"/>
-              <a:t>Prediction: CV and resistance decrease</a:t>
+              <a:t>Units｜訊號 CV (%); contact resistance (ohm)</a:t>
+            </a:r>
+          </a:p>
+          <a:p>
+            <a:r>
+              <a:rPr sz="1600"/>
+              <a:t>Method｜synthetic-pressure-fixture</a:t>
             </a:r>
           </a:p>
         </p:txBody>
@@ -6903,7 +6984,13 @@
           <a:p>
             <a:r>
               <a:rPr sz="1600"/>
-              <a:t>go: both metrics improve; partial_go: one metric improves; no_go: neither improves</a:t>
+              <a:t>Prediction｜CV and resistance decrease</a:t>
+            </a:r>
+          </a:p>
+          <a:p>
+            <a:r>
+              <a:rPr sz="1600"/>
+              <a:t>Rule｜go: both metrics improve; partial_go: one metric improves; no_go: neither improves</a:t>
             </a:r>
           </a:p>
         </p:txBody>
@@ -6925,7 +7012,7 @@
         <p:spPr>
           <a:xfrm>
             <a:off x="8275320" y="1280160"/>
-            <a:ext cx="3200400" cy="2194560"/>
+            <a:ext cx="3200400" cy="1887321"/>
           </a:xfrm>
           <a:prstGeom prst="rect">
             <a:avLst/>
@@ -6940,8 +7027,39 @@
         </p:nvSpPr>
         <p:spPr>
           <a:xfrm>
-            <a:off x="8275320" y="2772460"/>
-            <a:ext cx="3200400" cy="702259"/>
+            <a:off x="8275320" y="3167481"/>
+            <a:ext cx="3200400" cy="307238"/>
+          </a:xfrm>
+          <a:prstGeom prst="rect">
+            <a:avLst/>
+          </a:prstGeom>
+          <a:solidFill>
+            <a:srgbClr val="FFFFFF"/>
+          </a:solidFill>
+        </p:spPr>
+        <p:txBody>
+          <a:bodyPr wrap="none">
+            <a:spAutoFit/>
+          </a:bodyPr>
+          <a:lstStyle/>
+          <a:p>
+            <a:r>
+              <a:rPr sz="1200"/>
+              <a:t>Figure｜RES201｜高壓條件 CV 下降 38% ± 7% SD，contact resistance 同步下降</a:t>
+            </a:r>
+          </a:p>
+        </p:txBody>
+      </p:sp>
+      <p:sp>
+        <p:nvSpPr>
+          <p:cNvPr id="8" name="tds-slot:result_annotation"/>
+          <p:cNvSpPr txBox="1"/>
+          <p:nvPr/>
+        </p:nvSpPr>
+        <p:spPr>
+          <a:xfrm>
+            <a:off x="6217920" y="3611880"/>
+            <a:ext cx="5257800" cy="1600200"/>
           </a:xfrm>
           <a:prstGeom prst="rect">
             <a:avLst/>
@@ -6955,37 +7073,20 @@
           <a:lstStyle/>
           <a:p>
             <a:r>
-              <a:rPr sz="1500"/>
-              <a:t>高壓條件 CV 下降 38% ± 7% SD，contact resistance 同步下降</a:t>
-            </a:r>
-          </a:p>
-        </p:txBody>
-      </p:sp>
-      <p:sp>
-        <p:nvSpPr>
-          <p:cNvPr id="8" name="tds-slot:result_annotation"/>
-          <p:cNvSpPr txBox="1"/>
-          <p:nvPr/>
-        </p:nvSpPr>
-        <p:spPr>
-          <a:xfrm>
-            <a:off x="6217920" y="3611880"/>
-            <a:ext cx="5257800" cy="1600200"/>
-          </a:xfrm>
-          <a:prstGeom prst="rect">
-            <a:avLst/>
-          </a:prstGeom>
-          <a:noFill/>
-        </p:spPr>
-        <p:txBody>
-          <a:bodyPr wrap="none">
-            <a:spAutoFit/>
-          </a:bodyPr>
-          <a:lstStyle/>
-          <a:p>
-            <a:r>
               <a:rPr sz="1600"/>
-              <a:t>高壓條件 CV 下降 38% ± 7% SD，contact resistance 同步下降</a:t>
+              <a:t>ID｜RES201</a:t>
+            </a:r>
+          </a:p>
+          <a:p>
+            <a:r>
+              <a:rPr sz="1600"/>
+              <a:t>Result｜高壓條件 CV 下降 38% ± 7% SD，contact resistance 同步下降</a:t>
+            </a:r>
+          </a:p>
+          <a:p>
+            <a:r>
+              <a:rPr sz="1600"/>
+              <a:t>Metric｜{'name': 'CV', 'value': 24, 'uncertainty': 5, 'units': '%'}</a:t>
             </a:r>
           </a:p>
         </p:txBody>
@@ -7076,7 +7177,7 @@
           <a:p>
             <a:r>
               <a:rPr sz="1600"/>
-              <a:t>RES201</a:t>
+              <a:t>Support｜RES201</a:t>
             </a:r>
           </a:p>
         </p:txBody>
@@ -7105,7 +7206,13 @@
           <a:p>
             <a:r>
               <a:rPr sz="1600"/>
-              <a:t>None identified</a:t>
+              <a:t>Conflict｜none</a:t>
+            </a:r>
+          </a:p>
+          <a:p>
+            <a:r>
+              <a:rPr sz="1600"/>
+              <a:t>Non-disc.｜none</a:t>
             </a:r>
           </a:p>
         </p:txBody>
@@ -7175,13 +7282,31 @@
           <a:p>
             <a:r>
               <a:rPr sz="1600"/>
-              <a:t>Discussion uncertainty｜高壓長期循環是否造成新的 wear mechanism 尚未知。</a:t>
+              <a:t>Pattern｜匹配導電度後，提高接觸壓力明顯降低變異。</a:t>
             </a:r>
           </a:p>
           <a:p>
             <a:r>
               <a:rPr sz="1600"/>
-              <a:t>Summary unresolved｜高壓循環的耐久性與 wear 尚未測試。</a:t>
+              <a:t>Mechanism｜contact resistance 在低壓條件下主導不穩定。</a:t>
+            </a:r>
+          </a:p>
+          <a:p>
+            <a:r>
+              <a:rPr sz="1600"/>
+              <a:t>Alternatives｜電極幾何仍可能調節壓力分布</a:t>
+            </a:r>
+          </a:p>
+          <a:p>
+            <a:r>
+              <a:rPr sz="1600"/>
+              <a:t>Uncertainty｜高壓長期循環是否造成新的 wear mechanism 尚未知。</a:t>
+            </a:r>
+          </a:p>
+          <a:p>
+            <a:r>
+              <a:rPr sz="1600"/>
+              <a:t>Unresolved｜高壓循環的耐久性與 wear 尚未測試。</a:t>
             </a:r>
           </a:p>
         </p:txBody>
@@ -7210,13 +7335,19 @@
           <a:p>
             <a:r>
               <a:rPr sz="1600"/>
-              <a:t>Hypothesis status｜supported</a:t>
+              <a:t>Answer｜低接觸壓力下 contact resistance 是主導不穩定來源。</a:t>
             </a:r>
           </a:p>
           <a:p>
             <a:r>
               <a:rPr sz="1600"/>
-              <a:t>Decision｜Go: Contact-pressure control discriminates the interface mechanism.</a:t>
+              <a:t>Status｜supported</a:t>
+            </a:r>
+          </a:p>
+          <a:p>
+            <a:r>
+              <a:rPr sz="1600"/>
+              <a:t>Decision｜Go; Contact-pressure control discriminates the interface mechanism.</a:t>
             </a:r>
           </a:p>
         </p:txBody>
@@ -7251,7 +7382,7 @@
           <a:p>
             <a:r>
               <a:rPr sz="1600"/>
-              <a:t>Next Step｜NS201</a:t>
+              <a:t>Next step｜NS201</a:t>
             </a:r>
           </a:p>
         </p:txBody>
@@ -7342,13 +7473,7 @@
           <a:p>
             <a:r>
               <a:rPr sz="1600"/>
-              <a:t>Commitment｜NS101｜planned｜Owner: Gary｜Due: 2026-09-10T09:00:00Z</a:t>
-            </a:r>
-          </a:p>
-          <a:p>
-            <a:r>
-              <a:rPr sz="1600"/>
-              <a:t>Commitment｜NS201｜planned｜Owner: Gary｜Due: 2026-09-24T00:00:00Z</a:t>
+              <a:t>Commitment｜NS101; NS201</a:t>
             </a:r>
           </a:p>
         </p:txBody>
@@ -7377,7 +7502,7 @@
           <a:p>
             <a:r>
               <a:rPr sz="1600"/>
-              <a:t>H002</a:t>
+              <a:t>Current｜H002</a:t>
             </a:r>
           </a:p>
         </p:txBody>
@@ -7406,13 +7531,7 @@
           <a:p>
             <a:r>
               <a:rPr sz="1600"/>
-              <a:t>Dependencies｜pressure fixture｜Parallel: True</a:t>
-            </a:r>
-          </a:p>
-          <a:p>
-            <a:r>
-              <a:rPr sz="1600"/>
-              <a:t>Dependencies｜pressure fixture｜Parallel: True</a:t>
+              <a:t>Parallel｜interface-mechanism; interface-mechanism</a:t>
             </a:r>
           </a:p>
         </p:txBody>
@@ -7515,7 +7634,7 @@
           <a:p>
             <a:r>
               <a:rPr sz="2800"/>
-              <a:t>Research question｜提升 bulk conductivity 是否足以降低位置依賴的訊號變異？</a:t>
+              <a:t>Question｜提升 bulk conductivity 是否足以降低位置依賴的訊號變異？</a:t>
             </a:r>
           </a:p>
         </p:txBody>
@@ -7606,7 +7725,7 @@
           <a:p>
             <a:r>
               <a:rPr sz="1800"/>
-              <a:t>含水量與導電度存在位置梯度</a:t>
+              <a:t>Prior｜含水量與導電度存在位置梯度</a:t>
             </a:r>
           </a:p>
         </p:txBody>
@@ -7635,7 +7754,7 @@
           <a:p>
             <a:r>
               <a:rPr sz="1800"/>
-              <a:t>導電度提高是否足以修復重複性仍未知。</a:t>
+              <a:t>Conflict｜導電度提高是否足以修復重複性仍未知。</a:t>
             </a:r>
           </a:p>
         </p:txBody>
@@ -7664,7 +7783,7 @@
           <a:p>
             <a:r>
               <a:rPr sz="2000"/>
-              <a:t>提升 bulk conductivity 是否足以降低位置依賴的訊號變異？</a:t>
+              <a:t>Question｜提升 bulk conductivity 是否足以降低位置依賴的訊號變異？</a:t>
             </a:r>
           </a:p>
         </p:txBody>
@@ -7779,7 +7898,13 @@
           <a:p>
             <a:r>
               <a:rPr sz="1600"/>
-              <a:t>FB-MATERIAL-HYDRATION</a:t>
+              <a:t>History｜FB001 rev1</a:t>
+            </a:r>
+          </a:p>
+          <a:p>
+            <a:r>
+              <a:rPr sz="1600"/>
+              <a:t>Focus｜FB-MATERIAL-HYDRATION</a:t>
             </a:r>
           </a:p>
         </p:txBody>
@@ -7894,7 +8019,7 @@
           <a:p>
             <a:r>
               <a:rPr sz="2000"/>
-              <a:t>提升 bulk conductivity 是否足以降低位置依賴的訊號變異？</a:t>
+              <a:t>Question｜提升 bulk conductivity 是否足以降低位置依賴的訊號變異？</a:t>
             </a:r>
           </a:p>
         </p:txBody>
@@ -7924,12 +8049,6 @@
             <a:r>
               <a:rPr sz="1600"/>
               <a:t>Observation｜位置依賴缺陷與訊號變異已觀察到。</a:t>
-            </a:r>
-          </a:p>
-          <a:p>
-            <a:r>
-              <a:rPr sz="1600"/>
-              <a:t>Problem｜現有模型無法解釋此變異。</a:t>
             </a:r>
           </a:p>
         </p:txBody>
@@ -8020,7 +8139,7 @@
           <a:p>
             <a:r>
               <a:rPr sz="1600"/>
-              <a:t>Literature consensus｜transport gradient 可產生位置效應。</a:t>
+              <a:t>Consensus｜transport gradient 可產生位置效應。</a:t>
             </a:r>
           </a:p>
           <a:p>
@@ -8073,7 +8192,7 @@
           <a:p>
             <a:r>
               <a:rPr sz="1600"/>
-              <a:t>Strategy｜均化導電度</a:t>
+              <a:t>Evidence｜C102; C103; E103</a:t>
             </a:r>
           </a:p>
         </p:txBody>
@@ -8164,31 +8283,49 @@
           <a:p>
             <a:r>
               <a:rPr sz="1600"/>
-              <a:t>EXP101｜IV: ['含水量']</a:t>
+              <a:t>IV｜含水量</a:t>
             </a:r>
           </a:p>
           <a:p>
             <a:r>
               <a:rPr sz="1600"/>
-              <a:t>Controls: ['原始配方']</a:t>
+              <a:t>Controls｜電極幾何; 接觸壓力</a:t>
             </a:r>
           </a:p>
           <a:p>
             <a:r>
               <a:rPr sz="1600"/>
-              <a:t>N/replicates: {'replicates': 3, 'samples': 15}</a:t>
+              <a:t>Baseline｜原始配方</a:t>
             </a:r>
           </a:p>
           <a:p>
             <a:r>
               <a:rPr sz="1600"/>
-              <a:t>Metrics/units: ['導電度 (mS/cm)']</a:t>
+              <a:t>Sample｜replicates: 3; samples: 15</a:t>
             </a:r>
           </a:p>
           <a:p>
             <a:r>
               <a:rPr sz="1600"/>
-              <a:t>Method: ['synthetic-four-probe']</a:t>
+              <a:t>N｜3</a:t>
+            </a:r>
+          </a:p>
+          <a:p>
+            <a:r>
+              <a:rPr sz="1600"/>
+              <a:t>Outputs｜導電度 (mS/cm)</a:t>
+            </a:r>
+          </a:p>
+          <a:p>
+            <a:r>
+              <a:rPr sz="1600"/>
+              <a:t>Units｜導電度 (mS/cm)</a:t>
+            </a:r>
+          </a:p>
+          <a:p>
+            <a:r>
+              <a:rPr sz="1600"/>
+              <a:t>Method｜synthetic-four-probe</a:t>
             </a:r>
           </a:p>
         </p:txBody>
@@ -8217,13 +8354,13 @@
           <a:p>
             <a:r>
               <a:rPr sz="1600"/>
-              <a:t>Prediction: ['導電度提升']</a:t>
+              <a:t>Prediction｜導電度提升</a:t>
             </a:r>
           </a:p>
           <a:p>
             <a:r>
               <a:rPr sz="1600"/>
-              <a:t>Decision rule: {'go': 'mean conductivity increases &gt;=20%', 'partial_go': '10-20%', 'no_go': '&lt;10%'}</a:t>
+              <a:t>Rule｜go: mean conductivity increases &gt;=20%; partial_go: 10-20%; no_go: &lt;10%</a:t>
             </a:r>
           </a:p>
         </p:txBody>

</xml_diff>